<commit_message>
docs: add speaker notes to all 13 slides
</commit_message>
<xml_diff>
--- a/docs/CS584_Midterm_Presentation.pptx
+++ b/docs/CS584_Midterm_Presentation.pptx
@@ -5,21 +5,21 @@
     <p:sldMasterId id="2147483648" r:id="rId1"/>
   </p:sldMasterIdLst>
   <p:sldIdLst>
-    <p:sldId id="256" r:id="rId7"/>
-    <p:sldId id="257" r:id="rId8"/>
-    <p:sldId id="258" r:id="rId9"/>
-    <p:sldId id="259" r:id="rId10"/>
-    <p:sldId id="260" r:id="rId11"/>
-    <p:sldId id="261" r:id="rId12"/>
-    <p:sldId id="262" r:id="rId13"/>
-    <p:sldId id="263" r:id="rId14"/>
-    <p:sldId id="264" r:id="rId15"/>
-    <p:sldId id="265" r:id="rId16"/>
-    <p:sldId id="266" r:id="rId17"/>
-    <p:sldId id="267" r:id="rId18"/>
-    <p:sldId id="268" r:id="rId19"/>
+    <p:sldId id="256" r:id="rId2"/>
+    <p:sldId id="257" r:id="rId3"/>
+    <p:sldId id="258" r:id="rId4"/>
+    <p:sldId id="259" r:id="rId5"/>
+    <p:sldId id="260" r:id="rId6"/>
+    <p:sldId id="261" r:id="rId7"/>
+    <p:sldId id="262" r:id="rId8"/>
+    <p:sldId id="263" r:id="rId9"/>
+    <p:sldId id="264" r:id="rId10"/>
+    <p:sldId id="265" r:id="rId11"/>
+    <p:sldId id="266" r:id="rId12"/>
+    <p:sldId id="267" r:id="rId13"/>
+    <p:sldId id="268" r:id="rId14"/>
   </p:sldIdLst>
-  <p:sldSz cx="12191695" cy="6858000" type="screen4x3"/>
+  <p:sldSz cx="12192000" cy="6858000"/>
   <p:notesSz cx="6858000" cy="9144000"/>
   <p:defaultTextStyle>
     <a:defPPr>
@@ -116,7 +116,1463 @@
       </a:defRPr>
     </a:lvl9pPr>
   </p:defaultTextStyle>
+  <p:extLst>
+    <p:ext uri="{EFAFB233-063F-42B5-8137-9DF3F51BA10A}">
+      <p15:sldGuideLst xmlns:p15="http://schemas.microsoft.com/office/powerpoint/2012/main">
+        <p15:guide id="1" orient="horz" pos="2160">
+          <p15:clr>
+            <a:srgbClr val="A4A3A4"/>
+          </p15:clr>
+        </p15:guide>
+        <p15:guide id="2" pos="2880">
+          <p15:clr>
+            <a:srgbClr val="A4A3A4"/>
+          </p15:clr>
+        </p15:guide>
+      </p15:sldGuideLst>
+    </p:ext>
+  </p:extLst>
 </p:presentation>
+</file>
+
+<file path=ppt/notesMasters/notesMaster1.xml><?xml version="1.0" encoding="utf-8"?>
+<p:notesMaster xmlns:a="http://schemas.openxmlformats.org/drawingml/2006/main" xmlns:p="http://schemas.openxmlformats.org/presentationml/2006/main" xmlns:r="http://schemas.openxmlformats.org/officeDocument/2006/relationships">
+  <p:cSld>
+    <p:bg>
+      <p:bgRef idx="1001">
+        <a:schemeClr val="bg1"/>
+      </p:bgRef>
+    </p:bg>
+    <p:spTree>
+      <p:nvGrpSpPr>
+        <p:cNvPr id="1" name=""/>
+        <p:cNvGrpSpPr/>
+        <p:nvPr/>
+      </p:nvGrpSpPr>
+      <p:grpSpPr>
+        <a:xfrm>
+          <a:off x="0" y="0"/>
+          <a:ext cx="0" cy="0"/>
+          <a:chOff x="0" y="0"/>
+          <a:chExt cx="0" cy="0"/>
+        </a:xfrm>
+      </p:grpSpPr>
+      <p:sp>
+        <p:nvSpPr>
+          <p:cNvPr id="2" name="Header Placeholder 1"/>
+          <p:cNvSpPr>
+            <a:spLocks noGrp="1"/>
+          </p:cNvSpPr>
+          <p:nvPr>
+            <p:ph type="hdr" sz="quarter"/>
+          </p:nvPr>
+        </p:nvSpPr>
+        <p:spPr>
+          <a:xfrm>
+            <a:off x="0" y="0"/>
+            <a:ext cx="2971800" cy="457200"/>
+          </a:xfrm>
+          <a:prstGeom prst="rect">
+            <a:avLst/>
+          </a:prstGeom>
+        </p:spPr>
+        <p:txBody>
+          <a:bodyPr vert="horz" lIns="91440" tIns="45720" rIns="91440" bIns="45720" rtlCol="0"/>
+          <a:lstStyle>
+            <a:lvl1pPr algn="l">
+              <a:defRPr sz="1200"/>
+            </a:lvl1pPr>
+          </a:lstStyle>
+          <a:p>
+            <a:endParaRPr lang="en-US"/>
+          </a:p>
+        </p:txBody>
+      </p:sp>
+      <p:sp>
+        <p:nvSpPr>
+          <p:cNvPr id="3" name="Date Placeholder 2"/>
+          <p:cNvSpPr>
+            <a:spLocks noGrp="1"/>
+          </p:cNvSpPr>
+          <p:nvPr>
+            <p:ph type="dt" idx="1"/>
+          </p:nvPr>
+        </p:nvSpPr>
+        <p:spPr>
+          <a:xfrm>
+            <a:off x="3884613" y="0"/>
+            <a:ext cx="2971800" cy="457200"/>
+          </a:xfrm>
+          <a:prstGeom prst="rect">
+            <a:avLst/>
+          </a:prstGeom>
+        </p:spPr>
+        <p:txBody>
+          <a:bodyPr vert="horz" lIns="91440" tIns="45720" rIns="91440" bIns="45720" rtlCol="0"/>
+          <a:lstStyle>
+            <a:lvl1pPr algn="r">
+              <a:defRPr sz="1200"/>
+            </a:lvl1pPr>
+          </a:lstStyle>
+          <a:p>
+            <a:fld id="{0F89C1C7-3DCD-1040-A9CF-14679D8B5DDD}" type="datetimeFigureOut">
+              <a:rPr lang="en-US" smtClean="0"/>
+              <a:t>10/17/16</a:t>
+            </a:fld>
+            <a:endParaRPr lang="en-US"/>
+          </a:p>
+        </p:txBody>
+      </p:sp>
+      <p:sp>
+        <p:nvSpPr>
+          <p:cNvPr id="4" name="Slide Image Placeholder 3"/>
+          <p:cNvSpPr>
+            <a:spLocks noGrp="1" noRot="1" noChangeAspect="1"/>
+          </p:cNvSpPr>
+          <p:nvPr>
+            <p:ph type="sldImg" idx="2"/>
+          </p:nvPr>
+        </p:nvSpPr>
+        <p:spPr>
+          <a:xfrm>
+            <a:off x="1143000" y="685800"/>
+            <a:ext cx="4572000" cy="3429000"/>
+          </a:xfrm>
+          <a:prstGeom prst="rect">
+            <a:avLst/>
+          </a:prstGeom>
+          <a:noFill/>
+          <a:ln w="12700">
+            <a:solidFill>
+              <a:prstClr val="black"/>
+            </a:solidFill>
+          </a:ln>
+        </p:spPr>
+        <p:txBody>
+          <a:bodyPr vert="horz" lIns="91440" tIns="45720" rIns="91440" bIns="45720" rtlCol="0" anchor="ctr"/>
+          <a:lstStyle/>
+          <a:p>
+            <a:endParaRPr lang="en-US"/>
+          </a:p>
+        </p:txBody>
+      </p:sp>
+      <p:sp>
+        <p:nvSpPr>
+          <p:cNvPr id="5" name="Notes Placeholder 4"/>
+          <p:cNvSpPr>
+            <a:spLocks noGrp="1"/>
+          </p:cNvSpPr>
+          <p:nvPr>
+            <p:ph type="body" sz="quarter" idx="3"/>
+          </p:nvPr>
+        </p:nvSpPr>
+        <p:spPr>
+          <a:xfrm>
+            <a:off x="685800" y="4343400"/>
+            <a:ext cx="5486400" cy="4114800"/>
+          </a:xfrm>
+          <a:prstGeom prst="rect">
+            <a:avLst/>
+          </a:prstGeom>
+        </p:spPr>
+        <p:txBody>
+          <a:bodyPr vert="horz" lIns="91440" tIns="45720" rIns="91440" bIns="45720" rtlCol="0"/>
+          <a:lstStyle/>
+          <a:p>
+            <a:pPr lvl="0"/>
+            <a:r>
+              <a:rPr lang="en-US" smtClean="0"/>
+              <a:t>Click to edit Master text styles</a:t>
+            </a:r>
+          </a:p>
+          <a:p>
+            <a:pPr lvl="1"/>
+            <a:r>
+              <a:rPr lang="en-US" smtClean="0"/>
+              <a:t>Second level</a:t>
+            </a:r>
+          </a:p>
+          <a:p>
+            <a:pPr lvl="2"/>
+            <a:r>
+              <a:rPr lang="en-US" smtClean="0"/>
+              <a:t>Third level</a:t>
+            </a:r>
+          </a:p>
+          <a:p>
+            <a:pPr lvl="3"/>
+            <a:r>
+              <a:rPr lang="en-US" smtClean="0"/>
+              <a:t>Fourth level</a:t>
+            </a:r>
+          </a:p>
+          <a:p>
+            <a:pPr lvl="4"/>
+            <a:r>
+              <a:rPr lang="en-US" smtClean="0"/>
+              <a:t>Fifth level</a:t>
+            </a:r>
+            <a:endParaRPr lang="en-US"/>
+          </a:p>
+        </p:txBody>
+      </p:sp>
+      <p:sp>
+        <p:nvSpPr>
+          <p:cNvPr id="6" name="Footer Placeholder 5"/>
+          <p:cNvSpPr>
+            <a:spLocks noGrp="1"/>
+          </p:cNvSpPr>
+          <p:nvPr>
+            <p:ph type="ftr" sz="quarter" idx="4"/>
+          </p:nvPr>
+        </p:nvSpPr>
+        <p:spPr>
+          <a:xfrm>
+            <a:off x="0" y="8685213"/>
+            <a:ext cx="2971800" cy="457200"/>
+          </a:xfrm>
+          <a:prstGeom prst="rect">
+            <a:avLst/>
+          </a:prstGeom>
+        </p:spPr>
+        <p:txBody>
+          <a:bodyPr vert="horz" lIns="91440" tIns="45720" rIns="91440" bIns="45720" rtlCol="0" anchor="b"/>
+          <a:lstStyle>
+            <a:lvl1pPr algn="l">
+              <a:defRPr sz="1200"/>
+            </a:lvl1pPr>
+          </a:lstStyle>
+          <a:p>
+            <a:endParaRPr lang="en-US"/>
+          </a:p>
+        </p:txBody>
+      </p:sp>
+      <p:sp>
+        <p:nvSpPr>
+          <p:cNvPr id="7" name="Slide Number Placeholder 6"/>
+          <p:cNvSpPr>
+            <a:spLocks noGrp="1"/>
+          </p:cNvSpPr>
+          <p:nvPr>
+            <p:ph type="sldNum" sz="quarter" idx="5"/>
+          </p:nvPr>
+        </p:nvSpPr>
+        <p:spPr>
+          <a:xfrm>
+            <a:off x="3884613" y="8685213"/>
+            <a:ext cx="2971800" cy="457200"/>
+          </a:xfrm>
+          <a:prstGeom prst="rect">
+            <a:avLst/>
+          </a:prstGeom>
+        </p:spPr>
+        <p:txBody>
+          <a:bodyPr vert="horz" lIns="91440" tIns="45720" rIns="91440" bIns="45720" rtlCol="0" anchor="b"/>
+          <a:lstStyle>
+            <a:lvl1pPr algn="r">
+              <a:defRPr sz="1200"/>
+            </a:lvl1pPr>
+          </a:lstStyle>
+          <a:p>
+            <a:fld id="{BB5E49A5-4136-284D-997B-48E1D791AD67}" type="slidenum">
+              <a:rPr lang="en-US" smtClean="0"/>
+              <a:t>‹#›</a:t>
+            </a:fld>
+            <a:endParaRPr lang="en-US"/>
+          </a:p>
+        </p:txBody>
+      </p:sp>
+    </p:spTree>
+    <p:extLst>
+      <p:ext uri="{BB962C8B-B14F-4D97-AF65-F5344CB8AC3E}">
+        <p14:creationId xmlns:p14="http://schemas.microsoft.com/office/powerpoint/2010/main" val="2623252185"/>
+      </p:ext>
+    </p:extLst>
+  </p:cSld>
+  <p:clrMap bg1="lt1" tx1="dk1" bg2="lt2" tx2="dk2" accent1="accent1" accent2="accent2" accent3="accent3" accent4="accent4" accent5="accent5" accent6="accent6" hlink="hlink" folHlink="folHlink"/>
+  <p:notesStyle>
+    <a:lvl1pPr marL="0" algn="l" defTabSz="457200" rtl="0" eaLnBrk="1" latinLnBrk="0" hangingPunct="1">
+      <a:defRPr sz="1200" kern="1200">
+        <a:solidFill>
+          <a:schemeClr val="tx1"/>
+        </a:solidFill>
+        <a:latin typeface="+mn-lt"/>
+        <a:ea typeface="+mn-ea"/>
+        <a:cs typeface="+mn-cs"/>
+      </a:defRPr>
+    </a:lvl1pPr>
+    <a:lvl2pPr marL="457200" algn="l" defTabSz="457200" rtl="0" eaLnBrk="1" latinLnBrk="0" hangingPunct="1">
+      <a:defRPr sz="1200" kern="1200">
+        <a:solidFill>
+          <a:schemeClr val="tx1"/>
+        </a:solidFill>
+        <a:latin typeface="+mn-lt"/>
+        <a:ea typeface="+mn-ea"/>
+        <a:cs typeface="+mn-cs"/>
+      </a:defRPr>
+    </a:lvl2pPr>
+    <a:lvl3pPr marL="914400" algn="l" defTabSz="457200" rtl="0" eaLnBrk="1" latinLnBrk="0" hangingPunct="1">
+      <a:defRPr sz="1200" kern="1200">
+        <a:solidFill>
+          <a:schemeClr val="tx1"/>
+        </a:solidFill>
+        <a:latin typeface="+mn-lt"/>
+        <a:ea typeface="+mn-ea"/>
+        <a:cs typeface="+mn-cs"/>
+      </a:defRPr>
+    </a:lvl3pPr>
+    <a:lvl4pPr marL="1371600" algn="l" defTabSz="457200" rtl="0" eaLnBrk="1" latinLnBrk="0" hangingPunct="1">
+      <a:defRPr sz="1200" kern="1200">
+        <a:solidFill>
+          <a:schemeClr val="tx1"/>
+        </a:solidFill>
+        <a:latin typeface="+mn-lt"/>
+        <a:ea typeface="+mn-ea"/>
+        <a:cs typeface="+mn-cs"/>
+      </a:defRPr>
+    </a:lvl4pPr>
+    <a:lvl5pPr marL="1828800" algn="l" defTabSz="457200" rtl="0" eaLnBrk="1" latinLnBrk="0" hangingPunct="1">
+      <a:defRPr sz="1200" kern="1200">
+        <a:solidFill>
+          <a:schemeClr val="tx1"/>
+        </a:solidFill>
+        <a:latin typeface="+mn-lt"/>
+        <a:ea typeface="+mn-ea"/>
+        <a:cs typeface="+mn-cs"/>
+      </a:defRPr>
+    </a:lvl5pPr>
+    <a:lvl6pPr marL="2286000" algn="l" defTabSz="457200" rtl="0" eaLnBrk="1" latinLnBrk="0" hangingPunct="1">
+      <a:defRPr sz="1200" kern="1200">
+        <a:solidFill>
+          <a:schemeClr val="tx1"/>
+        </a:solidFill>
+        <a:latin typeface="+mn-lt"/>
+        <a:ea typeface="+mn-ea"/>
+        <a:cs typeface="+mn-cs"/>
+      </a:defRPr>
+    </a:lvl6pPr>
+    <a:lvl7pPr marL="2743200" algn="l" defTabSz="457200" rtl="0" eaLnBrk="1" latinLnBrk="0" hangingPunct="1">
+      <a:defRPr sz="1200" kern="1200">
+        <a:solidFill>
+          <a:schemeClr val="tx1"/>
+        </a:solidFill>
+        <a:latin typeface="+mn-lt"/>
+        <a:ea typeface="+mn-ea"/>
+        <a:cs typeface="+mn-cs"/>
+      </a:defRPr>
+    </a:lvl7pPr>
+    <a:lvl8pPr marL="3200400" algn="l" defTabSz="457200" rtl="0" eaLnBrk="1" latinLnBrk="0" hangingPunct="1">
+      <a:defRPr sz="1200" kern="1200">
+        <a:solidFill>
+          <a:schemeClr val="tx1"/>
+        </a:solidFill>
+        <a:latin typeface="+mn-lt"/>
+        <a:ea typeface="+mn-ea"/>
+        <a:cs typeface="+mn-cs"/>
+      </a:defRPr>
+    </a:lvl8pPr>
+    <a:lvl9pPr marL="3657600" algn="l" defTabSz="457200" rtl="0" eaLnBrk="1" latinLnBrk="0" hangingPunct="1">
+      <a:defRPr sz="1200" kern="1200">
+        <a:solidFill>
+          <a:schemeClr val="tx1"/>
+        </a:solidFill>
+        <a:latin typeface="+mn-lt"/>
+        <a:ea typeface="+mn-ea"/>
+        <a:cs typeface="+mn-cs"/>
+      </a:defRPr>
+    </a:lvl9pPr>
+  </p:notesStyle>
+</p:notesMaster>
+</file>
+
+<file path=ppt/notesSlides/notesSlide1.xml><?xml version="1.0" encoding="utf-8"?>
+<p:notes xmlns:a="http://schemas.openxmlformats.org/drawingml/2006/main" xmlns:p="http://schemas.openxmlformats.org/presentationml/2006/main" xmlns:r="http://schemas.openxmlformats.org/officeDocument/2006/relationships">
+  <p:cSld>
+    <p:spTree>
+      <p:nvGrpSpPr>
+        <p:cNvPr id="1" name=""/>
+        <p:cNvGrpSpPr/>
+        <p:nvPr/>
+      </p:nvGrpSpPr>
+      <p:grpSpPr>
+        <a:xfrm>
+          <a:off x="0" y="0"/>
+          <a:ext cx="0" cy="0"/>
+          <a:chOff x="0" y="0"/>
+          <a:chExt cx="0" cy="0"/>
+        </a:xfrm>
+      </p:grpSpPr>
+      <p:sp>
+        <p:nvSpPr>
+          <p:cNvPr id="2" name="Slide Image Placeholder 1"/>
+          <p:cNvSpPr>
+            <a:spLocks noGrp="1"/>
+          </p:cNvSpPr>
+          <p:nvPr>
+            <p:ph type="sldImg" idx="2"/>
+          </p:nvPr>
+        </p:nvSpPr>
+        <p:spPr/>
+      </p:sp>
+      <p:sp>
+        <p:nvSpPr>
+          <p:cNvPr id="3" name="Notes Placeholder 2"/>
+          <p:cNvSpPr>
+            <a:spLocks noGrp="1"/>
+          </p:cNvSpPr>
+          <p:nvPr>
+            <p:ph type="body" idx="3" sz="quarter"/>
+          </p:nvPr>
+        </p:nvSpPr>
+        <p:spPr/>
+        <p:txBody>
+          <a:bodyPr/>
+          <a:lstStyle/>
+          <a:p>
+            <a:r>
+              <a:t>Welcome everyone. Our project is about automating ontology engineering for insurance knowledge graphs. The title is "Schema-Evolving Knowledge Graphs for Insurance" — the key word is "automated." We want to eliminate the 3-6 month manual effort of building an ontology for each new insurance line of business.</a:t>
+            </a:r>
+          </a:p>
+        </p:txBody>
+      </p:sp>
+      <p:sp>
+        <p:nvSpPr>
+          <p:cNvPr id="4" name="Slide Number Placeholder 3"/>
+          <p:cNvSpPr>
+            <a:spLocks noGrp="1"/>
+          </p:cNvSpPr>
+          <p:nvPr>
+            <p:ph type="sldNum" idx="5" sz="quarter"/>
+          </p:nvPr>
+        </p:nvSpPr>
+        <p:spPr/>
+      </p:sp>
+    </p:spTree>
+  </p:cSld>
+  <p:clrMapOvr>
+    <a:masterClrMapping/>
+  </p:clrMapOvr>
+</p:notes>
+</file>
+
+<file path=ppt/notesSlides/notesSlide10.xml><?xml version="1.0" encoding="utf-8"?>
+<p:notes xmlns:a="http://schemas.openxmlformats.org/drawingml/2006/main" xmlns:p="http://schemas.openxmlformats.org/presentationml/2006/main" xmlns:r="http://schemas.openxmlformats.org/officeDocument/2006/relationships">
+  <p:cSld>
+    <p:spTree>
+      <p:nvGrpSpPr>
+        <p:cNvPr id="1" name=""/>
+        <p:cNvGrpSpPr/>
+        <p:nvPr/>
+      </p:nvGrpSpPr>
+      <p:grpSpPr>
+        <a:xfrm>
+          <a:off x="0" y="0"/>
+          <a:ext cx="0" cy="0"/>
+          <a:chOff x="0" y="0"/>
+          <a:chExt cx="0" cy="0"/>
+        </a:xfrm>
+      </p:grpSpPr>
+      <p:sp>
+        <p:nvSpPr>
+          <p:cNvPr id="2" name="Slide Image Placeholder 1"/>
+          <p:cNvSpPr>
+            <a:spLocks noGrp="1"/>
+          </p:cNvSpPr>
+          <p:nvPr>
+            <p:ph type="sldImg" idx="2"/>
+          </p:nvPr>
+        </p:nvSpPr>
+        <p:spPr/>
+      </p:sp>
+      <p:sp>
+        <p:nvSpPr>
+          <p:cNvPr id="3" name="Notes Placeholder 2"/>
+          <p:cNvSpPr>
+            <a:spLocks noGrp="1"/>
+          </p:cNvSpPr>
+          <p:nvPr>
+            <p:ph type="body" idx="3" sz="quarter"/>
+          </p:nvPr>
+        </p:nvSpPr>
+        <p:spPr/>
+        <p:txBody>
+          <a:bodyPr/>
+          <a:lstStyle/>
+          <a:p>
+            <a:r>
+              <a:t>This shows what SV-LOI actually discovered versus the Riskine reference ontology. Coverage matched Coverage — perfect. Product matched Product. Property matched Property. Risk matched Risk with a partial score. Address matched Address.</a:t>
+            </a:r>
+          </a:p>
+          <a:p/>
+          <a:p>
+            <a:r>
+              <a:t>The 5 unmatched Riskine classes — Person, Organization, Object, Structure, Damage — are mostly absent from flood insurance data. The SFIP policy and FEMA claims records don't contain named people, organizations, or physical objects. This is a data coverage limitation, not a method limitation.</a:t>
+            </a:r>
+          </a:p>
+          <a:p/>
+          <a:p>
+            <a:r>
+              <a:t>This is actually a STRENGTH: our method correctly induces only the classes that are evidenced in the source data. It doesn't hallucinate classes that aren't there.</a:t>
+            </a:r>
+          </a:p>
+        </p:txBody>
+      </p:sp>
+      <p:sp>
+        <p:nvSpPr>
+          <p:cNvPr id="4" name="Slide Number Placeholder 3"/>
+          <p:cNvSpPr>
+            <a:spLocks noGrp="1"/>
+          </p:cNvSpPr>
+          <p:nvPr>
+            <p:ph type="sldNum" idx="5" sz="quarter"/>
+          </p:nvPr>
+        </p:nvSpPr>
+        <p:spPr/>
+      </p:sp>
+    </p:spTree>
+  </p:cSld>
+  <p:clrMapOvr>
+    <a:masterClrMapping/>
+  </p:clrMapOvr>
+</p:notes>
+</file>
+
+<file path=ppt/notesSlides/notesSlide11.xml><?xml version="1.0" encoding="utf-8"?>
+<p:notes xmlns:a="http://schemas.openxmlformats.org/drawingml/2006/main" xmlns:p="http://schemas.openxmlformats.org/presentationml/2006/main" xmlns:r="http://schemas.openxmlformats.org/officeDocument/2006/relationships">
+  <p:cSld>
+    <p:spTree>
+      <p:nvGrpSpPr>
+        <p:cNvPr id="1" name=""/>
+        <p:cNvGrpSpPr/>
+        <p:nvPr/>
+      </p:nvGrpSpPr>
+      <p:grpSpPr>
+        <a:xfrm>
+          <a:off x="0" y="0"/>
+          <a:ext cx="0" cy="0"/>
+          <a:chOff x="0" y="0"/>
+          <a:chExt cx="0" cy="0"/>
+        </a:xfrm>
+      </p:grpSpPr>
+      <p:sp>
+        <p:nvSpPr>
+          <p:cNvPr id="2" name="Slide Image Placeholder 1"/>
+          <p:cNvSpPr>
+            <a:spLocks noGrp="1"/>
+          </p:cNvSpPr>
+          <p:nvPr>
+            <p:ph type="sldImg" idx="2"/>
+          </p:nvPr>
+        </p:nvSpPr>
+        <p:spPr/>
+      </p:sp>
+      <p:sp>
+        <p:nvSpPr>
+          <p:cNvPr id="3" name="Notes Placeholder 2"/>
+          <p:cNvSpPr>
+            <a:spLocks noGrp="1"/>
+          </p:cNvSpPr>
+          <p:nvPr>
+            <p:ph type="body" idx="3" sz="quarter"/>
+          </p:nvPr>
+        </p:nvSpPr>
+        <p:spPr/>
+        <p:txBody>
+          <a:bodyPr/>
+          <a:lstStyle/>
+          <a:p>
+            <a:r>
+              <a:t>Four key findings from our experiments.</a:t>
+            </a:r>
+          </a:p>
+          <a:p/>
+          <a:p>
+            <a:r>
+              <a:t>First, extraction scales dramatically with model size — 8b extracts 1 triple per chunk, while 72b extracts 8 to 50 triples per chunk. This is why we use the 72b model.</a:t>
+            </a:r>
+          </a:p>
+          <a:p/>
+          <a:p>
+            <a:r>
+              <a:t>Second, LLMs default to data-type thinking. Our first SV-LOI attempt produced classes like "FinancialAmount" and "TimePeriod" instead of domain concepts like Coverage and Risk. We fixed this with two-stage class discovery — detect the domain first, then propose domain-appropriate classes.</a:t>
+            </a:r>
+          </a:p>
+          <a:p/>
+          <a:p>
+            <a:r>
+              <a:t>Third, name-matching F1 is a poor metric for this task. It rewards naming convention rather than semantic correctness. We adopted BERTScore F1 as a better alternative.</a:t>
+            </a:r>
+          </a:p>
+          <a:p/>
+          <a:p>
+            <a:r>
+              <a:t>Fourth, source data limits recall. Flood insurance data simply doesn't contain Person or Organization entities, so we report both full 10-class F1 and present-class F1 for fair comparison.</a:t>
+            </a:r>
+          </a:p>
+        </p:txBody>
+      </p:sp>
+      <p:sp>
+        <p:nvSpPr>
+          <p:cNvPr id="4" name="Slide Number Placeholder 3"/>
+          <p:cNvSpPr>
+            <a:spLocks noGrp="1"/>
+          </p:cNvSpPr>
+          <p:nvPr>
+            <p:ph type="sldNum" idx="5" sz="quarter"/>
+          </p:nvPr>
+        </p:nvSpPr>
+        <p:spPr/>
+      </p:sp>
+    </p:spTree>
+  </p:cSld>
+  <p:clrMapOvr>
+    <a:masterClrMapping/>
+  </p:clrMapOvr>
+</p:notes>
+</file>
+
+<file path=ppt/notesSlides/notesSlide12.xml><?xml version="1.0" encoding="utf-8"?>
+<p:notes xmlns:a="http://schemas.openxmlformats.org/drawingml/2006/main" xmlns:p="http://schemas.openxmlformats.org/presentationml/2006/main" xmlns:r="http://schemas.openxmlformats.org/officeDocument/2006/relationships">
+  <p:cSld>
+    <p:spTree>
+      <p:nvGrpSpPr>
+        <p:cNvPr id="1" name=""/>
+        <p:cNvGrpSpPr/>
+        <p:nvPr/>
+      </p:nvGrpSpPr>
+      <p:grpSpPr>
+        <a:xfrm>
+          <a:off x="0" y="0"/>
+          <a:ext cx="0" cy="0"/>
+          <a:chOff x="0" y="0"/>
+          <a:chExt cx="0" cy="0"/>
+        </a:xfrm>
+      </p:grpSpPr>
+      <p:sp>
+        <p:nvSpPr>
+          <p:cNvPr id="2" name="Slide Image Placeholder 1"/>
+          <p:cNvSpPr>
+            <a:spLocks noGrp="1"/>
+          </p:cNvSpPr>
+          <p:nvPr>
+            <p:ph type="sldImg" idx="2"/>
+          </p:nvPr>
+        </p:nvSpPr>
+        <p:spPr/>
+      </p:sp>
+      <p:sp>
+        <p:nvSpPr>
+          <p:cNvPr id="3" name="Notes Placeholder 2"/>
+          <p:cNvSpPr>
+            <a:spLocks noGrp="1"/>
+          </p:cNvSpPr>
+          <p:nvPr>
+            <p:ph type="body" idx="3" sz="quarter"/>
+          </p:nvPr>
+        </p:nvSpPr>
+        <p:spPr/>
+        <p:txBody>
+          <a:bodyPr/>
+          <a:lstStyle/>
+          <a:p>
+            <a:r>
+              <a:t>For the remaining weeks, our priorities are: First, reduce unclassified entities from 24% to under 5% using a rescue step that re-types Other entities with class examples as context.</a:t>
+            </a:r>
+          </a:p>
+          <a:p/>
+          <a:p>
+            <a:r>
+              <a:t>Second, cross-domain transfer — run the identical pipeline on auto insurance data with zero code changes. This proves our domain-agnostic claim and fills coverage gaps since auto insurance has Persons, Organizations, and Vehicles.</a:t>
+            </a:r>
+          </a:p>
+          <a:p/>
+          <a:p>
+            <a:r>
+              <a:t>Third, measure Cross-domain Transfer Ratio and Partial Transfer Ratio to quantify how many ontology classes transfer between flood and auto.</a:t>
+            </a:r>
+          </a:p>
+          <a:p/>
+          <a:p>
+            <a:r>
+              <a:t>Fourth, paper writing targeting a peer-reviewed venue. And fifth, a Streamlit demo for interactive ontology exploration.</a:t>
+            </a:r>
+          </a:p>
+        </p:txBody>
+      </p:sp>
+      <p:sp>
+        <p:nvSpPr>
+          <p:cNvPr id="4" name="Slide Number Placeholder 3"/>
+          <p:cNvSpPr>
+            <a:spLocks noGrp="1"/>
+          </p:cNvSpPr>
+          <p:nvPr>
+            <p:ph type="sldNum" idx="5" sz="quarter"/>
+          </p:nvPr>
+        </p:nvSpPr>
+        <p:spPr/>
+      </p:sp>
+    </p:spTree>
+  </p:cSld>
+  <p:clrMapOvr>
+    <a:masterClrMapping/>
+  </p:clrMapOvr>
+</p:notes>
+</file>
+
+<file path=ppt/notesSlides/notesSlide13.xml><?xml version="1.0" encoding="utf-8"?>
+<p:notes xmlns:a="http://schemas.openxmlformats.org/drawingml/2006/main" xmlns:p="http://schemas.openxmlformats.org/presentationml/2006/main" xmlns:r="http://schemas.openxmlformats.org/officeDocument/2006/relationships">
+  <p:cSld>
+    <p:spTree>
+      <p:nvGrpSpPr>
+        <p:cNvPr id="1" name=""/>
+        <p:cNvGrpSpPr/>
+        <p:nvPr/>
+      </p:nvGrpSpPr>
+      <p:grpSpPr>
+        <a:xfrm>
+          <a:off x="0" y="0"/>
+          <a:ext cx="0" cy="0"/>
+          <a:chOff x="0" y="0"/>
+          <a:chExt cx="0" cy="0"/>
+        </a:xfrm>
+      </p:grpSpPr>
+      <p:sp>
+        <p:nvSpPr>
+          <p:cNvPr id="2" name="Slide Image Placeholder 1"/>
+          <p:cNvSpPr>
+            <a:spLocks noGrp="1"/>
+          </p:cNvSpPr>
+          <p:nvPr>
+            <p:ph type="sldImg" idx="2"/>
+          </p:nvPr>
+        </p:nvSpPr>
+        <p:spPr/>
+      </p:sp>
+      <p:sp>
+        <p:nvSpPr>
+          <p:cNvPr id="3" name="Notes Placeholder 2"/>
+          <p:cNvSpPr>
+            <a:spLocks noGrp="1"/>
+          </p:cNvSpPr>
+          <p:nvPr>
+            <p:ph type="body" idx="3" sz="quarter"/>
+          </p:nvPr>
+        </p:nvSpPr>
+        <p:spPr/>
+        <p:txBody>
+          <a:bodyPr/>
+          <a:lstStyle/>
+          <a:p>
+            <a:r>
+              <a:t>Thank you. I'm happy to take questions. The code is available on GitHub, and I want to thank Dr. Kang at Assurant for her guidance and the Emory Turing cluster for GPU resources.</a:t>
+            </a:r>
+          </a:p>
+          <a:p/>
+          <a:p>
+            <a:r>
+              <a:t>The key takeaway: SV-LOI achieves 0.732 BERTScore F1 and 0.714 Graph F1 without ever seeing the reference ontology during induction. It's fully domain-agnostic and ready for cross-domain transfer.</a:t>
+            </a:r>
+          </a:p>
+        </p:txBody>
+      </p:sp>
+      <p:sp>
+        <p:nvSpPr>
+          <p:cNvPr id="4" name="Slide Number Placeholder 3"/>
+          <p:cNvSpPr>
+            <a:spLocks noGrp="1"/>
+          </p:cNvSpPr>
+          <p:nvPr>
+            <p:ph type="sldNum" idx="5" sz="quarter"/>
+          </p:nvPr>
+        </p:nvSpPr>
+        <p:spPr/>
+      </p:sp>
+    </p:spTree>
+  </p:cSld>
+  <p:clrMapOvr>
+    <a:masterClrMapping/>
+  </p:clrMapOvr>
+</p:notes>
+</file>
+
+<file path=ppt/notesSlides/notesSlide2.xml><?xml version="1.0" encoding="utf-8"?>
+<p:notes xmlns:a="http://schemas.openxmlformats.org/drawingml/2006/main" xmlns:p="http://schemas.openxmlformats.org/presentationml/2006/main" xmlns:r="http://schemas.openxmlformats.org/officeDocument/2006/relationships">
+  <p:cSld>
+    <p:spTree>
+      <p:nvGrpSpPr>
+        <p:cNvPr id="1" name=""/>
+        <p:cNvGrpSpPr/>
+        <p:nvPr/>
+      </p:nvGrpSpPr>
+      <p:grpSpPr>
+        <a:xfrm>
+          <a:off x="0" y="0"/>
+          <a:ext cx="0" cy="0"/>
+          <a:chOff x="0" y="0"/>
+          <a:chExt cx="0" cy="0"/>
+        </a:xfrm>
+      </p:grpSpPr>
+      <p:sp>
+        <p:nvSpPr>
+          <p:cNvPr id="2" name="Slide Image Placeholder 1"/>
+          <p:cNvSpPr>
+            <a:spLocks noGrp="1"/>
+          </p:cNvSpPr>
+          <p:nvPr>
+            <p:ph type="sldImg" idx="2"/>
+          </p:nvPr>
+        </p:nvSpPr>
+        <p:spPr/>
+      </p:sp>
+      <p:sp>
+        <p:nvSpPr>
+          <p:cNvPr id="3" name="Notes Placeholder 2"/>
+          <p:cNvSpPr>
+            <a:spLocks noGrp="1"/>
+          </p:cNvSpPr>
+          <p:nvPr>
+            <p:ph type="body" idx="3" sz="quarter"/>
+          </p:nvPr>
+        </p:nvSpPr>
+        <p:spPr/>
+        <p:txBody>
+          <a:bodyPr/>
+          <a:lstStyle/>
+          <a:p>
+            <a:r>
+              <a:t>Here's the problem. When an insurance company expands into a new line of business — say from flood to auto — they need a new ontology. That means hiring domain experts, spending 3-6 months, and the work doesn't transfer between domains.</a:t>
+            </a:r>
+          </a:p>
+          <a:p/>
+          <a:p>
+            <a:r>
+              <a:t>Existing tools like LangChain's LLMGraphTransformer can extract knowledge graphs, but they produce a flat mess — duplicated entities, inconsistent types, no hierarchy. You get a knowledge graph but no ontology structure.</a:t>
+            </a:r>
+          </a:p>
+          <a:p/>
+          <a:p>
+            <a:r>
+              <a:t>Our research question: can we automatically induce an ontology from an extracted knowledge graph, without any manual engineering?</a:t>
+            </a:r>
+          </a:p>
+        </p:txBody>
+      </p:sp>
+      <p:sp>
+        <p:nvSpPr>
+          <p:cNvPr id="4" name="Slide Number Placeholder 3"/>
+          <p:cNvSpPr>
+            <a:spLocks noGrp="1"/>
+          </p:cNvSpPr>
+          <p:nvPr>
+            <p:ph type="sldNum" idx="5" sz="quarter"/>
+          </p:nvPr>
+        </p:nvSpPr>
+        <p:spPr/>
+      </p:sp>
+    </p:spTree>
+  </p:cSld>
+  <p:clrMapOvr>
+    <a:masterClrMapping/>
+  </p:clrMapOvr>
+</p:notes>
+</file>
+
+<file path=ppt/notesSlides/notesSlide3.xml><?xml version="1.0" encoding="utf-8"?>
+<p:notes xmlns:a="http://schemas.openxmlformats.org/drawingml/2006/main" xmlns:p="http://schemas.openxmlformats.org/presentationml/2006/main" xmlns:r="http://schemas.openxmlformats.org/officeDocument/2006/relationships">
+  <p:cSld>
+    <p:spTree>
+      <p:nvGrpSpPr>
+        <p:cNvPr id="1" name=""/>
+        <p:cNvGrpSpPr/>
+        <p:nvPr/>
+      </p:nvGrpSpPr>
+      <p:grpSpPr>
+        <a:xfrm>
+          <a:off x="0" y="0"/>
+          <a:ext cx="0" cy="0"/>
+          <a:chOff x="0" y="0"/>
+          <a:chExt cx="0" cy="0"/>
+        </a:xfrm>
+      </p:grpSpPr>
+      <p:sp>
+        <p:nvSpPr>
+          <p:cNvPr id="2" name="Slide Image Placeholder 1"/>
+          <p:cNvSpPr>
+            <a:spLocks noGrp="1"/>
+          </p:cNvSpPr>
+          <p:nvPr>
+            <p:ph type="sldImg" idx="2"/>
+          </p:nvPr>
+        </p:nvSpPr>
+        <p:spPr/>
+      </p:sp>
+      <p:sp>
+        <p:nvSpPr>
+          <p:cNvPr id="3" name="Notes Placeholder 2"/>
+          <p:cNvSpPr>
+            <a:spLocks noGrp="1"/>
+          </p:cNvSpPr>
+          <p:nvPr>
+            <p:ph type="body" idx="3" sz="quarter"/>
+          </p:nvPr>
+        </p:nvSpPr>
+        <p:spPr/>
+        <p:txBody>
+          <a:bodyPr/>
+          <a:lstStyle/>
+          <a:p>
+            <a:r>
+              <a:t>Our pipeline has 4 zones. Zone 1 handles document ingestion — we process both SFIP policy PDFs and OpenFEMA claims CSVs using section-aware chunking with a semantic merge threshold of 0.85.</a:t>
+            </a:r>
+          </a:p>
+          <a:p/>
+          <a:p>
+            <a:r>
+              <a:t>Zone 2 is extraction — this is where we bootstrap entity and relation vocabularies from the documents themselves, extract triples, and resolve duplicate entities. This zone is done and works well — 95% query accuracy.</a:t>
+            </a:r>
+          </a:p>
+          <a:p/>
+          <a:p>
+            <a:r>
+              <a:t>Zone 3 is the research contribution — ontology induction. This is where we take the flat entity graph and discover what classes exist, which entities belong to which class, and how classes relate hierarchically.</a:t>
+            </a:r>
+          </a:p>
+          <a:p/>
+          <a:p>
+            <a:r>
+              <a:t>Zone 4 is structured storage in Neo4j with three layers. The critical point: the entire pipeline is domain-agnostic. The same code runs on flood AND auto insurance with zero changes.</a:t>
+            </a:r>
+          </a:p>
+        </p:txBody>
+      </p:sp>
+      <p:sp>
+        <p:nvSpPr>
+          <p:cNvPr id="4" name="Slide Number Placeholder 3"/>
+          <p:cNvSpPr>
+            <a:spLocks noGrp="1"/>
+          </p:cNvSpPr>
+          <p:nvPr>
+            <p:ph type="sldNum" idx="5" sz="quarter"/>
+          </p:nvPr>
+        </p:nvSpPr>
+        <p:spPr/>
+      </p:sp>
+    </p:spTree>
+  </p:cSld>
+  <p:clrMapOvr>
+    <a:masterClrMapping/>
+  </p:clrMapOvr>
+</p:notes>
+</file>
+
+<file path=ppt/notesSlides/notesSlide4.xml><?xml version="1.0" encoding="utf-8"?>
+<p:notes xmlns:a="http://schemas.openxmlformats.org/drawingml/2006/main" xmlns:p="http://schemas.openxmlformats.org/presentationml/2006/main" xmlns:r="http://schemas.openxmlformats.org/officeDocument/2006/relationships">
+  <p:cSld>
+    <p:spTree>
+      <p:nvGrpSpPr>
+        <p:cNvPr id="1" name=""/>
+        <p:cNvGrpSpPr/>
+        <p:nvPr/>
+      </p:nvGrpSpPr>
+      <p:grpSpPr>
+        <a:xfrm>
+          <a:off x="0" y="0"/>
+          <a:ext cx="0" cy="0"/>
+          <a:chOff x="0" y="0"/>
+          <a:chExt cx="0" cy="0"/>
+        </a:xfrm>
+      </p:grpSpPr>
+      <p:sp>
+        <p:nvSpPr>
+          <p:cNvPr id="2" name="Slide Image Placeholder 1"/>
+          <p:cNvSpPr>
+            <a:spLocks noGrp="1"/>
+          </p:cNvSpPr>
+          <p:nvPr>
+            <p:ph type="sldImg" idx="2"/>
+          </p:nvPr>
+        </p:nvSpPr>
+        <p:spPr/>
+      </p:sp>
+      <p:sp>
+        <p:nvSpPr>
+          <p:cNvPr id="3" name="Notes Placeholder 2"/>
+          <p:cNvSpPr>
+            <a:spLocks noGrp="1"/>
+          </p:cNvSpPr>
+          <p:nvPr>
+            <p:ph type="body" idx="3" sz="quarter"/>
+          </p:nvPr>
+        </p:nvSpPr>
+        <p:spPr/>
+        <p:txBody>
+          <a:bodyPr/>
+          <a:lstStyle/>
+          <a:p>
+            <a:r>
+              <a:t>Let me show you Zone 2 results. Using qwen2.5:72b on the Emory Turing GPU cluster, we extracted 1,351 entities and 1,749 relationships from 188 chunks. Query accuracy is 95% — meaning 19 out of 20 evaluation queries return correct answers.</a:t>
+            </a:r>
+          </a:p>
+          <a:p/>
+          <a:p>
+            <a:r>
+              <a:t>The key takeaway: extraction is solved. The bottleneck is ontology induction — that's where our research contribution lies.</a:t>
+            </a:r>
+          </a:p>
+        </p:txBody>
+      </p:sp>
+      <p:sp>
+        <p:nvSpPr>
+          <p:cNvPr id="4" name="Slide Number Placeholder 3"/>
+          <p:cNvSpPr>
+            <a:spLocks noGrp="1"/>
+          </p:cNvSpPr>
+          <p:nvPr>
+            <p:ph type="sldNum" idx="5" sz="quarter"/>
+          </p:nvPr>
+        </p:nvSpPr>
+        <p:spPr/>
+      </p:sp>
+    </p:spTree>
+  </p:cSld>
+  <p:clrMapOvr>
+    <a:masterClrMapping/>
+  </p:clrMapOvr>
+</p:notes>
+</file>
+
+<file path=ppt/notesSlides/notesSlide5.xml><?xml version="1.0" encoding="utf-8"?>
+<p:notes xmlns:a="http://schemas.openxmlformats.org/drawingml/2006/main" xmlns:p="http://schemas.openxmlformats.org/presentationml/2006/main" xmlns:r="http://schemas.openxmlformats.org/officeDocument/2006/relationships">
+  <p:cSld>
+    <p:spTree>
+      <p:nvGrpSpPr>
+        <p:cNvPr id="1" name=""/>
+        <p:cNvGrpSpPr/>
+        <p:nvPr/>
+      </p:nvGrpSpPr>
+      <p:grpSpPr>
+        <a:xfrm>
+          <a:off x="0" y="0"/>
+          <a:ext cx="0" cy="0"/>
+          <a:chOff x="0" y="0"/>
+          <a:chExt cx="0" cy="0"/>
+        </a:xfrm>
+      </p:grpSpPr>
+      <p:sp>
+        <p:nvSpPr>
+          <p:cNvPr id="2" name="Slide Image Placeholder 1"/>
+          <p:cNvSpPr>
+            <a:spLocks noGrp="1"/>
+          </p:cNvSpPr>
+          <p:nvPr>
+            <p:ph type="sldImg" idx="2"/>
+          </p:nvPr>
+        </p:nvSpPr>
+        <p:spPr/>
+      </p:sp>
+      <p:sp>
+        <p:nvSpPr>
+          <p:cNvPr id="3" name="Notes Placeholder 2"/>
+          <p:cNvSpPr>
+            <a:spLocks noGrp="1"/>
+          </p:cNvSpPr>
+          <p:nvPr>
+            <p:ph type="body" idx="3" sz="quarter"/>
+          </p:nvPr>
+        </p:nvSpPr>
+        <p:spPr/>
+        <p:txBody>
+          <a:bodyPr/>
+          <a:lstStyle/>
+          <a:p>
+            <a:r>
+              <a:t>For Zone 3, we implemented and compared three ontology induction methods. Method A is our baseline — Leiden community detection, a standard graph clustering algorithm. Method B is RSI-LCR, which uses relation signatures instead of name embeddings. Method C is SV-LOI — our novel contribution — which fuses LLM semantic typing with structural verification.</a:t>
+            </a:r>
+          </a:p>
+          <a:p/>
+          <a:p>
+            <a:r>
+              <a:t>The key insight driving this progression: neither semantic signals alone nor structural signals alone are sufficient. You need both.</a:t>
+            </a:r>
+          </a:p>
+        </p:txBody>
+      </p:sp>
+      <p:sp>
+        <p:nvSpPr>
+          <p:cNvPr id="4" name="Slide Number Placeholder 3"/>
+          <p:cNvSpPr>
+            <a:spLocks noGrp="1"/>
+          </p:cNvSpPr>
+          <p:nvPr>
+            <p:ph type="sldNum" idx="5" sz="quarter"/>
+          </p:nvPr>
+        </p:nvSpPr>
+        <p:spPr/>
+      </p:sp>
+    </p:spTree>
+  </p:cSld>
+  <p:clrMapOvr>
+    <a:masterClrMapping/>
+  </p:clrMapOvr>
+</p:notes>
+</file>
+
+<file path=ppt/notesSlides/notesSlide6.xml><?xml version="1.0" encoding="utf-8"?>
+<p:notes xmlns:a="http://schemas.openxmlformats.org/drawingml/2006/main" xmlns:p="http://schemas.openxmlformats.org/presentationml/2006/main" xmlns:r="http://schemas.openxmlformats.org/officeDocument/2006/relationships">
+  <p:cSld>
+    <p:spTree>
+      <p:nvGrpSpPr>
+        <p:cNvPr id="1" name=""/>
+        <p:cNvGrpSpPr/>
+        <p:nvPr/>
+      </p:nvGrpSpPr>
+      <p:grpSpPr>
+        <a:xfrm>
+          <a:off x="0" y="0"/>
+          <a:ext cx="0" cy="0"/>
+          <a:chOff x="0" y="0"/>
+          <a:chExt cx="0" cy="0"/>
+        </a:xfrm>
+      </p:grpSpPr>
+      <p:sp>
+        <p:nvSpPr>
+          <p:cNvPr id="2" name="Slide Image Placeholder 1"/>
+          <p:cNvSpPr>
+            <a:spLocks noGrp="1"/>
+          </p:cNvSpPr>
+          <p:nvPr>
+            <p:ph type="sldImg" idx="2"/>
+          </p:nvPr>
+        </p:nvSpPr>
+        <p:spPr/>
+      </p:sp>
+      <p:sp>
+        <p:nvSpPr>
+          <p:cNvPr id="3" name="Notes Placeholder 2"/>
+          <p:cNvSpPr>
+            <a:spLocks noGrp="1"/>
+          </p:cNvSpPr>
+          <p:nvPr>
+            <p:ph type="body" idx="3" sz="quarter"/>
+          </p:nvPr>
+        </p:nvSpPr>
+        <p:spPr/>
+        <p:txBody>
+          <a:bodyPr/>
+          <a:lstStyle/>
+          <a:p>
+            <a:r>
+              <a:t>Method A: Leiden community detection. Why did we try this? It's the standard approach — if entities are similar, they should cluster together. Leiden is state-of-the-art for community detection.</a:t>
+            </a:r>
+          </a:p>
+          <a:p/>
+          <a:p>
+            <a:r>
+              <a:t>What it solved: it successfully found 11 clusters from 1,351 entities and produced a SUBCLASS_OF hierarchy. So bottom-up induction IS feasible.</a:t>
+            </a:r>
+          </a:p>
+          <a:p/>
+          <a:p>
+            <a:r>
+              <a:t>But why did it fail? The clusters are semantically impure. For example, the cluster named "Hazard" mixed together coverages, buildings, AND perils — three completely different ontological types. Name F1 was literally zero — not a single class name matched the reference ontology.</a:t>
+            </a:r>
+          </a:p>
+          <a:p/>
+          <a:p>
+            <a:r>
+              <a:t>The lesson: embedding similarity groups entities that LOOK alike in vector space, but that doesn't mean they ARE the same thing ontologically. A flood zone and a building can have similar embeddings but belong to completely different classes.</a:t>
+            </a:r>
+          </a:p>
+        </p:txBody>
+      </p:sp>
+      <p:sp>
+        <p:nvSpPr>
+          <p:cNvPr id="4" name="Slide Number Placeholder 3"/>
+          <p:cNvSpPr>
+            <a:spLocks noGrp="1"/>
+          </p:cNvSpPr>
+          <p:nvPr>
+            <p:ph type="sldNum" idx="5" sz="quarter"/>
+          </p:nvPr>
+        </p:nvSpPr>
+        <p:spPr/>
+      </p:sp>
+    </p:spTree>
+  </p:cSld>
+  <p:clrMapOvr>
+    <a:masterClrMapping/>
+  </p:clrMapOvr>
+</p:notes>
+</file>
+
+<file path=ppt/notesSlides/notesSlide7.xml><?xml version="1.0" encoding="utf-8"?>
+<p:notes xmlns:a="http://schemas.openxmlformats.org/drawingml/2006/main" xmlns:p="http://schemas.openxmlformats.org/presentationml/2006/main" xmlns:r="http://schemas.openxmlformats.org/officeDocument/2006/relationships">
+  <p:cSld>
+    <p:spTree>
+      <p:nvGrpSpPr>
+        <p:cNvPr id="1" name=""/>
+        <p:cNvGrpSpPr/>
+        <p:nvPr/>
+      </p:nvGrpSpPr>
+      <p:grpSpPr>
+        <a:xfrm>
+          <a:off x="0" y="0"/>
+          <a:ext cx="0" cy="0"/>
+          <a:chOff x="0" y="0"/>
+          <a:chExt cx="0" cy="0"/>
+        </a:xfrm>
+      </p:grpSpPr>
+      <p:sp>
+        <p:nvSpPr>
+          <p:cNvPr id="2" name="Slide Image Placeholder 1"/>
+          <p:cNvSpPr>
+            <a:spLocks noGrp="1"/>
+          </p:cNvSpPr>
+          <p:nvPr>
+            <p:ph type="sldImg" idx="2"/>
+          </p:nvPr>
+        </p:nvSpPr>
+        <p:spPr/>
+      </p:sp>
+      <p:sp>
+        <p:nvSpPr>
+          <p:cNvPr id="3" name="Notes Placeholder 2"/>
+          <p:cNvSpPr>
+            <a:spLocks noGrp="1"/>
+          </p:cNvSpPr>
+          <p:nvPr>
+            <p:ph type="body" idx="3" sz="quarter"/>
+          </p:nvPr>
+        </p:nvSpPr>
+        <p:spPr/>
+        <p:txBody>
+          <a:bodyPr/>
+          <a:lstStyle/>
+          <a:p>
+            <a:r>
+              <a:t>Method B: RSI-LCR — Relation-Signature Induction with LLM Coherence Refinement. The idea: fix Leiden's flaw by clustering on relation PATTERNS instead of name embeddings. The insight is that entities of the same class participate in the same types of relations — Coverage entities have COVERS and HAS_LIMIT; Person entities have HAS_NAME and RESIDES_AT.</a:t>
+            </a:r>
+          </a:p>
+          <a:p/>
+          <a:p>
+            <a:r>
+              <a:t>What it solved: better structural separation. Name F1 went from 0.000 to 0.295 — it found Coverage, Risk, and Property. The LLM coherence refinement step catches and splits bad clusters.</a:t>
+            </a:r>
+          </a:p>
+          <a:p/>
+          <a:p>
+            <a:r>
+              <a:t>But it fell short because it over-fragments — 30 tiny clusters instead of 10-15 meaningful classes. In a dense graph where entities share many relation types, the signatures overlap too much. Structural signal alone can't distinguish ontological types.</a:t>
+            </a:r>
+          </a:p>
+          <a:p/>
+          <a:p>
+            <a:r>
+              <a:t>The lesson: relation patterns tell you how entities BEHAVE, not what they ARE. A deductible and a coverage both participate in the same relations — but they're different concepts.</a:t>
+            </a:r>
+          </a:p>
+        </p:txBody>
+      </p:sp>
+      <p:sp>
+        <p:nvSpPr>
+          <p:cNvPr id="4" name="Slide Number Placeholder 3"/>
+          <p:cNvSpPr>
+            <a:spLocks noGrp="1"/>
+          </p:cNvSpPr>
+          <p:nvPr>
+            <p:ph type="sldNum" idx="5" sz="quarter"/>
+          </p:nvPr>
+        </p:nvSpPr>
+        <p:spPr/>
+      </p:sp>
+    </p:spTree>
+  </p:cSld>
+  <p:clrMapOvr>
+    <a:masterClrMapping/>
+  </p:clrMapOvr>
+</p:notes>
+</file>
+
+<file path=ppt/notesSlides/notesSlide8.xml><?xml version="1.0" encoding="utf-8"?>
+<p:notes xmlns:a="http://schemas.openxmlformats.org/drawingml/2006/main" xmlns:p="http://schemas.openxmlformats.org/presentationml/2006/main" xmlns:r="http://schemas.openxmlformats.org/officeDocument/2006/relationships">
+  <p:cSld>
+    <p:spTree>
+      <p:nvGrpSpPr>
+        <p:cNvPr id="1" name=""/>
+        <p:cNvGrpSpPr/>
+        <p:nvPr/>
+      </p:nvGrpSpPr>
+      <p:grpSpPr>
+        <a:xfrm>
+          <a:off x="0" y="0"/>
+          <a:ext cx="0" cy="0"/>
+          <a:chOff x="0" y="0"/>
+          <a:chExt cx="0" cy="0"/>
+        </a:xfrm>
+      </p:grpSpPr>
+      <p:sp>
+        <p:nvSpPr>
+          <p:cNvPr id="2" name="Slide Image Placeholder 1"/>
+          <p:cNvSpPr>
+            <a:spLocks noGrp="1"/>
+          </p:cNvSpPr>
+          <p:nvPr>
+            <p:ph type="sldImg" idx="2"/>
+          </p:nvPr>
+        </p:nvSpPr>
+        <p:spPr/>
+      </p:sp>
+      <p:sp>
+        <p:nvSpPr>
+          <p:cNvPr id="3" name="Notes Placeholder 2"/>
+          <p:cNvSpPr>
+            <a:spLocks noGrp="1"/>
+          </p:cNvSpPr>
+          <p:nvPr>
+            <p:ph type="body" idx="3" sz="quarter"/>
+          </p:nvPr>
+        </p:nvSpPr>
+        <p:spPr/>
+        <p:txBody>
+          <a:bodyPr/>
+          <a:lstStyle/>
+          <a:p>
+            <a:r>
+              <a:t>Method C: SV-LOI — our novel contribution. This is Structurally-Verified LLM Ontology Induction.</a:t>
+            </a:r>
+          </a:p>
+          <a:p/>
+          <a:p>
+            <a:r>
+              <a:t>Why? Because Leiden showed semantic signals fail alone, and RSI-LCR showed structural signals fail alone. The key insight: FUSE both signals. The LLM knows WHAT an entity is from its name and context. The graph structure can VERIFY whether that assignment is consistent.</a:t>
+            </a:r>
+          </a:p>
+          <a:p/>
+          <a:p>
+            <a:r>
+              <a:t>How it works in 6 phases: First, detect the domain from entity names — the LLM figures out "this is flood insurance." Second, the LLM proposes ontology classes for that domain. Third, it assigns each entity to a class in batches. Fourth, we build structural signatures and check — does each entity's relation pattern match its assigned class? Fifth, for disagreements, the LLM arbitrates with enriched context. Sixth, we consolidate fine-grained classes.</a:t>
+            </a:r>
+          </a:p>
+          <a:p/>
+          <a:p>
+            <a:r>
+              <a:t>Results: Name F1 jumped to 0.563. BERTScore F1 is 0.732. Graph F1 is 0.714. We get 7 clean classes instead of 30, and 5 out of 10 Riskine reference classes are matched — without ever seeing the reference ontology during induction.</a:t>
+            </a:r>
+          </a:p>
+          <a:p/>
+          <a:p>
+            <a:r>
+              <a:t>SV-LOI wins on EVERY metric versus both Leiden and RSI-LCR.</a:t>
+            </a:r>
+          </a:p>
+        </p:txBody>
+      </p:sp>
+      <p:sp>
+        <p:nvSpPr>
+          <p:cNvPr id="4" name="Slide Number Placeholder 3"/>
+          <p:cNvSpPr>
+            <a:spLocks noGrp="1"/>
+          </p:cNvSpPr>
+          <p:nvPr>
+            <p:ph type="sldNum" idx="5" sz="quarter"/>
+          </p:nvPr>
+        </p:nvSpPr>
+        <p:spPr/>
+      </p:sp>
+    </p:spTree>
+  </p:cSld>
+  <p:clrMapOvr>
+    <a:masterClrMapping/>
+  </p:clrMapOvr>
+</p:notes>
+</file>
+
+<file path=ppt/notesSlides/notesSlide9.xml><?xml version="1.0" encoding="utf-8"?>
+<p:notes xmlns:a="http://schemas.openxmlformats.org/drawingml/2006/main" xmlns:p="http://schemas.openxmlformats.org/presentationml/2006/main" xmlns:r="http://schemas.openxmlformats.org/officeDocument/2006/relationships">
+  <p:cSld>
+    <p:spTree>
+      <p:nvGrpSpPr>
+        <p:cNvPr id="1" name=""/>
+        <p:cNvGrpSpPr/>
+        <p:nvPr/>
+      </p:nvGrpSpPr>
+      <p:grpSpPr>
+        <a:xfrm>
+          <a:off x="0" y="0"/>
+          <a:ext cx="0" cy="0"/>
+          <a:chOff x="0" y="0"/>
+          <a:chExt cx="0" cy="0"/>
+        </a:xfrm>
+      </p:grpSpPr>
+      <p:sp>
+        <p:nvSpPr>
+          <p:cNvPr id="2" name="Slide Image Placeholder 1"/>
+          <p:cNvSpPr>
+            <a:spLocks noGrp="1"/>
+          </p:cNvSpPr>
+          <p:nvPr>
+            <p:ph type="sldImg" idx="2"/>
+          </p:nvPr>
+        </p:nvSpPr>
+        <p:spPr/>
+      </p:sp>
+      <p:sp>
+        <p:nvSpPr>
+          <p:cNvPr id="3" name="Notes Placeholder 2"/>
+          <p:cNvSpPr>
+            <a:spLocks noGrp="1"/>
+          </p:cNvSpPr>
+          <p:nvPr>
+            <p:ph type="body" idx="3" sz="quarter"/>
+          </p:nvPr>
+        </p:nvSpPr>
+        <p:spPr/>
+        <p:txBody>
+          <a:bodyPr/>
+          <a:lstStyle/>
+          <a:p>
+            <a:r>
+              <a:t>Here's the full comparison table. Look at the progression across all metrics — every single one improves from Leiden to RSI-LCR to SV-LOI.</a:t>
+            </a:r>
+          </a:p>
+          <a:p/>
+          <a:p>
+            <a:r>
+              <a:t>The most dramatic improvement is Name F1: from literally zero with Leiden, to 0.295 with RSI-LCR, to 0.563 with SV-LOI. BERTScore F1 goes from 0.451 to 0.732. Graph F1 from 0.441 to 0.714.</a:t>
+            </a:r>
+          </a:p>
+          <a:p/>
+          <a:p>
+            <a:r>
+              <a:t>Also notice the induced class count: Leiden found 11 clusters, RSI-LCR over-fragmented to 30, and SV-LOI consolidates to 7 clean classes. Fewer, cleaner classes.</a:t>
+            </a:r>
+          </a:p>
+          <a:p/>
+          <a:p>
+            <a:r>
+              <a:t>All three methods use the exact same Zone 2 extraction as input — same 1,351 entities, same 1,749 relationships. The only difference is the induction algorithm. We follow the OLLM evaluation protocol from NeurIPS 2024 for fair comparison.</a:t>
+            </a:r>
+          </a:p>
+        </p:txBody>
+      </p:sp>
+      <p:sp>
+        <p:nvSpPr>
+          <p:cNvPr id="4" name="Slide Number Placeholder 3"/>
+          <p:cNvSpPr>
+            <a:spLocks noGrp="1"/>
+          </p:cNvSpPr>
+          <p:nvPr>
+            <p:ph type="sldNum" idx="5" sz="quarter"/>
+          </p:nvPr>
+        </p:nvSpPr>
+        <p:spPr/>
+      </p:sp>
+    </p:spTree>
+  </p:cSld>
+  <p:clrMapOvr>
+    <a:masterClrMapping/>
+  </p:clrMapOvr>
+</p:notes>
 </file>
 
 <file path=ppt/slideLayouts/slideLayout1.xml><?xml version="1.0" encoding="utf-8"?>
@@ -157,10 +1613,9 @@
           <a:lstStyle/>
           <a:p>
             <a:r>
-              <a:rPr lang="en-US" smtClean="0"/>
+              <a:rPr lang="en-US"/>
               <a:t>Click to edit Master title style</a:t>
             </a:r>
-            <a:endParaRPr lang="en-US"/>
           </a:p>
         </p:txBody>
       </p:sp>
@@ -276,10 +1731,9 @@
           </a:lstStyle>
           <a:p>
             <a:r>
-              <a:rPr lang="en-US" smtClean="0"/>
+              <a:rPr lang="en-US"/>
               <a:t>Click to edit Master subtitle style</a:t>
             </a:r>
-            <a:endParaRPr lang="en-US"/>
           </a:p>
         </p:txBody>
       </p:sp>
@@ -300,7 +1754,7 @@
           <a:p>
             <a:fld id="{5BCAD085-E8A6-8845-BD4E-CB4CCA059FC4}" type="datetimeFigureOut">
               <a:rPr lang="en-US" smtClean="0"/>
-              <a:t>1/27/13</a:t>
+              <a:t>3/24/26</a:t>
             </a:fld>
             <a:endParaRPr lang="en-US"/>
           </a:p>
@@ -394,10 +1848,9 @@
           <a:lstStyle/>
           <a:p>
             <a:r>
-              <a:rPr lang="en-US" smtClean="0"/>
+              <a:rPr lang="en-US"/>
               <a:t>Click to edit Master title style</a:t>
             </a:r>
-            <a:endParaRPr lang="en-US"/>
           </a:p>
         </p:txBody>
       </p:sp>
@@ -418,38 +1871,37 @@
           <a:p>
             <a:pPr lvl="0"/>
             <a:r>
-              <a:rPr lang="en-US" smtClean="0"/>
+              <a:rPr lang="en-US"/>
               <a:t>Click to edit Master text styles</a:t>
             </a:r>
           </a:p>
           <a:p>
             <a:pPr lvl="1"/>
             <a:r>
-              <a:rPr lang="en-US" smtClean="0"/>
+              <a:rPr lang="en-US"/>
               <a:t>Second level</a:t>
             </a:r>
           </a:p>
           <a:p>
             <a:pPr lvl="2"/>
             <a:r>
-              <a:rPr lang="en-US" smtClean="0"/>
+              <a:rPr lang="en-US"/>
               <a:t>Third level</a:t>
             </a:r>
           </a:p>
           <a:p>
             <a:pPr lvl="3"/>
             <a:r>
-              <a:rPr lang="en-US" smtClean="0"/>
+              <a:rPr lang="en-US"/>
               <a:t>Fourth level</a:t>
             </a:r>
           </a:p>
           <a:p>
             <a:pPr lvl="4"/>
             <a:r>
-              <a:rPr lang="en-US" smtClean="0"/>
+              <a:rPr lang="en-US"/>
               <a:t>Fifth level</a:t>
             </a:r>
-            <a:endParaRPr lang="en-US"/>
           </a:p>
         </p:txBody>
       </p:sp>
@@ -470,7 +1922,7 @@
           <a:p>
             <a:fld id="{5BCAD085-E8A6-8845-BD4E-CB4CCA059FC4}" type="datetimeFigureOut">
               <a:rPr lang="en-US" smtClean="0"/>
-              <a:t>1/27/13</a:t>
+              <a:t>3/24/26</a:t>
             </a:fld>
             <a:endParaRPr lang="en-US"/>
           </a:p>
@@ -569,10 +2021,9 @@
           <a:lstStyle/>
           <a:p>
             <a:r>
-              <a:rPr lang="en-US" smtClean="0"/>
+              <a:rPr lang="en-US"/>
               <a:t>Click to edit Master title style</a:t>
             </a:r>
-            <a:endParaRPr lang="en-US"/>
           </a:p>
         </p:txBody>
       </p:sp>
@@ -598,38 +2049,37 @@
           <a:p>
             <a:pPr lvl="0"/>
             <a:r>
-              <a:rPr lang="en-US" smtClean="0"/>
+              <a:rPr lang="en-US"/>
               <a:t>Click to edit Master text styles</a:t>
             </a:r>
           </a:p>
           <a:p>
             <a:pPr lvl="1"/>
             <a:r>
-              <a:rPr lang="en-US" smtClean="0"/>
+              <a:rPr lang="en-US"/>
               <a:t>Second level</a:t>
             </a:r>
           </a:p>
           <a:p>
             <a:pPr lvl="2"/>
             <a:r>
-              <a:rPr lang="en-US" smtClean="0"/>
+              <a:rPr lang="en-US"/>
               <a:t>Third level</a:t>
             </a:r>
           </a:p>
           <a:p>
             <a:pPr lvl="3"/>
             <a:r>
-              <a:rPr lang="en-US" smtClean="0"/>
+              <a:rPr lang="en-US"/>
               <a:t>Fourth level</a:t>
             </a:r>
           </a:p>
           <a:p>
             <a:pPr lvl="4"/>
             <a:r>
-              <a:rPr lang="en-US" smtClean="0"/>
+              <a:rPr lang="en-US"/>
               <a:t>Fifth level</a:t>
             </a:r>
-            <a:endParaRPr lang="en-US"/>
           </a:p>
         </p:txBody>
       </p:sp>
@@ -650,7 +2100,7 @@
           <a:p>
             <a:fld id="{5BCAD085-E8A6-8845-BD4E-CB4CCA059FC4}" type="datetimeFigureOut">
               <a:rPr lang="en-US" smtClean="0"/>
-              <a:t>1/27/13</a:t>
+              <a:t>3/24/26</a:t>
             </a:fld>
             <a:endParaRPr lang="en-US"/>
           </a:p>
@@ -744,10 +2194,9 @@
           <a:lstStyle/>
           <a:p>
             <a:r>
-              <a:rPr lang="en-US" smtClean="0"/>
+              <a:rPr lang="en-US"/>
               <a:t>Click to edit Master title style</a:t>
             </a:r>
-            <a:endParaRPr lang="en-US"/>
           </a:p>
         </p:txBody>
       </p:sp>
@@ -768,38 +2217,37 @@
           <a:p>
             <a:pPr lvl="0"/>
             <a:r>
-              <a:rPr lang="en-US" smtClean="0"/>
+              <a:rPr lang="en-US"/>
               <a:t>Click to edit Master text styles</a:t>
             </a:r>
           </a:p>
           <a:p>
             <a:pPr lvl="1"/>
             <a:r>
-              <a:rPr lang="en-US" smtClean="0"/>
+              <a:rPr lang="en-US"/>
               <a:t>Second level</a:t>
             </a:r>
           </a:p>
           <a:p>
             <a:pPr lvl="2"/>
             <a:r>
-              <a:rPr lang="en-US" smtClean="0"/>
+              <a:rPr lang="en-US"/>
               <a:t>Third level</a:t>
             </a:r>
           </a:p>
           <a:p>
             <a:pPr lvl="3"/>
             <a:r>
-              <a:rPr lang="en-US" smtClean="0"/>
+              <a:rPr lang="en-US"/>
               <a:t>Fourth level</a:t>
             </a:r>
           </a:p>
           <a:p>
             <a:pPr lvl="4"/>
             <a:r>
-              <a:rPr lang="en-US" smtClean="0"/>
+              <a:rPr lang="en-US"/>
               <a:t>Fifth level</a:t>
             </a:r>
-            <a:endParaRPr lang="en-US"/>
           </a:p>
         </p:txBody>
       </p:sp>
@@ -820,7 +2268,7 @@
           <a:p>
             <a:fld id="{5BCAD085-E8A6-8845-BD4E-CB4CCA059FC4}" type="datetimeFigureOut">
               <a:rPr lang="en-US" smtClean="0"/>
-              <a:t>1/27/13</a:t>
+              <a:t>3/24/26</a:t>
             </a:fld>
             <a:endParaRPr lang="en-US"/>
           </a:p>
@@ -923,10 +2371,9 @@
           </a:lstStyle>
           <a:p>
             <a:r>
-              <a:rPr lang="en-US" smtClean="0"/>
+              <a:rPr lang="en-US"/>
               <a:t>Click to edit Master title style</a:t>
             </a:r>
-            <a:endParaRPr lang="en-US"/>
           </a:p>
         </p:txBody>
       </p:sp>
@@ -1043,7 +2490,7 @@
           <a:p>
             <a:pPr lvl="0"/>
             <a:r>
-              <a:rPr lang="en-US" smtClean="0"/>
+              <a:rPr lang="en-US"/>
               <a:t>Click to edit Master text styles</a:t>
             </a:r>
           </a:p>
@@ -1066,7 +2513,7 @@
           <a:p>
             <a:fld id="{5BCAD085-E8A6-8845-BD4E-CB4CCA059FC4}" type="datetimeFigureOut">
               <a:rPr lang="en-US" smtClean="0"/>
-              <a:t>1/27/13</a:t>
+              <a:t>3/24/26</a:t>
             </a:fld>
             <a:endParaRPr lang="en-US"/>
           </a:p>
@@ -1160,10 +2607,9 @@
           <a:lstStyle/>
           <a:p>
             <a:r>
-              <a:rPr lang="en-US" smtClean="0"/>
+              <a:rPr lang="en-US"/>
               <a:t>Click to edit Master title style</a:t>
             </a:r>
-            <a:endParaRPr lang="en-US"/>
           </a:p>
         </p:txBody>
       </p:sp>
@@ -1217,38 +2663,37 @@
           <a:p>
             <a:pPr lvl="0"/>
             <a:r>
-              <a:rPr lang="en-US" smtClean="0"/>
+              <a:rPr lang="en-US"/>
               <a:t>Click to edit Master text styles</a:t>
             </a:r>
           </a:p>
           <a:p>
             <a:pPr lvl="1"/>
             <a:r>
-              <a:rPr lang="en-US" smtClean="0"/>
+              <a:rPr lang="en-US"/>
               <a:t>Second level</a:t>
             </a:r>
           </a:p>
           <a:p>
             <a:pPr lvl="2"/>
             <a:r>
-              <a:rPr lang="en-US" smtClean="0"/>
+              <a:rPr lang="en-US"/>
               <a:t>Third level</a:t>
             </a:r>
           </a:p>
           <a:p>
             <a:pPr lvl="3"/>
             <a:r>
-              <a:rPr lang="en-US" smtClean="0"/>
+              <a:rPr lang="en-US"/>
               <a:t>Fourth level</a:t>
             </a:r>
           </a:p>
           <a:p>
             <a:pPr lvl="4"/>
             <a:r>
-              <a:rPr lang="en-US" smtClean="0"/>
+              <a:rPr lang="en-US"/>
               <a:t>Fifth level</a:t>
             </a:r>
-            <a:endParaRPr lang="en-US"/>
           </a:p>
         </p:txBody>
       </p:sp>
@@ -1302,38 +2747,37 @@
           <a:p>
             <a:pPr lvl="0"/>
             <a:r>
-              <a:rPr lang="en-US" smtClean="0"/>
+              <a:rPr lang="en-US"/>
               <a:t>Click to edit Master text styles</a:t>
             </a:r>
           </a:p>
           <a:p>
             <a:pPr lvl="1"/>
             <a:r>
-              <a:rPr lang="en-US" smtClean="0"/>
+              <a:rPr lang="en-US"/>
               <a:t>Second level</a:t>
             </a:r>
           </a:p>
           <a:p>
             <a:pPr lvl="2"/>
             <a:r>
-              <a:rPr lang="en-US" smtClean="0"/>
+              <a:rPr lang="en-US"/>
               <a:t>Third level</a:t>
             </a:r>
           </a:p>
           <a:p>
             <a:pPr lvl="3"/>
             <a:r>
-              <a:rPr lang="en-US" smtClean="0"/>
+              <a:rPr lang="en-US"/>
               <a:t>Fourth level</a:t>
             </a:r>
           </a:p>
           <a:p>
             <a:pPr lvl="4"/>
             <a:r>
-              <a:rPr lang="en-US" smtClean="0"/>
+              <a:rPr lang="en-US"/>
               <a:t>Fifth level</a:t>
             </a:r>
-            <a:endParaRPr lang="en-US"/>
           </a:p>
         </p:txBody>
       </p:sp>
@@ -1354,7 +2798,7 @@
           <a:p>
             <a:fld id="{5BCAD085-E8A6-8845-BD4E-CB4CCA059FC4}" type="datetimeFigureOut">
               <a:rPr lang="en-US" smtClean="0"/>
-              <a:t>1/27/13</a:t>
+              <a:t>3/24/26</a:t>
             </a:fld>
             <a:endParaRPr lang="en-US"/>
           </a:p>
@@ -1452,10 +2896,9 @@
           </a:lstStyle>
           <a:p>
             <a:r>
-              <a:rPr lang="en-US" smtClean="0"/>
+              <a:rPr lang="en-US"/>
               <a:t>Click to edit Master title style</a:t>
             </a:r>
-            <a:endParaRPr lang="en-US"/>
           </a:p>
         </p:txBody>
       </p:sp>
@@ -1518,7 +2961,7 @@
           <a:p>
             <a:pPr lvl="0"/>
             <a:r>
-              <a:rPr lang="en-US" smtClean="0"/>
+              <a:rPr lang="en-US"/>
               <a:t>Click to edit Master text styles</a:t>
             </a:r>
           </a:p>
@@ -1574,38 +3017,37 @@
           <a:p>
             <a:pPr lvl="0"/>
             <a:r>
-              <a:rPr lang="en-US" smtClean="0"/>
+              <a:rPr lang="en-US"/>
               <a:t>Click to edit Master text styles</a:t>
             </a:r>
           </a:p>
           <a:p>
             <a:pPr lvl="1"/>
             <a:r>
-              <a:rPr lang="en-US" smtClean="0"/>
+              <a:rPr lang="en-US"/>
               <a:t>Second level</a:t>
             </a:r>
           </a:p>
           <a:p>
             <a:pPr lvl="2"/>
             <a:r>
-              <a:rPr lang="en-US" smtClean="0"/>
+              <a:rPr lang="en-US"/>
               <a:t>Third level</a:t>
             </a:r>
           </a:p>
           <a:p>
             <a:pPr lvl="3"/>
             <a:r>
-              <a:rPr lang="en-US" smtClean="0"/>
+              <a:rPr lang="en-US"/>
               <a:t>Fourth level</a:t>
             </a:r>
           </a:p>
           <a:p>
             <a:pPr lvl="4"/>
             <a:r>
-              <a:rPr lang="en-US" smtClean="0"/>
+              <a:rPr lang="en-US"/>
               <a:t>Fifth level</a:t>
             </a:r>
-            <a:endParaRPr lang="en-US"/>
           </a:p>
         </p:txBody>
       </p:sp>
@@ -1668,7 +3110,7 @@
           <a:p>
             <a:pPr lvl="0"/>
             <a:r>
-              <a:rPr lang="en-US" smtClean="0"/>
+              <a:rPr lang="en-US"/>
               <a:t>Click to edit Master text styles</a:t>
             </a:r>
           </a:p>
@@ -1724,38 +3166,37 @@
           <a:p>
             <a:pPr lvl="0"/>
             <a:r>
-              <a:rPr lang="en-US" smtClean="0"/>
+              <a:rPr lang="en-US"/>
               <a:t>Click to edit Master text styles</a:t>
             </a:r>
           </a:p>
           <a:p>
             <a:pPr lvl="1"/>
             <a:r>
-              <a:rPr lang="en-US" smtClean="0"/>
+              <a:rPr lang="en-US"/>
               <a:t>Second level</a:t>
             </a:r>
           </a:p>
           <a:p>
             <a:pPr lvl="2"/>
             <a:r>
-              <a:rPr lang="en-US" smtClean="0"/>
+              <a:rPr lang="en-US"/>
               <a:t>Third level</a:t>
             </a:r>
           </a:p>
           <a:p>
             <a:pPr lvl="3"/>
             <a:r>
-              <a:rPr lang="en-US" smtClean="0"/>
+              <a:rPr lang="en-US"/>
               <a:t>Fourth level</a:t>
             </a:r>
           </a:p>
           <a:p>
             <a:pPr lvl="4"/>
             <a:r>
-              <a:rPr lang="en-US" smtClean="0"/>
+              <a:rPr lang="en-US"/>
               <a:t>Fifth level</a:t>
             </a:r>
-            <a:endParaRPr lang="en-US"/>
           </a:p>
         </p:txBody>
       </p:sp>
@@ -1776,7 +3217,7 @@
           <a:p>
             <a:fld id="{5BCAD085-E8A6-8845-BD4E-CB4CCA059FC4}" type="datetimeFigureOut">
               <a:rPr lang="en-US" smtClean="0"/>
-              <a:t>1/27/13</a:t>
+              <a:t>3/24/26</a:t>
             </a:fld>
             <a:endParaRPr lang="en-US"/>
           </a:p>
@@ -1870,10 +3311,9 @@
           <a:lstStyle/>
           <a:p>
             <a:r>
-              <a:rPr lang="en-US" smtClean="0"/>
+              <a:rPr lang="en-US"/>
               <a:t>Click to edit Master title style</a:t>
             </a:r>
-            <a:endParaRPr lang="en-US"/>
           </a:p>
         </p:txBody>
       </p:sp>
@@ -1894,7 +3334,7 @@
           <a:p>
             <a:fld id="{5BCAD085-E8A6-8845-BD4E-CB4CCA059FC4}" type="datetimeFigureOut">
               <a:rPr lang="en-US" smtClean="0"/>
-              <a:t>1/27/13</a:t>
+              <a:t>3/24/26</a:t>
             </a:fld>
             <a:endParaRPr lang="en-US"/>
           </a:p>
@@ -1989,7 +3429,7 @@
           <a:p>
             <a:fld id="{5BCAD085-E8A6-8845-BD4E-CB4CCA059FC4}" type="datetimeFigureOut">
               <a:rPr lang="en-US" smtClean="0"/>
-              <a:t>1/27/13</a:t>
+              <a:t>3/24/26</a:t>
             </a:fld>
             <a:endParaRPr lang="en-US"/>
           </a:p>
@@ -2092,10 +3532,9 @@
           </a:lstStyle>
           <a:p>
             <a:r>
-              <a:rPr lang="en-US" smtClean="0"/>
+              <a:rPr lang="en-US"/>
               <a:t>Click to edit Master title style</a:t>
             </a:r>
-            <a:endParaRPr lang="en-US"/>
           </a:p>
         </p:txBody>
       </p:sp>
@@ -2149,38 +3588,37 @@
           <a:p>
             <a:pPr lvl="0"/>
             <a:r>
-              <a:rPr lang="en-US" smtClean="0"/>
+              <a:rPr lang="en-US"/>
               <a:t>Click to edit Master text styles</a:t>
             </a:r>
           </a:p>
           <a:p>
             <a:pPr lvl="1"/>
             <a:r>
-              <a:rPr lang="en-US" smtClean="0"/>
+              <a:rPr lang="en-US"/>
               <a:t>Second level</a:t>
             </a:r>
           </a:p>
           <a:p>
             <a:pPr lvl="2"/>
             <a:r>
-              <a:rPr lang="en-US" smtClean="0"/>
+              <a:rPr lang="en-US"/>
               <a:t>Third level</a:t>
             </a:r>
           </a:p>
           <a:p>
             <a:pPr lvl="3"/>
             <a:r>
-              <a:rPr lang="en-US" smtClean="0"/>
+              <a:rPr lang="en-US"/>
               <a:t>Fourth level</a:t>
             </a:r>
           </a:p>
           <a:p>
             <a:pPr lvl="4"/>
             <a:r>
-              <a:rPr lang="en-US" smtClean="0"/>
+              <a:rPr lang="en-US"/>
               <a:t>Fifth level</a:t>
             </a:r>
-            <a:endParaRPr lang="en-US"/>
           </a:p>
         </p:txBody>
       </p:sp>
@@ -2243,7 +3681,7 @@
           <a:p>
             <a:pPr lvl="0"/>
             <a:r>
-              <a:rPr lang="en-US" smtClean="0"/>
+              <a:rPr lang="en-US"/>
               <a:t>Click to edit Master text styles</a:t>
             </a:r>
           </a:p>
@@ -2266,7 +3704,7 @@
           <a:p>
             <a:fld id="{5BCAD085-E8A6-8845-BD4E-CB4CCA059FC4}" type="datetimeFigureOut">
               <a:rPr lang="en-US" smtClean="0"/>
-              <a:t>1/27/13</a:t>
+              <a:t>3/24/26</a:t>
             </a:fld>
             <a:endParaRPr lang="en-US"/>
           </a:p>
@@ -2369,10 +3807,9 @@
           </a:lstStyle>
           <a:p>
             <a:r>
-              <a:rPr lang="en-US" smtClean="0"/>
+              <a:rPr lang="en-US"/>
               <a:t>Click to edit Master title style</a:t>
             </a:r>
-            <a:endParaRPr lang="en-US"/>
           </a:p>
         </p:txBody>
       </p:sp>
@@ -2496,7 +3933,7 @@
           <a:p>
             <a:pPr lvl="0"/>
             <a:r>
-              <a:rPr lang="en-US" smtClean="0"/>
+              <a:rPr lang="en-US"/>
               <a:t>Click to edit Master text styles</a:t>
             </a:r>
           </a:p>
@@ -2519,7 +3956,7 @@
           <a:p>
             <a:fld id="{5BCAD085-E8A6-8845-BD4E-CB4CCA059FC4}" type="datetimeFigureOut">
               <a:rPr lang="en-US" smtClean="0"/>
-              <a:t>1/27/13</a:t>
+              <a:t>3/24/26</a:t>
             </a:fld>
             <a:endParaRPr lang="en-US"/>
           </a:p>
@@ -2628,10 +4065,9 @@
           <a:lstStyle/>
           <a:p>
             <a:r>
-              <a:rPr lang="en-US" smtClean="0"/>
+              <a:rPr lang="en-US"/>
               <a:t>Click to edit Master title style</a:t>
             </a:r>
-            <a:endParaRPr lang="en-US"/>
           </a:p>
         </p:txBody>
       </p:sp>
@@ -2662,38 +4098,37 @@
           <a:p>
             <a:pPr lvl="0"/>
             <a:r>
-              <a:rPr lang="en-US" smtClean="0"/>
+              <a:rPr lang="en-US"/>
               <a:t>Click to edit Master text styles</a:t>
             </a:r>
           </a:p>
           <a:p>
             <a:pPr lvl="1"/>
             <a:r>
-              <a:rPr lang="en-US" smtClean="0"/>
+              <a:rPr lang="en-US"/>
               <a:t>Second level</a:t>
             </a:r>
           </a:p>
           <a:p>
             <a:pPr lvl="2"/>
             <a:r>
-              <a:rPr lang="en-US" smtClean="0"/>
+              <a:rPr lang="en-US"/>
               <a:t>Third level</a:t>
             </a:r>
           </a:p>
           <a:p>
             <a:pPr lvl="3"/>
             <a:r>
-              <a:rPr lang="en-US" smtClean="0"/>
+              <a:rPr lang="en-US"/>
               <a:t>Fourth level</a:t>
             </a:r>
           </a:p>
           <a:p>
             <a:pPr lvl="4"/>
             <a:r>
-              <a:rPr lang="en-US" smtClean="0"/>
+              <a:rPr lang="en-US"/>
               <a:t>Fifth level</a:t>
             </a:r>
-            <a:endParaRPr lang="en-US"/>
           </a:p>
         </p:txBody>
       </p:sp>
@@ -2732,7 +4167,7 @@
           <a:p>
             <a:fld id="{5BCAD085-E8A6-8845-BD4E-CB4CCA059FC4}" type="datetimeFigureOut">
               <a:rPr lang="en-US" smtClean="0"/>
-              <a:t>1/27/13</a:t>
+              <a:t>3/24/26</a:t>
             </a:fld>
             <a:endParaRPr lang="en-US"/>
           </a:p>
@@ -3091,7 +4526,7 @@
 </file>
 
 <file path=ppt/slides/slide1.xml><?xml version="1.0" encoding="utf-8"?>
-<p:sld xmlns:a="http://schemas.openxmlformats.org/drawingml/2006/main" xmlns:p="http://schemas.openxmlformats.org/presentationml/2006/main" xmlns:r="http://schemas.openxmlformats.org/officeDocument/2006/relationships">
+<p:sld xmlns:a="http://schemas.openxmlformats.org/drawingml/2006/main" xmlns:r="http://schemas.openxmlformats.org/officeDocument/2006/relationships" xmlns:p="http://schemas.openxmlformats.org/presentationml/2006/main">
   <p:cSld>
     <p:bg>
       <p:bgPr>
@@ -3107,7 +4542,14 @@
         <p:cNvGrpSpPr/>
         <p:nvPr/>
       </p:nvGrpSpPr>
-      <p:grpSpPr/>
+      <p:grpSpPr>
+        <a:xfrm>
+          <a:off x="0" y="0"/>
+          <a:ext cx="0" cy="0"/>
+          <a:chOff x="0" y="0"/>
+          <a:chExt cx="0" cy="0"/>
+        </a:xfrm>
+      </p:grpSpPr>
       <p:sp>
         <p:nvSpPr>
           <p:cNvPr id="2" name="TextBox 1"/>
@@ -3292,7 +4734,7 @@
 </file>
 
 <file path=ppt/slides/slide10.xml><?xml version="1.0" encoding="utf-8"?>
-<p:sld xmlns:a="http://schemas.openxmlformats.org/drawingml/2006/main" xmlns:p="http://schemas.openxmlformats.org/presentationml/2006/main" xmlns:r="http://schemas.openxmlformats.org/officeDocument/2006/relationships">
+<p:sld xmlns:a="http://schemas.openxmlformats.org/drawingml/2006/main" xmlns:r="http://schemas.openxmlformats.org/officeDocument/2006/relationships" xmlns:p="http://schemas.openxmlformats.org/presentationml/2006/main">
   <p:cSld>
     <p:bg>
       <p:bgPr>
@@ -3308,7 +4750,14 @@
         <p:cNvGrpSpPr/>
         <p:nvPr/>
       </p:nvGrpSpPr>
-      <p:grpSpPr/>
+      <p:grpSpPr>
+        <a:xfrm>
+          <a:off x="0" y="0"/>
+          <a:ext cx="0" cy="0"/>
+          <a:chOff x="0" y="0"/>
+          <a:chExt cx="0" cy="0"/>
+        </a:xfrm>
+      </p:grpSpPr>
       <p:sp>
         <p:nvSpPr>
           <p:cNvPr id="2" name="TextBox 1"/>
@@ -4263,7 +5712,7 @@
 </file>
 
 <file path=ppt/slides/slide11.xml><?xml version="1.0" encoding="utf-8"?>
-<p:sld xmlns:a="http://schemas.openxmlformats.org/drawingml/2006/main" xmlns:p="http://schemas.openxmlformats.org/presentationml/2006/main" xmlns:r="http://schemas.openxmlformats.org/officeDocument/2006/relationships">
+<p:sld xmlns:a="http://schemas.openxmlformats.org/drawingml/2006/main" xmlns:r="http://schemas.openxmlformats.org/officeDocument/2006/relationships" xmlns:p="http://schemas.openxmlformats.org/presentationml/2006/main">
   <p:cSld>
     <p:bg>
       <p:bgPr>
@@ -4279,7 +5728,14 @@
         <p:cNvGrpSpPr/>
         <p:nvPr/>
       </p:nvGrpSpPr>
-      <p:grpSpPr/>
+      <p:grpSpPr>
+        <a:xfrm>
+          <a:off x="0" y="0"/>
+          <a:ext cx="0" cy="0"/>
+          <a:chOff x="0" y="0"/>
+          <a:chExt cx="0" cy="0"/>
+        </a:xfrm>
+      </p:grpSpPr>
       <p:sp>
         <p:nvSpPr>
           <p:cNvPr id="2" name="TextBox 1"/>
@@ -4604,7 +6060,7 @@
 </file>
 
 <file path=ppt/slides/slide12.xml><?xml version="1.0" encoding="utf-8"?>
-<p:sld xmlns:a="http://schemas.openxmlformats.org/drawingml/2006/main" xmlns:p="http://schemas.openxmlformats.org/presentationml/2006/main" xmlns:r="http://schemas.openxmlformats.org/officeDocument/2006/relationships">
+<p:sld xmlns:a="http://schemas.openxmlformats.org/drawingml/2006/main" xmlns:r="http://schemas.openxmlformats.org/officeDocument/2006/relationships" xmlns:p="http://schemas.openxmlformats.org/presentationml/2006/main">
   <p:cSld>
     <p:bg>
       <p:bgPr>
@@ -4620,7 +6076,14 @@
         <p:cNvGrpSpPr/>
         <p:nvPr/>
       </p:nvGrpSpPr>
-      <p:grpSpPr/>
+      <p:grpSpPr>
+        <a:xfrm>
+          <a:off x="0" y="0"/>
+          <a:ext cx="0" cy="0"/>
+          <a:chOff x="0" y="0"/>
+          <a:chExt cx="0" cy="0"/>
+        </a:xfrm>
+      </p:grpSpPr>
       <p:sp>
         <p:nvSpPr>
           <p:cNvPr id="2" name="TextBox 1"/>
@@ -5015,7 +6478,7 @@
 </file>
 
 <file path=ppt/slides/slide13.xml><?xml version="1.0" encoding="utf-8"?>
-<p:sld xmlns:a="http://schemas.openxmlformats.org/drawingml/2006/main" xmlns:p="http://schemas.openxmlformats.org/presentationml/2006/main" xmlns:r="http://schemas.openxmlformats.org/officeDocument/2006/relationships">
+<p:sld xmlns:a="http://schemas.openxmlformats.org/drawingml/2006/main" xmlns:r="http://schemas.openxmlformats.org/officeDocument/2006/relationships" xmlns:p="http://schemas.openxmlformats.org/presentationml/2006/main">
   <p:cSld>
     <p:bg>
       <p:bgPr>
@@ -5031,7 +6494,14 @@
         <p:cNvGrpSpPr/>
         <p:nvPr/>
       </p:nvGrpSpPr>
-      <p:grpSpPr/>
+      <p:grpSpPr>
+        <a:xfrm>
+          <a:off x="0" y="0"/>
+          <a:ext cx="0" cy="0"/>
+          <a:chOff x="0" y="0"/>
+          <a:chExt cx="0" cy="0"/>
+        </a:xfrm>
+      </p:grpSpPr>
       <p:sp>
         <p:nvSpPr>
           <p:cNvPr id="2" name="TextBox 1"/>
@@ -5166,6 +6636,7 @@
                 </a:solidFill>
               </a:defRPr>
             </a:pPr>
+            <a:endParaRPr/>
           </a:p>
           <a:p>
             <a:pPr>
@@ -5223,7 +6694,7 @@
 </file>
 
 <file path=ppt/slides/slide2.xml><?xml version="1.0" encoding="utf-8"?>
-<p:sld xmlns:a="http://schemas.openxmlformats.org/drawingml/2006/main" xmlns:p="http://schemas.openxmlformats.org/presentationml/2006/main" xmlns:r="http://schemas.openxmlformats.org/officeDocument/2006/relationships">
+<p:sld xmlns:a="http://schemas.openxmlformats.org/drawingml/2006/main" xmlns:r="http://schemas.openxmlformats.org/officeDocument/2006/relationships" xmlns:p="http://schemas.openxmlformats.org/presentationml/2006/main">
   <p:cSld>
     <p:bg>
       <p:bgPr>
@@ -5239,7 +6710,14 @@
         <p:cNvGrpSpPr/>
         <p:nvPr/>
       </p:nvGrpSpPr>
-      <p:grpSpPr/>
+      <p:grpSpPr>
+        <a:xfrm>
+          <a:off x="0" y="0"/>
+          <a:ext cx="0" cy="0"/>
+          <a:chOff x="0" y="0"/>
+          <a:chExt cx="0" cy="0"/>
+        </a:xfrm>
+      </p:grpSpPr>
       <p:sp>
         <p:nvSpPr>
           <p:cNvPr id="2" name="TextBox 1"/>
@@ -5319,6 +6797,7 @@
                 </a:solidFill>
               </a:defRPr>
             </a:pPr>
+            <a:endParaRPr/>
           </a:p>
           <a:p>
             <a:pPr>
@@ -5376,6 +6855,7 @@
                 </a:solidFill>
               </a:defRPr>
             </a:pPr>
+            <a:endParaRPr/>
           </a:p>
           <a:p>
             <a:pPr>
@@ -5423,6 +6903,7 @@
                 </a:solidFill>
               </a:defRPr>
             </a:pPr>
+            <a:endParaRPr/>
           </a:p>
           <a:p>
             <a:pPr>
@@ -5450,6 +6931,7 @@
                 </a:solidFill>
               </a:defRPr>
             </a:pPr>
+            <a:endParaRPr/>
           </a:p>
           <a:p>
             <a:pPr>
@@ -5477,6 +6959,7 @@
                 </a:solidFill>
               </a:defRPr>
             </a:pPr>
+            <a:endParaRPr/>
           </a:p>
           <a:p>
             <a:pPr>
@@ -5504,6 +6987,7 @@
                 </a:solidFill>
               </a:defRPr>
             </a:pPr>
+            <a:endParaRPr/>
           </a:p>
           <a:p>
             <a:pPr>
@@ -5531,6 +7015,7 @@
                 </a:solidFill>
               </a:defRPr>
             </a:pPr>
+            <a:endParaRPr/>
           </a:p>
           <a:p>
             <a:pPr>
@@ -5593,7 +7078,7 @@
 </file>
 
 <file path=ppt/slides/slide3.xml><?xml version="1.0" encoding="utf-8"?>
-<p:sld xmlns:a="http://schemas.openxmlformats.org/drawingml/2006/main" xmlns:p="http://schemas.openxmlformats.org/presentationml/2006/main" xmlns:r="http://schemas.openxmlformats.org/officeDocument/2006/relationships">
+<p:sld xmlns:a="http://schemas.openxmlformats.org/drawingml/2006/main" xmlns:r="http://schemas.openxmlformats.org/officeDocument/2006/relationships" xmlns:p="http://schemas.openxmlformats.org/presentationml/2006/main">
   <p:cSld>
     <p:bg>
       <p:bgPr>
@@ -5609,7 +7094,14 @@
         <p:cNvGrpSpPr/>
         <p:nvPr/>
       </p:nvGrpSpPr>
-      <p:grpSpPr/>
+      <p:grpSpPr>
+        <a:xfrm>
+          <a:off x="0" y="0"/>
+          <a:ext cx="0" cy="0"/>
+          <a:chOff x="0" y="0"/>
+          <a:chExt cx="0" cy="0"/>
+        </a:xfrm>
+      </p:grpSpPr>
       <p:sp>
         <p:nvSpPr>
           <p:cNvPr id="2" name="TextBox 1"/>
@@ -5687,6 +7179,7 @@
           <a:lstStyle/>
           <a:p>
             <a:pPr algn="ctr"/>
+            <a:endParaRPr/>
           </a:p>
         </p:txBody>
       </p:sp>
@@ -5884,6 +7377,7 @@
           <a:lstStyle/>
           <a:p>
             <a:pPr algn="ctr"/>
+            <a:endParaRPr/>
           </a:p>
         </p:txBody>
       </p:sp>
@@ -6081,6 +7575,7 @@
           <a:lstStyle/>
           <a:p>
             <a:pPr algn="ctr"/>
+            <a:endParaRPr/>
           </a:p>
         </p:txBody>
       </p:sp>
@@ -6282,6 +7777,7 @@
           <a:lstStyle/>
           <a:p>
             <a:pPr algn="ctr"/>
+            <a:endParaRPr/>
           </a:p>
         </p:txBody>
       </p:sp>
@@ -6446,7 +7942,7 @@
 </file>
 
 <file path=ppt/slides/slide4.xml><?xml version="1.0" encoding="utf-8"?>
-<p:sld xmlns:a="http://schemas.openxmlformats.org/drawingml/2006/main" xmlns:p="http://schemas.openxmlformats.org/presentationml/2006/main" xmlns:r="http://schemas.openxmlformats.org/officeDocument/2006/relationships">
+<p:sld xmlns:a="http://schemas.openxmlformats.org/drawingml/2006/main" xmlns:r="http://schemas.openxmlformats.org/officeDocument/2006/relationships" xmlns:p="http://schemas.openxmlformats.org/presentationml/2006/main">
   <p:cSld>
     <p:bg>
       <p:bgPr>
@@ -6462,7 +7958,14 @@
         <p:cNvGrpSpPr/>
         <p:nvPr/>
       </p:nvGrpSpPr>
-      <p:grpSpPr/>
+      <p:grpSpPr>
+        <a:xfrm>
+          <a:off x="0" y="0"/>
+          <a:ext cx="0" cy="0"/>
+          <a:chOff x="0" y="0"/>
+          <a:chExt cx="0" cy="0"/>
+        </a:xfrm>
+      </p:grpSpPr>
       <p:sp>
         <p:nvSpPr>
           <p:cNvPr id="2" name="TextBox 1"/>
@@ -6807,6 +8310,7 @@
                 </a:solidFill>
               </a:defRPr>
             </a:pPr>
+            <a:endParaRPr/>
           </a:p>
           <a:p>
             <a:pPr>
@@ -6849,6 +8353,7 @@
                 </a:solidFill>
               </a:defRPr>
             </a:pPr>
+            <a:endParaRPr/>
           </a:p>
           <a:p>
             <a:pPr>
@@ -6876,7 +8381,7 @@
 </file>
 
 <file path=ppt/slides/slide5.xml><?xml version="1.0" encoding="utf-8"?>
-<p:sld xmlns:a="http://schemas.openxmlformats.org/drawingml/2006/main" xmlns:p="http://schemas.openxmlformats.org/presentationml/2006/main" xmlns:r="http://schemas.openxmlformats.org/officeDocument/2006/relationships">
+<p:sld xmlns:a="http://schemas.openxmlformats.org/drawingml/2006/main" xmlns:r="http://schemas.openxmlformats.org/officeDocument/2006/relationships" xmlns:p="http://schemas.openxmlformats.org/presentationml/2006/main">
   <p:cSld>
     <p:bg>
       <p:bgPr>
@@ -6892,7 +8397,14 @@
         <p:cNvGrpSpPr/>
         <p:nvPr/>
       </p:nvGrpSpPr>
-      <p:grpSpPr/>
+      <p:grpSpPr>
+        <a:xfrm>
+          <a:off x="0" y="0"/>
+          <a:ext cx="0" cy="0"/>
+          <a:chOff x="0" y="0"/>
+          <a:chExt cx="0" cy="0"/>
+        </a:xfrm>
+      </p:grpSpPr>
       <p:sp>
         <p:nvSpPr>
           <p:cNvPr id="2" name="TextBox 1"/>
@@ -6970,6 +8482,7 @@
           <a:lstStyle/>
           <a:p>
             <a:pPr algn="ctr"/>
+            <a:endParaRPr/>
           </a:p>
         </p:txBody>
       </p:sp>
@@ -7133,6 +8646,7 @@
           <a:lstStyle/>
           <a:p>
             <a:pPr algn="ctr"/>
+            <a:endParaRPr/>
           </a:p>
         </p:txBody>
       </p:sp>
@@ -7296,6 +8810,7 @@
           <a:lstStyle/>
           <a:p>
             <a:pPr algn="ctr"/>
+            <a:endParaRPr/>
           </a:p>
         </p:txBody>
       </p:sp>
@@ -7461,7 +8976,7 @@
 </file>
 
 <file path=ppt/slides/slide6.xml><?xml version="1.0" encoding="utf-8"?>
-<p:sld xmlns:a="http://schemas.openxmlformats.org/drawingml/2006/main" xmlns:p="http://schemas.openxmlformats.org/presentationml/2006/main" xmlns:r="http://schemas.openxmlformats.org/officeDocument/2006/relationships">
+<p:sld xmlns:a="http://schemas.openxmlformats.org/drawingml/2006/main" xmlns:r="http://schemas.openxmlformats.org/officeDocument/2006/relationships" xmlns:p="http://schemas.openxmlformats.org/presentationml/2006/main">
   <p:cSld>
     <p:bg>
       <p:bgPr>
@@ -7477,7 +8992,14 @@
         <p:cNvGrpSpPr/>
         <p:nvPr/>
       </p:nvGrpSpPr>
-      <p:grpSpPr/>
+      <p:grpSpPr>
+        <a:xfrm>
+          <a:off x="0" y="0"/>
+          <a:ext cx="0" cy="0"/>
+          <a:chOff x="0" y="0"/>
+          <a:chExt cx="0" cy="0"/>
+        </a:xfrm>
+      </p:grpSpPr>
       <p:sp>
         <p:nvSpPr>
           <p:cNvPr id="2" name="TextBox 1"/>
@@ -7590,6 +9112,7 @@
           <a:lstStyle/>
           <a:p>
             <a:pPr algn="ctr"/>
+            <a:endParaRPr/>
           </a:p>
         </p:txBody>
       </p:sp>
@@ -7637,6 +9160,7 @@
                 </a:solidFill>
               </a:defRPr>
             </a:pPr>
+            <a:endParaRPr/>
           </a:p>
           <a:p>
             <a:pPr>
@@ -7664,6 +9188,7 @@
                 </a:solidFill>
               </a:defRPr>
             </a:pPr>
+            <a:endParaRPr/>
           </a:p>
           <a:p>
             <a:pPr>
@@ -7691,6 +9216,7 @@
                 </a:solidFill>
               </a:defRPr>
             </a:pPr>
+            <a:endParaRPr/>
           </a:p>
           <a:p>
             <a:pPr>
@@ -7751,6 +9277,7 @@
           <a:lstStyle/>
           <a:p>
             <a:pPr algn="ctr"/>
+            <a:endParaRPr/>
           </a:p>
         </p:txBody>
       </p:sp>
@@ -7798,6 +9325,7 @@
                 </a:solidFill>
               </a:defRPr>
             </a:pPr>
+            <a:endParaRPr/>
           </a:p>
           <a:p>
             <a:pPr>
@@ -7825,6 +9353,7 @@
                 </a:solidFill>
               </a:defRPr>
             </a:pPr>
+            <a:endParaRPr/>
           </a:p>
           <a:p>
             <a:pPr>
@@ -7852,6 +9381,7 @@
                 </a:solidFill>
               </a:defRPr>
             </a:pPr>
+            <a:endParaRPr/>
           </a:p>
           <a:p>
             <a:pPr>
@@ -7912,6 +9442,7 @@
           <a:lstStyle/>
           <a:p>
             <a:pPr algn="ctr"/>
+            <a:endParaRPr/>
           </a:p>
         </p:txBody>
       </p:sp>
@@ -7959,6 +9490,7 @@
                 </a:solidFill>
               </a:defRPr>
             </a:pPr>
+            <a:endParaRPr/>
           </a:p>
           <a:p>
             <a:pPr>
@@ -7986,6 +9518,7 @@
                 </a:solidFill>
               </a:defRPr>
             </a:pPr>
+            <a:endParaRPr/>
           </a:p>
           <a:p>
             <a:pPr>
@@ -8013,6 +9546,7 @@
                 </a:solidFill>
               </a:defRPr>
             </a:pPr>
+            <a:endParaRPr/>
           </a:p>
           <a:p>
             <a:pPr>
@@ -8110,7 +9644,7 @@
 </file>
 
 <file path=ppt/slides/slide7.xml><?xml version="1.0" encoding="utf-8"?>
-<p:sld xmlns:a="http://schemas.openxmlformats.org/drawingml/2006/main" xmlns:p="http://schemas.openxmlformats.org/presentationml/2006/main" xmlns:r="http://schemas.openxmlformats.org/officeDocument/2006/relationships">
+<p:sld xmlns:a="http://schemas.openxmlformats.org/drawingml/2006/main" xmlns:r="http://schemas.openxmlformats.org/officeDocument/2006/relationships" xmlns:p="http://schemas.openxmlformats.org/presentationml/2006/main">
   <p:cSld>
     <p:bg>
       <p:bgPr>
@@ -8126,7 +9660,14 @@
         <p:cNvGrpSpPr/>
         <p:nvPr/>
       </p:nvGrpSpPr>
-      <p:grpSpPr/>
+      <p:grpSpPr>
+        <a:xfrm>
+          <a:off x="0" y="0"/>
+          <a:ext cx="0" cy="0"/>
+          <a:chOff x="0" y="0"/>
+          <a:chExt cx="0" cy="0"/>
+        </a:xfrm>
+      </p:grpSpPr>
       <p:sp>
         <p:nvSpPr>
           <p:cNvPr id="2" name="TextBox 1"/>
@@ -8157,6 +9698,7 @@
               </a:defRPr>
             </a:pPr>
             <a:r>
+              <a:rPr dirty="0"/>
               <a:t>Method B: RSI-LCR — Why, What It Solved, Why It Fell Short</a:t>
             </a:r>
           </a:p>
@@ -8170,7 +9712,7 @@
         </p:nvSpPr>
         <p:spPr>
           <a:xfrm>
-            <a:off x="731520" y="777240"/>
+            <a:off x="731520" y="691243"/>
             <a:ext cx="7315200" cy="320040"/>
           </a:xfrm>
           <a:prstGeom prst="rect">
@@ -8192,6 +9734,7 @@
               </a:defRPr>
             </a:pPr>
             <a:r>
+              <a:rPr dirty="0"/>
               <a:t>RELATION-SIGNATURE INDUCTION + LLM COHERENCE REFINEMENT</a:t>
             </a:r>
           </a:p>
@@ -8239,6 +9782,7 @@
           <a:lstStyle/>
           <a:p>
             <a:pPr algn="ctr"/>
+            <a:endParaRPr/>
           </a:p>
         </p:txBody>
       </p:sp>
@@ -8286,6 +9830,7 @@
                 </a:solidFill>
               </a:defRPr>
             </a:pPr>
+            <a:endParaRPr/>
           </a:p>
           <a:p>
             <a:pPr>
@@ -8313,6 +9858,7 @@
                 </a:solidFill>
               </a:defRPr>
             </a:pPr>
+            <a:endParaRPr/>
           </a:p>
           <a:p>
             <a:pPr>
@@ -8340,6 +9886,7 @@
                 </a:solidFill>
               </a:defRPr>
             </a:pPr>
+            <a:endParaRPr/>
           </a:p>
           <a:p>
             <a:pPr>
@@ -8404,6 +9951,7 @@
           <a:lstStyle/>
           <a:p>
             <a:pPr algn="ctr"/>
+            <a:endParaRPr/>
           </a:p>
         </p:txBody>
       </p:sp>
@@ -8451,6 +9999,7 @@
                 </a:solidFill>
               </a:defRPr>
             </a:pPr>
+            <a:endParaRPr/>
           </a:p>
           <a:p>
             <a:pPr>
@@ -8478,6 +10027,7 @@
                 </a:solidFill>
               </a:defRPr>
             </a:pPr>
+            <a:endParaRPr/>
           </a:p>
           <a:p>
             <a:pPr>
@@ -8520,6 +10070,7 @@
                 </a:solidFill>
               </a:defRPr>
             </a:pPr>
+            <a:endParaRPr/>
           </a:p>
           <a:p>
             <a:pPr>
@@ -8580,6 +10131,7 @@
           <a:lstStyle/>
           <a:p>
             <a:pPr algn="ctr"/>
+            <a:endParaRPr/>
           </a:p>
         </p:txBody>
       </p:sp>
@@ -8613,6 +10165,7 @@
               </a:defRPr>
             </a:pPr>
             <a:r>
+              <a:rPr dirty="0"/>
               <a:t>WHY it fell short</a:t>
             </a:r>
           </a:p>
@@ -8627,6 +10180,7 @@
                 </a:solidFill>
               </a:defRPr>
             </a:pPr>
+            <a:endParaRPr dirty="0"/>
           </a:p>
           <a:p>
             <a:pPr>
@@ -8640,6 +10194,7 @@
               </a:defRPr>
             </a:pPr>
             <a:r>
+              <a:rPr dirty="0"/>
               <a:t>Over-fragments: 30 clusters (too many)</a:t>
             </a:r>
           </a:p>
@@ -8654,6 +10209,7 @@
                 </a:solidFill>
               </a:defRPr>
             </a:pPr>
+            <a:endParaRPr dirty="0"/>
           </a:p>
           <a:p>
             <a:pPr>
@@ -8667,6 +10223,7 @@
               </a:defRPr>
             </a:pPr>
             <a:r>
+              <a:rPr dirty="0"/>
               <a:t>Dense graph → signatures overlap</a:t>
             </a:r>
           </a:p>
@@ -8681,6 +10238,7 @@
                 </a:solidFill>
               </a:defRPr>
             </a:pPr>
+            <a:endParaRPr dirty="0"/>
           </a:p>
           <a:p>
             <a:pPr>
@@ -8694,6 +10252,7 @@
               </a:defRPr>
             </a:pPr>
             <a:r>
+              <a:rPr dirty="0"/>
               <a:t>Structural signal alone can't distinguish ontological types</a:t>
             </a:r>
           </a:p>
@@ -8778,7 +10337,7 @@
 </file>
 
 <file path=ppt/slides/slide8.xml><?xml version="1.0" encoding="utf-8"?>
-<p:sld xmlns:a="http://schemas.openxmlformats.org/drawingml/2006/main" xmlns:p="http://schemas.openxmlformats.org/presentationml/2006/main" xmlns:r="http://schemas.openxmlformats.org/officeDocument/2006/relationships">
+<p:sld xmlns:a="http://schemas.openxmlformats.org/drawingml/2006/main" xmlns:r="http://schemas.openxmlformats.org/officeDocument/2006/relationships" xmlns:p="http://schemas.openxmlformats.org/presentationml/2006/main">
   <p:cSld>
     <p:bg>
       <p:bgPr>
@@ -8794,7 +10353,14 @@
         <p:cNvGrpSpPr/>
         <p:nvPr/>
       </p:nvGrpSpPr>
-      <p:grpSpPr/>
+      <p:grpSpPr>
+        <a:xfrm>
+          <a:off x="0" y="0"/>
+          <a:ext cx="0" cy="0"/>
+          <a:chOff x="0" y="0"/>
+          <a:chExt cx="0" cy="0"/>
+        </a:xfrm>
+      </p:grpSpPr>
       <p:sp>
         <p:nvSpPr>
           <p:cNvPr id="2" name="TextBox 1"/>
@@ -8907,6 +10473,7 @@
           <a:lstStyle/>
           <a:p>
             <a:pPr algn="ctr"/>
+            <a:endParaRPr/>
           </a:p>
         </p:txBody>
       </p:sp>
@@ -8954,6 +10521,7 @@
                 </a:solidFill>
               </a:defRPr>
             </a:pPr>
+            <a:endParaRPr/>
           </a:p>
           <a:p>
             <a:pPr>
@@ -8996,6 +10564,7 @@
                 </a:solidFill>
               </a:defRPr>
             </a:pPr>
+            <a:endParaRPr/>
           </a:p>
           <a:p>
             <a:pPr>
@@ -9023,6 +10592,7 @@
                 </a:solidFill>
               </a:defRPr>
             </a:pPr>
+            <a:endParaRPr/>
           </a:p>
           <a:p>
             <a:pPr>
@@ -9083,6 +10653,7 @@
           <a:lstStyle/>
           <a:p>
             <a:pPr algn="ctr"/>
+            <a:endParaRPr/>
           </a:p>
         </p:txBody>
       </p:sp>
@@ -9130,6 +10701,7 @@
                 </a:solidFill>
               </a:defRPr>
             </a:pPr>
+            <a:endParaRPr/>
           </a:p>
           <a:p>
             <a:pPr>
@@ -9265,6 +10837,7 @@
           <a:lstStyle/>
           <a:p>
             <a:pPr algn="ctr"/>
+            <a:endParaRPr/>
           </a:p>
         </p:txBody>
       </p:sp>
@@ -9312,6 +10885,7 @@
                 </a:solidFill>
               </a:defRPr>
             </a:pPr>
+            <a:endParaRPr/>
           </a:p>
           <a:p>
             <a:pPr>
@@ -9369,6 +10943,7 @@
                 </a:solidFill>
               </a:defRPr>
             </a:pPr>
+            <a:endParaRPr/>
           </a:p>
           <a:p>
             <a:pPr>
@@ -9481,7 +11056,7 @@
 </file>
 
 <file path=ppt/slides/slide9.xml><?xml version="1.0" encoding="utf-8"?>
-<p:sld xmlns:a="http://schemas.openxmlformats.org/drawingml/2006/main" xmlns:p="http://schemas.openxmlformats.org/presentationml/2006/main" xmlns:r="http://schemas.openxmlformats.org/officeDocument/2006/relationships">
+<p:sld xmlns:a="http://schemas.openxmlformats.org/drawingml/2006/main" xmlns:r="http://schemas.openxmlformats.org/officeDocument/2006/relationships" xmlns:p="http://schemas.openxmlformats.org/presentationml/2006/main">
   <p:cSld>
     <p:bg>
       <p:bgPr>
@@ -9497,7 +11072,14 @@
         <p:cNvGrpSpPr/>
         <p:nvPr/>
       </p:nvGrpSpPr>
-      <p:grpSpPr/>
+      <p:grpSpPr>
+        <a:xfrm>
+          <a:off x="0" y="0"/>
+          <a:ext cx="0" cy="0"/>
+          <a:chOff x="0" y="0"/>
+          <a:chExt cx="0" cy="0"/>
+        </a:xfrm>
+      </p:grpSpPr>
       <p:sp>
         <p:nvSpPr>
           <p:cNvPr id="2" name="TextBox 1"/>
@@ -10909,4 +12491,324 @@
   </a:objectDefaults>
   <a:extraClrSchemeLst/>
 </a:theme>
+</file>
+
+<file path=ppt/theme/theme2.xml><?xml version="1.0" encoding="utf-8"?>
+<a:theme xmlns:a="http://schemas.openxmlformats.org/drawingml/2006/main" name="Office Theme">
+  <a:themeElements>
+    <a:clrScheme name="Office">
+      <a:dk1>
+        <a:sysClr val="windowText" lastClr="000000"/>
+      </a:dk1>
+      <a:lt1>
+        <a:sysClr val="window" lastClr="FFFFFF"/>
+      </a:lt1>
+      <a:dk2>
+        <a:srgbClr val="1F497D"/>
+      </a:dk2>
+      <a:lt2>
+        <a:srgbClr val="EEECE1"/>
+      </a:lt2>
+      <a:accent1>
+        <a:srgbClr val="4F81BD"/>
+      </a:accent1>
+      <a:accent2>
+        <a:srgbClr val="C0504D"/>
+      </a:accent2>
+      <a:accent3>
+        <a:srgbClr val="9BBB59"/>
+      </a:accent3>
+      <a:accent4>
+        <a:srgbClr val="8064A2"/>
+      </a:accent4>
+      <a:accent5>
+        <a:srgbClr val="4BACC6"/>
+      </a:accent5>
+      <a:accent6>
+        <a:srgbClr val="F79646"/>
+      </a:accent6>
+      <a:hlink>
+        <a:srgbClr val="0000FF"/>
+      </a:hlink>
+      <a:folHlink>
+        <a:srgbClr val="800080"/>
+      </a:folHlink>
+    </a:clrScheme>
+    <a:fontScheme name="Office">
+      <a:majorFont>
+        <a:latin typeface="Calibri"/>
+        <a:ea typeface=""/>
+        <a:cs typeface=""/>
+        <a:font script="Jpan" typeface="ＭＳ Ｐゴシック"/>
+        <a:font script="Hang" typeface="맑은 고딕"/>
+        <a:font script="Hans" typeface="宋体"/>
+        <a:font script="Hant" typeface="新細明體"/>
+        <a:font script="Arab" typeface="Times New Roman"/>
+        <a:font script="Hebr" typeface="Times New Roman"/>
+        <a:font script="Thai" typeface="Angsana New"/>
+        <a:font script="Ethi" typeface="Nyala"/>
+        <a:font script="Beng" typeface="Vrinda"/>
+        <a:font script="Gujr" typeface="Shruti"/>
+        <a:font script="Khmr" typeface="MoolBoran"/>
+        <a:font script="Knda" typeface="Tunga"/>
+        <a:font script="Guru" typeface="Raavi"/>
+        <a:font script="Cans" typeface="Euphemia"/>
+        <a:font script="Cher" typeface="Plantagenet Cherokee"/>
+        <a:font script="Yiii" typeface="Microsoft Yi Baiti"/>
+        <a:font script="Tibt" typeface="Microsoft Himalaya"/>
+        <a:font script="Thaa" typeface="MV Boli"/>
+        <a:font script="Deva" typeface="Mangal"/>
+        <a:font script="Telu" typeface="Gautami"/>
+        <a:font script="Taml" typeface="Latha"/>
+        <a:font script="Syrc" typeface="Estrangelo Edessa"/>
+        <a:font script="Orya" typeface="Kalinga"/>
+        <a:font script="Mlym" typeface="Kartika"/>
+        <a:font script="Laoo" typeface="DokChampa"/>
+        <a:font script="Sinh" typeface="Iskoola Pota"/>
+        <a:font script="Mong" typeface="Mongolian Baiti"/>
+        <a:font script="Viet" typeface="Times New Roman"/>
+        <a:font script="Uigh" typeface="Microsoft Uighur"/>
+        <a:font script="Geor" typeface="Sylfaen"/>
+      </a:majorFont>
+      <a:minorFont>
+        <a:latin typeface="Calibri"/>
+        <a:ea typeface=""/>
+        <a:cs typeface=""/>
+        <a:font script="Jpan" typeface="ＭＳ Ｐゴシック"/>
+        <a:font script="Hang" typeface="맑은 고딕"/>
+        <a:font script="Hans" typeface="宋体"/>
+        <a:font script="Hant" typeface="新細明體"/>
+        <a:font script="Arab" typeface="Arial"/>
+        <a:font script="Hebr" typeface="Arial"/>
+        <a:font script="Thai" typeface="Cordia New"/>
+        <a:font script="Ethi" typeface="Nyala"/>
+        <a:font script="Beng" typeface="Vrinda"/>
+        <a:font script="Gujr" typeface="Shruti"/>
+        <a:font script="Khmr" typeface="DaunPenh"/>
+        <a:font script="Knda" typeface="Tunga"/>
+        <a:font script="Guru" typeface="Raavi"/>
+        <a:font script="Cans" typeface="Euphemia"/>
+        <a:font script="Cher" typeface="Plantagenet Cherokee"/>
+        <a:font script="Yiii" typeface="Microsoft Yi Baiti"/>
+        <a:font script="Tibt" typeface="Microsoft Himalaya"/>
+        <a:font script="Thaa" typeface="MV Boli"/>
+        <a:font script="Deva" typeface="Mangal"/>
+        <a:font script="Telu" typeface="Gautami"/>
+        <a:font script="Taml" typeface="Latha"/>
+        <a:font script="Syrc" typeface="Estrangelo Edessa"/>
+        <a:font script="Orya" typeface="Kalinga"/>
+        <a:font script="Mlym" typeface="Kartika"/>
+        <a:font script="Laoo" typeface="DokChampa"/>
+        <a:font script="Sinh" typeface="Iskoola Pota"/>
+        <a:font script="Mong" typeface="Mongolian Baiti"/>
+        <a:font script="Viet" typeface="Arial"/>
+        <a:font script="Uigh" typeface="Microsoft Uighur"/>
+        <a:font script="Geor" typeface="Sylfaen"/>
+      </a:minorFont>
+    </a:fontScheme>
+    <a:fmtScheme name="Office">
+      <a:fillStyleLst>
+        <a:solidFill>
+          <a:schemeClr val="phClr"/>
+        </a:solidFill>
+        <a:gradFill rotWithShape="1">
+          <a:gsLst>
+            <a:gs pos="0">
+              <a:schemeClr val="phClr">
+                <a:tint val="50000"/>
+                <a:satMod val="300000"/>
+              </a:schemeClr>
+            </a:gs>
+            <a:gs pos="35000">
+              <a:schemeClr val="phClr">
+                <a:tint val="37000"/>
+                <a:satMod val="300000"/>
+              </a:schemeClr>
+            </a:gs>
+            <a:gs pos="100000">
+              <a:schemeClr val="phClr">
+                <a:tint val="15000"/>
+                <a:satMod val="350000"/>
+              </a:schemeClr>
+            </a:gs>
+          </a:gsLst>
+          <a:lin ang="16200000" scaled="1"/>
+        </a:gradFill>
+        <a:gradFill rotWithShape="1">
+          <a:gsLst>
+            <a:gs pos="0">
+              <a:schemeClr val="phClr">
+                <a:tint val="100000"/>
+                <a:shade val="100000"/>
+                <a:satMod val="130000"/>
+              </a:schemeClr>
+            </a:gs>
+            <a:gs pos="100000">
+              <a:schemeClr val="phClr">
+                <a:tint val="50000"/>
+                <a:shade val="100000"/>
+                <a:satMod val="350000"/>
+              </a:schemeClr>
+            </a:gs>
+          </a:gsLst>
+          <a:lin ang="16200000" scaled="0"/>
+        </a:gradFill>
+      </a:fillStyleLst>
+      <a:lnStyleLst>
+        <a:ln w="9525" cap="flat" cmpd="sng" algn="ctr">
+          <a:solidFill>
+            <a:schemeClr val="phClr">
+              <a:shade val="95000"/>
+              <a:satMod val="105000"/>
+            </a:schemeClr>
+          </a:solidFill>
+          <a:prstDash val="solid"/>
+        </a:ln>
+        <a:ln w="25400" cap="flat" cmpd="sng" algn="ctr">
+          <a:solidFill>
+            <a:schemeClr val="phClr"/>
+          </a:solidFill>
+          <a:prstDash val="solid"/>
+        </a:ln>
+        <a:ln w="38100" cap="flat" cmpd="sng" algn="ctr">
+          <a:solidFill>
+            <a:schemeClr val="phClr"/>
+          </a:solidFill>
+          <a:prstDash val="solid"/>
+        </a:ln>
+      </a:lnStyleLst>
+      <a:effectStyleLst>
+        <a:effectStyle>
+          <a:effectLst>
+            <a:outerShdw blurRad="40000" dist="20000" dir="5400000" rotWithShape="0">
+              <a:srgbClr val="000000">
+                <a:alpha val="38000"/>
+              </a:srgbClr>
+            </a:outerShdw>
+          </a:effectLst>
+        </a:effectStyle>
+        <a:effectStyle>
+          <a:effectLst>
+            <a:outerShdw blurRad="40000" dist="23000" dir="5400000" rotWithShape="0">
+              <a:srgbClr val="000000">
+                <a:alpha val="35000"/>
+              </a:srgbClr>
+            </a:outerShdw>
+          </a:effectLst>
+        </a:effectStyle>
+        <a:effectStyle>
+          <a:effectLst>
+            <a:outerShdw blurRad="40000" dist="23000" dir="5400000" rotWithShape="0">
+              <a:srgbClr val="000000">
+                <a:alpha val="35000"/>
+              </a:srgbClr>
+            </a:outerShdw>
+          </a:effectLst>
+          <a:scene3d>
+            <a:camera prst="orthographicFront">
+              <a:rot lat="0" lon="0" rev="0"/>
+            </a:camera>
+            <a:lightRig rig="threePt" dir="t">
+              <a:rot lat="0" lon="0" rev="1200000"/>
+            </a:lightRig>
+          </a:scene3d>
+          <a:sp3d>
+            <a:bevelT w="63500" h="25400"/>
+          </a:sp3d>
+        </a:effectStyle>
+      </a:effectStyleLst>
+      <a:bgFillStyleLst>
+        <a:solidFill>
+          <a:schemeClr val="phClr"/>
+        </a:solidFill>
+        <a:gradFill rotWithShape="1">
+          <a:gsLst>
+            <a:gs pos="0">
+              <a:schemeClr val="phClr">
+                <a:tint val="40000"/>
+                <a:satMod val="350000"/>
+              </a:schemeClr>
+            </a:gs>
+            <a:gs pos="40000">
+              <a:schemeClr val="phClr">
+                <a:tint val="45000"/>
+                <a:shade val="99000"/>
+                <a:satMod val="350000"/>
+              </a:schemeClr>
+            </a:gs>
+            <a:gs pos="100000">
+              <a:schemeClr val="phClr">
+                <a:shade val="20000"/>
+                <a:satMod val="255000"/>
+              </a:schemeClr>
+            </a:gs>
+          </a:gsLst>
+          <a:path path="circle">
+            <a:fillToRect l="50000" t="-80000" r="50000" b="180000"/>
+          </a:path>
+        </a:gradFill>
+        <a:gradFill rotWithShape="1">
+          <a:gsLst>
+            <a:gs pos="0">
+              <a:schemeClr val="phClr">
+                <a:tint val="80000"/>
+                <a:satMod val="300000"/>
+              </a:schemeClr>
+            </a:gs>
+            <a:gs pos="100000">
+              <a:schemeClr val="phClr">
+                <a:shade val="30000"/>
+                <a:satMod val="200000"/>
+              </a:schemeClr>
+            </a:gs>
+          </a:gsLst>
+          <a:path path="circle">
+            <a:fillToRect l="50000" t="50000" r="50000" b="50000"/>
+          </a:path>
+        </a:gradFill>
+      </a:bgFillStyleLst>
+    </a:fmtScheme>
+  </a:themeElements>
+  <a:objectDefaults>
+    <a:spDef>
+      <a:spPr/>
+      <a:bodyPr/>
+      <a:lstStyle/>
+      <a:style>
+        <a:lnRef idx="1">
+          <a:schemeClr val="accent1"/>
+        </a:lnRef>
+        <a:fillRef idx="3">
+          <a:schemeClr val="accent1"/>
+        </a:fillRef>
+        <a:effectRef idx="2">
+          <a:schemeClr val="accent1"/>
+        </a:effectRef>
+        <a:fontRef idx="minor">
+          <a:schemeClr val="lt1"/>
+        </a:fontRef>
+      </a:style>
+    </a:spDef>
+    <a:lnDef>
+      <a:spPr/>
+      <a:bodyPr/>
+      <a:lstStyle/>
+      <a:style>
+        <a:lnRef idx="2">
+          <a:schemeClr val="accent1"/>
+        </a:lnRef>
+        <a:fillRef idx="0">
+          <a:schemeClr val="accent1"/>
+        </a:fillRef>
+        <a:effectRef idx="1">
+          <a:schemeClr val="accent1"/>
+        </a:effectRef>
+        <a:fontRef idx="minor">
+          <a:schemeClr val="tx1"/>
+        </a:fontRef>
+      </a:style>
+    </a:lnDef>
+  </a:objectDefaults>
+  <a:extraClrSchemeLst/>
+</a:theme>
 </file>
</xml_diff>

<commit_message>
refactor: reorganize scripts and results directory
Scripts:
- 4 focused SLURM scripts: slurm_pipeline.sh, slurm_zone2.sh,
  slurm_zone3.sh, slurm_eval.sh (all support DATA_DIR, JUDGE_MODEL)
- Shared env in scripts/_env.sh (auto-derives RESULTS_DIR from DATA_DIR)
- 8 old scripts archived to scripts/archive/
- run_on_cluster.sh updated with --mode, --data, --judge flags

Results:
- Flat data/results/ (84 files) reorganized into:
  data/results/flood/ (77 files), data/results/emory/ (3 files),
  data/results/visualizations/ (4 files)
- config.RESULTS_DIR updated to data/results/flood

Cleanup:
- 10 stale git worktrees removed (~150MB freed)
</commit_message>
<xml_diff>
--- a/docs/CS584_Midterm_Presentation.pptx
+++ b/docs/CS584_Midterm_Presentation.pptx
@@ -4,23 +4,26 @@
   <p:sldMasterIdLst>
     <p:sldMasterId id="2147483648" r:id="rId1"/>
   </p:sldMasterIdLst>
+  <p:notesMasterIdLst>
+    <p:notesMasterId r:id="rId16"/>
+  </p:notesMasterIdLst>
   <p:sldIdLst>
-    <p:sldId id="256" r:id="rId7"/>
-    <p:sldId id="257" r:id="rId9"/>
-    <p:sldId id="258" r:id="rId10"/>
-    <p:sldId id="259" r:id="rId11"/>
-    <p:sldId id="260" r:id="rId12"/>
-    <p:sldId id="261" r:id="rId13"/>
-    <p:sldId id="262" r:id="rId14"/>
-    <p:sldId id="263" r:id="rId15"/>
-    <p:sldId id="264" r:id="rId16"/>
-    <p:sldId id="265" r:id="rId17"/>
-    <p:sldId id="266" r:id="rId18"/>
-    <p:sldId id="267" r:id="rId19"/>
-    <p:sldId id="268" r:id="rId20"/>
-    <p:sldId id="269" r:id="rId21"/>
+    <p:sldId id="256" r:id="rId2"/>
+    <p:sldId id="257" r:id="rId3"/>
+    <p:sldId id="258" r:id="rId4"/>
+    <p:sldId id="259" r:id="rId5"/>
+    <p:sldId id="260" r:id="rId6"/>
+    <p:sldId id="261" r:id="rId7"/>
+    <p:sldId id="262" r:id="rId8"/>
+    <p:sldId id="263" r:id="rId9"/>
+    <p:sldId id="264" r:id="rId10"/>
+    <p:sldId id="265" r:id="rId11"/>
+    <p:sldId id="266" r:id="rId12"/>
+    <p:sldId id="267" r:id="rId13"/>
+    <p:sldId id="268" r:id="rId14"/>
+    <p:sldId id="269" r:id="rId15"/>
   </p:sldIdLst>
-  <p:sldSz cx="12191695" cy="6858000" type="screen4x3"/>
+  <p:sldSz cx="12192000" cy="6858000"/>
   <p:notesSz cx="6858000" cy="9144000"/>
   <p:defaultTextStyle>
     <a:defPPr>
@@ -117,11 +120,27 @@
       </a:defRPr>
     </a:lvl9pPr>
   </p:defaultTextStyle>
+  <p:extLst>
+    <p:ext uri="{EFAFB233-063F-42B5-8137-9DF3F51BA10A}">
+      <p15:sldGuideLst xmlns:p15="http://schemas.microsoft.com/office/powerpoint/2012/main">
+        <p15:guide id="1" orient="horz" pos="2160">
+          <p15:clr>
+            <a:srgbClr val="A4A3A4"/>
+          </p15:clr>
+        </p15:guide>
+        <p15:guide id="2" pos="2880">
+          <p15:clr>
+            <a:srgbClr val="A4A3A4"/>
+          </p15:clr>
+        </p15:guide>
+      </p15:sldGuideLst>
+    </p:ext>
+  </p:extLst>
 </p:presentation>
 </file>
 
 <file path=ppt/notesMasters/notesMaster1.xml><?xml version="1.0" encoding="utf-8"?>
-<p:notesMaster xmlns:a="http://schemas.openxmlformats.org/drawingml/2006/main" xmlns:p="http://schemas.openxmlformats.org/presentationml/2006/main" xmlns:r="http://schemas.openxmlformats.org/officeDocument/2006/relationships">
+<p:notesMaster xmlns:a="http://schemas.openxmlformats.org/drawingml/2006/main" xmlns:r="http://schemas.openxmlformats.org/officeDocument/2006/relationships" xmlns:p="http://schemas.openxmlformats.org/presentationml/2006/main">
   <p:cSld>
     <p:bg>
       <p:bgRef idx="1001">
@@ -142,241 +161,16 @@
           <a:chExt cx="0" cy="0"/>
         </a:xfrm>
       </p:grpSpPr>
-      <p:sp>
-        <p:nvSpPr>
-          <p:cNvPr id="2" name="Header Placeholder 1"/>
-          <p:cNvSpPr>
-            <a:spLocks noGrp="1"/>
-          </p:cNvSpPr>
-          <p:nvPr>
-            <p:ph type="hdr" sz="quarter"/>
-          </p:nvPr>
-        </p:nvSpPr>
-        <p:spPr>
-          <a:xfrm>
-            <a:off x="0" y="0"/>
-            <a:ext cx="2971800" cy="457200"/>
-          </a:xfrm>
-          <a:prstGeom prst="rect">
-            <a:avLst/>
-          </a:prstGeom>
-        </p:spPr>
-        <p:txBody>
-          <a:bodyPr vert="horz" lIns="91440" tIns="45720" rIns="91440" bIns="45720" rtlCol="0"/>
-          <a:lstStyle>
-            <a:lvl1pPr algn="l">
-              <a:defRPr sz="1200"/>
-            </a:lvl1pPr>
-          </a:lstStyle>
-          <a:p>
-            <a:endParaRPr lang="en-US"/>
-          </a:p>
-        </p:txBody>
-      </p:sp>
-      <p:sp>
-        <p:nvSpPr>
-          <p:cNvPr id="3" name="Date Placeholder 2"/>
-          <p:cNvSpPr>
-            <a:spLocks noGrp="1"/>
-          </p:cNvSpPr>
-          <p:nvPr>
-            <p:ph type="dt" idx="1"/>
-          </p:nvPr>
-        </p:nvSpPr>
-        <p:spPr>
-          <a:xfrm>
-            <a:off x="3884613" y="0"/>
-            <a:ext cx="2971800" cy="457200"/>
-          </a:xfrm>
-          <a:prstGeom prst="rect">
-            <a:avLst/>
-          </a:prstGeom>
-        </p:spPr>
-        <p:txBody>
-          <a:bodyPr vert="horz" lIns="91440" tIns="45720" rIns="91440" bIns="45720" rtlCol="0"/>
-          <a:lstStyle>
-            <a:lvl1pPr algn="r">
-              <a:defRPr sz="1200"/>
-            </a:lvl1pPr>
-          </a:lstStyle>
-          <a:p>
-            <a:fld id="{0F89C1C7-3DCD-1040-A9CF-14679D8B5DDD}" type="datetimeFigureOut">
-              <a:rPr lang="en-US" smtClean="0"/>
-              <a:t>10/17/16</a:t>
-            </a:fld>
-            <a:endParaRPr lang="en-US"/>
-          </a:p>
-        </p:txBody>
-      </p:sp>
-      <p:sp>
-        <p:nvSpPr>
-          <p:cNvPr id="4" name="Slide Image Placeholder 3"/>
-          <p:cNvSpPr>
-            <a:spLocks noGrp="1" noRot="1" noChangeAspect="1"/>
-          </p:cNvSpPr>
-          <p:nvPr>
-            <p:ph type="sldImg" idx="2"/>
-          </p:nvPr>
-        </p:nvSpPr>
-        <p:spPr>
-          <a:xfrm>
-            <a:off x="1143000" y="685800"/>
-            <a:ext cx="4572000" cy="3429000"/>
-          </a:xfrm>
-          <a:prstGeom prst="rect">
-            <a:avLst/>
-          </a:prstGeom>
-          <a:noFill/>
-          <a:ln w="12700">
-            <a:solidFill>
-              <a:prstClr val="black"/>
-            </a:solidFill>
-          </a:ln>
-        </p:spPr>
-        <p:txBody>
-          <a:bodyPr vert="horz" lIns="91440" tIns="45720" rIns="91440" bIns="45720" rtlCol="0" anchor="ctr"/>
-          <a:lstStyle/>
-          <a:p>
-            <a:endParaRPr lang="en-US"/>
-          </a:p>
-        </p:txBody>
-      </p:sp>
-      <p:sp>
-        <p:nvSpPr>
-          <p:cNvPr id="5" name="Notes Placeholder 4"/>
-          <p:cNvSpPr>
-            <a:spLocks noGrp="1"/>
-          </p:cNvSpPr>
-          <p:nvPr>
-            <p:ph type="body" sz="quarter" idx="3"/>
-          </p:nvPr>
-        </p:nvSpPr>
-        <p:spPr>
-          <a:xfrm>
-            <a:off x="685800" y="4343400"/>
-            <a:ext cx="5486400" cy="4114800"/>
-          </a:xfrm>
-          <a:prstGeom prst="rect">
-            <a:avLst/>
-          </a:prstGeom>
-        </p:spPr>
-        <p:txBody>
-          <a:bodyPr vert="horz" lIns="91440" tIns="45720" rIns="91440" bIns="45720" rtlCol="0"/>
-          <a:lstStyle/>
-          <a:p>
-            <a:pPr lvl="0"/>
-            <a:r>
-              <a:rPr lang="en-US" smtClean="0"/>
-              <a:t>Click to edit Master text styles</a:t>
-            </a:r>
-          </a:p>
-          <a:p>
-            <a:pPr lvl="1"/>
-            <a:r>
-              <a:rPr lang="en-US" smtClean="0"/>
-              <a:t>Second level</a:t>
-            </a:r>
-          </a:p>
-          <a:p>
-            <a:pPr lvl="2"/>
-            <a:r>
-              <a:rPr lang="en-US" smtClean="0"/>
-              <a:t>Third level</a:t>
-            </a:r>
-          </a:p>
-          <a:p>
-            <a:pPr lvl="3"/>
-            <a:r>
-              <a:rPr lang="en-US" smtClean="0"/>
-              <a:t>Fourth level</a:t>
-            </a:r>
-          </a:p>
-          <a:p>
-            <a:pPr lvl="4"/>
-            <a:r>
-              <a:rPr lang="en-US" smtClean="0"/>
-              <a:t>Fifth level</a:t>
-            </a:r>
-            <a:endParaRPr lang="en-US"/>
-          </a:p>
-        </p:txBody>
-      </p:sp>
-      <p:sp>
-        <p:nvSpPr>
-          <p:cNvPr id="6" name="Footer Placeholder 5"/>
-          <p:cNvSpPr>
-            <a:spLocks noGrp="1"/>
-          </p:cNvSpPr>
-          <p:nvPr>
-            <p:ph type="ftr" sz="quarter" idx="4"/>
-          </p:nvPr>
-        </p:nvSpPr>
-        <p:spPr>
-          <a:xfrm>
-            <a:off x="0" y="8685213"/>
-            <a:ext cx="2971800" cy="457200"/>
-          </a:xfrm>
-          <a:prstGeom prst="rect">
-            <a:avLst/>
-          </a:prstGeom>
-        </p:spPr>
-        <p:txBody>
-          <a:bodyPr vert="horz" lIns="91440" tIns="45720" rIns="91440" bIns="45720" rtlCol="0" anchor="b"/>
-          <a:lstStyle>
-            <a:lvl1pPr algn="l">
-              <a:defRPr sz="1200"/>
-            </a:lvl1pPr>
-          </a:lstStyle>
-          <a:p>
-            <a:endParaRPr lang="en-US"/>
-          </a:p>
-        </p:txBody>
-      </p:sp>
-      <p:sp>
-        <p:nvSpPr>
-          <p:cNvPr id="7" name="Slide Number Placeholder 6"/>
-          <p:cNvSpPr>
-            <a:spLocks noGrp="1"/>
-          </p:cNvSpPr>
-          <p:nvPr>
-            <p:ph type="sldNum" sz="quarter" idx="5"/>
-          </p:nvPr>
-        </p:nvSpPr>
-        <p:spPr>
-          <a:xfrm>
-            <a:off x="3884613" y="8685213"/>
-            <a:ext cx="2971800" cy="457200"/>
-          </a:xfrm>
-          <a:prstGeom prst="rect">
-            <a:avLst/>
-          </a:prstGeom>
-        </p:spPr>
-        <p:txBody>
-          <a:bodyPr vert="horz" lIns="91440" tIns="45720" rIns="91440" bIns="45720" rtlCol="0" anchor="b"/>
-          <a:lstStyle>
-            <a:lvl1pPr algn="r">
-              <a:defRPr sz="1200"/>
-            </a:lvl1pPr>
-          </a:lstStyle>
-          <a:p>
-            <a:fld id="{BB5E49A5-4136-284D-997B-48E1D791AD67}" type="slidenum">
-              <a:rPr lang="en-US" smtClean="0"/>
-              <a:t>‹#›</a:t>
-            </a:fld>
-            <a:endParaRPr lang="en-US"/>
-          </a:p>
-        </p:txBody>
-      </p:sp>
     </p:spTree>
     <p:extLst>
       <p:ext uri="{BB962C8B-B14F-4D97-AF65-F5344CB8AC3E}">
-        <p14:creationId xmlns:p14="http://schemas.microsoft.com/office/powerpoint/2010/main" val="2623252185"/>
+        <p14:creationId xmlns:p14="http://schemas.microsoft.com/office/powerpoint/2010/main" val="2425394648"/>
       </p:ext>
     </p:extLst>
   </p:cSld>
   <p:clrMap bg1="lt1" tx1="dk1" bg2="lt2" tx2="dk2" accent1="accent1" accent2="accent2" accent3="accent3" accent4="accent4" accent5="accent5" accent6="accent6" hlink="hlink" folHlink="folHlink"/>
   <p:notesStyle>
-    <a:lvl1pPr marL="0" algn="l" defTabSz="457200" rtl="0" eaLnBrk="1" latinLnBrk="0" hangingPunct="1">
+    <a:lvl1pPr marL="0" algn="l" defTabSz="914400" rtl="0" eaLnBrk="1" latinLnBrk="0" hangingPunct="1">
       <a:defRPr sz="1200" kern="1200">
         <a:solidFill>
           <a:schemeClr val="tx1"/>
@@ -386,7 +180,7 @@
         <a:cs typeface="+mn-cs"/>
       </a:defRPr>
     </a:lvl1pPr>
-    <a:lvl2pPr marL="457200" algn="l" defTabSz="457200" rtl="0" eaLnBrk="1" latinLnBrk="0" hangingPunct="1">
+    <a:lvl2pPr marL="457200" algn="l" defTabSz="914400" rtl="0" eaLnBrk="1" latinLnBrk="0" hangingPunct="1">
       <a:defRPr sz="1200" kern="1200">
         <a:solidFill>
           <a:schemeClr val="tx1"/>
@@ -396,7 +190,7 @@
         <a:cs typeface="+mn-cs"/>
       </a:defRPr>
     </a:lvl2pPr>
-    <a:lvl3pPr marL="914400" algn="l" defTabSz="457200" rtl="0" eaLnBrk="1" latinLnBrk="0" hangingPunct="1">
+    <a:lvl3pPr marL="914400" algn="l" defTabSz="914400" rtl="0" eaLnBrk="1" latinLnBrk="0" hangingPunct="1">
       <a:defRPr sz="1200" kern="1200">
         <a:solidFill>
           <a:schemeClr val="tx1"/>
@@ -406,7 +200,7 @@
         <a:cs typeface="+mn-cs"/>
       </a:defRPr>
     </a:lvl3pPr>
-    <a:lvl4pPr marL="1371600" algn="l" defTabSz="457200" rtl="0" eaLnBrk="1" latinLnBrk="0" hangingPunct="1">
+    <a:lvl4pPr marL="1371600" algn="l" defTabSz="914400" rtl="0" eaLnBrk="1" latinLnBrk="0" hangingPunct="1">
       <a:defRPr sz="1200" kern="1200">
         <a:solidFill>
           <a:schemeClr val="tx1"/>
@@ -416,7 +210,7 @@
         <a:cs typeface="+mn-cs"/>
       </a:defRPr>
     </a:lvl4pPr>
-    <a:lvl5pPr marL="1828800" algn="l" defTabSz="457200" rtl="0" eaLnBrk="1" latinLnBrk="0" hangingPunct="1">
+    <a:lvl5pPr marL="1828800" algn="l" defTabSz="914400" rtl="0" eaLnBrk="1" latinLnBrk="0" hangingPunct="1">
       <a:defRPr sz="1200" kern="1200">
         <a:solidFill>
           <a:schemeClr val="tx1"/>
@@ -426,7 +220,7 @@
         <a:cs typeface="+mn-cs"/>
       </a:defRPr>
     </a:lvl5pPr>
-    <a:lvl6pPr marL="2286000" algn="l" defTabSz="457200" rtl="0" eaLnBrk="1" latinLnBrk="0" hangingPunct="1">
+    <a:lvl6pPr marL="2286000" algn="l" defTabSz="914400" rtl="0" eaLnBrk="1" latinLnBrk="0" hangingPunct="1">
       <a:defRPr sz="1200" kern="1200">
         <a:solidFill>
           <a:schemeClr val="tx1"/>
@@ -436,7 +230,7 @@
         <a:cs typeface="+mn-cs"/>
       </a:defRPr>
     </a:lvl6pPr>
-    <a:lvl7pPr marL="2743200" algn="l" defTabSz="457200" rtl="0" eaLnBrk="1" latinLnBrk="0" hangingPunct="1">
+    <a:lvl7pPr marL="2743200" algn="l" defTabSz="914400" rtl="0" eaLnBrk="1" latinLnBrk="0" hangingPunct="1">
       <a:defRPr sz="1200" kern="1200">
         <a:solidFill>
           <a:schemeClr val="tx1"/>
@@ -446,7 +240,7 @@
         <a:cs typeface="+mn-cs"/>
       </a:defRPr>
     </a:lvl7pPr>
-    <a:lvl8pPr marL="3200400" algn="l" defTabSz="457200" rtl="0" eaLnBrk="1" latinLnBrk="0" hangingPunct="1">
+    <a:lvl8pPr marL="3200400" algn="l" defTabSz="914400" rtl="0" eaLnBrk="1" latinLnBrk="0" hangingPunct="1">
       <a:defRPr sz="1200" kern="1200">
         <a:solidFill>
           <a:schemeClr val="tx1"/>
@@ -456,7 +250,7 @@
         <a:cs typeface="+mn-cs"/>
       </a:defRPr>
     </a:lvl8pPr>
-    <a:lvl9pPr marL="3657600" algn="l" defTabSz="457200" rtl="0" eaLnBrk="1" latinLnBrk="0" hangingPunct="1">
+    <a:lvl9pPr marL="3657600" algn="l" defTabSz="914400" rtl="0" eaLnBrk="1" latinLnBrk="0" hangingPunct="1">
       <a:defRPr sz="1200" kern="1200">
         <a:solidFill>
           <a:schemeClr val="tx1"/>
@@ -471,7 +265,7 @@
 </file>
 
 <file path=ppt/notesSlides/notesSlide1.xml><?xml version="1.0" encoding="utf-8"?>
-<p:notes xmlns:a="http://schemas.openxmlformats.org/drawingml/2006/main" xmlns:p="http://schemas.openxmlformats.org/presentationml/2006/main" xmlns:r="http://schemas.openxmlformats.org/officeDocument/2006/relationships">
+<p:notes xmlns:a="http://schemas.openxmlformats.org/drawingml/2006/main" xmlns:r="http://schemas.openxmlformats.org/officeDocument/2006/relationships" xmlns:p="http://schemas.openxmlformats.org/presentationml/2006/main">
   <p:cSld>
     <p:spTree>
       <p:nvGrpSpPr>
@@ -491,7 +285,7 @@
         <p:nvSpPr>
           <p:cNvPr id="2" name="Slide Image Placeholder 1"/>
           <p:cNvSpPr>
-            <a:spLocks noGrp="1"/>
+            <a:spLocks noGrp="1" noRot="1" noChangeAspect="1"/>
           </p:cNvSpPr>
           <p:nvPr>
             <p:ph type="sldImg" idx="2"/>
@@ -506,7 +300,7 @@
             <a:spLocks noGrp="1"/>
           </p:cNvSpPr>
           <p:nvPr>
-            <p:ph type="body" idx="3" sz="quarter"/>
+            <p:ph type="body" sz="quarter" idx="3"/>
           </p:nvPr>
         </p:nvSpPr>
         <p:spPr/>
@@ -518,7 +312,9 @@
               <a:t>Welcome everyone. Our project is Schema-Evolving Knowledge Graphs for Insurance. The key word is 'automated.' We want to eliminate the 3-6 month manual effort of building an ontology for each new insurance line of business.</a:t>
             </a:r>
           </a:p>
-          <a:p/>
+          <a:p>
+            <a:endParaRPr/>
+          </a:p>
           <a:p>
             <a:r>
               <a:t>I'm Xiaofei Wang, working with Zechary Chou, advised by Dr. Kang at Assurant.</a:t>
@@ -533,7 +329,7 @@
             <a:spLocks noGrp="1"/>
           </p:cNvSpPr>
           <p:nvPr>
-            <p:ph type="sldNum" idx="5" sz="quarter"/>
+            <p:ph type="sldNum" sz="quarter" idx="5"/>
           </p:nvPr>
         </p:nvSpPr>
         <p:spPr/>
@@ -547,7 +343,7 @@
 </file>
 
 <file path=ppt/notesSlides/notesSlide10.xml><?xml version="1.0" encoding="utf-8"?>
-<p:notes xmlns:a="http://schemas.openxmlformats.org/drawingml/2006/main" xmlns:p="http://schemas.openxmlformats.org/presentationml/2006/main" xmlns:r="http://schemas.openxmlformats.org/officeDocument/2006/relationships">
+<p:notes xmlns:a="http://schemas.openxmlformats.org/drawingml/2006/main" xmlns:r="http://schemas.openxmlformats.org/officeDocument/2006/relationships" xmlns:p="http://schemas.openxmlformats.org/presentationml/2006/main">
   <p:cSld>
     <p:spTree>
       <p:nvGrpSpPr>
@@ -567,7 +363,7 @@
         <p:nvSpPr>
           <p:cNvPr id="2" name="Slide Image Placeholder 1"/>
           <p:cNvSpPr>
-            <a:spLocks noGrp="1"/>
+            <a:spLocks noGrp="1" noRot="1" noChangeAspect="1"/>
           </p:cNvSpPr>
           <p:nvPr>
             <p:ph type="sldImg" idx="2"/>
@@ -582,7 +378,7 @@
             <a:spLocks noGrp="1"/>
           </p:cNvSpPr>
           <p:nvPr>
-            <p:ph type="body" idx="3" sz="quarter"/>
+            <p:ph type="body" sz="quarter" idx="3"/>
           </p:nvPr>
         </p:nvSpPr>
         <p:spPr/>
@@ -594,25 +390,33 @@
               <a:t>BERTScore F1: embed all class names, compute pairwise similarity. Unlike exact matching, 'Policy' gets partial credit against 'Product.'</a:t>
             </a:r>
           </a:p>
-          <a:p/>
+          <a:p>
+            <a:endParaRPr/>
+          </a:p>
           <a:p>
             <a:r>
               <a:t>Graph F1: propagate embeddings through the hierarchy. If our 'Peril' is subclass of 'Risk', it gets credit through graph proximity.</a:t>
             </a:r>
           </a:p>
-          <a:p/>
+          <a:p>
+            <a:endParaRPr/>
+          </a:p>
           <a:p>
             <a:r>
               <a:t>Entity Assignment F1: embed member entity names, compute centroids, compare to reference. The ONLY metric checking if entities are in the right bucket.</a:t>
             </a:r>
           </a:p>
-          <a:p/>
+          <a:p>
+            <a:endParaRPr/>
+          </a:p>
           <a:p>
             <a:r>
               <a:t>Wu-Palmer: standard taxonomy depth agreement.</a:t>
             </a:r>
           </a:p>
-          <a:p/>
+          <a:p>
+            <a:endParaRPr/>
+          </a:p>
           <a:p>
             <a:r>
               <a:t>We also report present-class F1, which only counts classes evidenced in the data. Person, Organization, Object are absent from flood insurance.</a:t>
@@ -627,7 +431,7 @@
             <a:spLocks noGrp="1"/>
           </p:cNvSpPr>
           <p:nvPr>
-            <p:ph type="sldNum" idx="5" sz="quarter"/>
+            <p:ph type="sldNum" sz="quarter" idx="5"/>
           </p:nvPr>
         </p:nvSpPr>
         <p:spPr/>
@@ -641,7 +445,7 @@
 </file>
 
 <file path=ppt/notesSlides/notesSlide11.xml><?xml version="1.0" encoding="utf-8"?>
-<p:notes xmlns:a="http://schemas.openxmlformats.org/drawingml/2006/main" xmlns:p="http://schemas.openxmlformats.org/presentationml/2006/main" xmlns:r="http://schemas.openxmlformats.org/officeDocument/2006/relationships">
+<p:notes xmlns:a="http://schemas.openxmlformats.org/drawingml/2006/main" xmlns:r="http://schemas.openxmlformats.org/officeDocument/2006/relationships" xmlns:p="http://schemas.openxmlformats.org/presentationml/2006/main">
   <p:cSld>
     <p:spTree>
       <p:nvGrpSpPr>
@@ -661,7 +465,7 @@
         <p:nvSpPr>
           <p:cNvPr id="2" name="Slide Image Placeholder 1"/>
           <p:cNvSpPr>
-            <a:spLocks noGrp="1"/>
+            <a:spLocks noGrp="1" noRot="1" noChangeAspect="1"/>
           </p:cNvSpPr>
           <p:nvPr>
             <p:ph type="sldImg" idx="2"/>
@@ -676,7 +480,7 @@
             <a:spLocks noGrp="1"/>
           </p:cNvSpPr>
           <p:nvPr>
-            <p:ph type="body" idx="3" sz="quarter"/>
+            <p:ph type="body" sz="quarter" idx="3"/>
           </p:nvPr>
         </p:nvSpPr>
         <p:spPr/>
@@ -688,13 +492,17 @@
               <a:t>Full comparison. Every metric improves from Leiden to RSI-LCR to SV-LOI.</a:t>
             </a:r>
           </a:p>
-          <a:p/>
+          <a:p>
+            <a:endParaRPr/>
+          </a:p>
           <a:p>
             <a:r>
               <a:t>Name F1: zero to 0.295 to 0.563. BERTScore: 0.451 to 0.577 to 0.732. Graph F1: 0.441 to 0.501 to 0.714.</a:t>
             </a:r>
           </a:p>
-          <a:p/>
+          <a:p>
+            <a:endParaRPr/>
+          </a:p>
           <a:p>
             <a:r>
               <a:t>SV-LOI produces 7 classes vs Leiden's 11 and RSI-LCR's 30. Fewer, cleaner classes. All methods use the exact same extraction.</a:t>
@@ -709,7 +517,7 @@
             <a:spLocks noGrp="1"/>
           </p:cNvSpPr>
           <p:nvPr>
-            <p:ph type="sldNum" idx="5" sz="quarter"/>
+            <p:ph type="sldNum" sz="quarter" idx="5"/>
           </p:nvPr>
         </p:nvSpPr>
         <p:spPr/>
@@ -723,7 +531,7 @@
 </file>
 
 <file path=ppt/notesSlides/notesSlide12.xml><?xml version="1.0" encoding="utf-8"?>
-<p:notes xmlns:a="http://schemas.openxmlformats.org/drawingml/2006/main" xmlns:p="http://schemas.openxmlformats.org/presentationml/2006/main" xmlns:r="http://schemas.openxmlformats.org/officeDocument/2006/relationships">
+<p:notes xmlns:a="http://schemas.openxmlformats.org/drawingml/2006/main" xmlns:r="http://schemas.openxmlformats.org/officeDocument/2006/relationships" xmlns:p="http://schemas.openxmlformats.org/presentationml/2006/main">
   <p:cSld>
     <p:spTree>
       <p:nvGrpSpPr>
@@ -743,7 +551,7 @@
         <p:nvSpPr>
           <p:cNvPr id="2" name="Slide Image Placeholder 1"/>
           <p:cNvSpPr>
-            <a:spLocks noGrp="1"/>
+            <a:spLocks noGrp="1" noRot="1" noChangeAspect="1"/>
           </p:cNvSpPr>
           <p:nvPr>
             <p:ph type="sldImg" idx="2"/>
@@ -758,7 +566,7 @@
             <a:spLocks noGrp="1"/>
           </p:cNvSpPr>
           <p:nvPr>
-            <p:ph type="body" idx="3" sz="quarter"/>
+            <p:ph type="body" sz="quarter" idx="3"/>
           </p:nvPr>
         </p:nvSpPr>
         <p:spPr/>
@@ -770,31 +578,41 @@
               <a:t>Five key findings.</a:t>
             </a:r>
           </a:p>
-          <a:p/>
+          <a:p>
+            <a:endParaRPr/>
+          </a:p>
           <a:p>
             <a:r>
               <a:t>Extraction scales dramatically with model size. 8b: 1 triple per chunk. 72b: 8 to 50.</a:t>
             </a:r>
           </a:p>
-          <a:p/>
+          <a:p>
+            <a:endParaRPr/>
+          </a:p>
           <a:p>
             <a:r>
               <a:t>Leiden clusters are impure - 'Hazard' mixes coverages, buildings, perils.</a:t>
             </a:r>
           </a:p>
-          <a:p/>
+          <a:p>
+            <a:endParaRPr/>
+          </a:p>
           <a:p>
             <a:r>
               <a:t>LLMs default to data-type thinking. First SV-LOI attempt: 'FinancialAmount' with 577 entities! Fixed with two-stage domain-aware discovery.</a:t>
             </a:r>
           </a:p>
-          <a:p/>
+          <a:p>
+            <a:endParaRPr/>
+          </a:p>
           <a:p>
             <a:r>
               <a:t>Source data limits recall. Person, Organization absent from flood insurance.</a:t>
             </a:r>
           </a:p>
-          <a:p/>
+          <a:p>
+            <a:endParaRPr/>
+          </a:p>
           <a:p>
             <a:r>
               <a:t>Core finding: neither signal alone is sufficient. Their fusion is SV-LOI's contribution.</a:t>
@@ -809,7 +627,7 @@
             <a:spLocks noGrp="1"/>
           </p:cNvSpPr>
           <p:nvPr>
-            <p:ph type="sldNum" idx="5" sz="quarter"/>
+            <p:ph type="sldNum" sz="quarter" idx="5"/>
           </p:nvPr>
         </p:nvSpPr>
         <p:spPr/>
@@ -823,7 +641,7 @@
 </file>
 
 <file path=ppt/notesSlides/notesSlide13.xml><?xml version="1.0" encoding="utf-8"?>
-<p:notes xmlns:a="http://schemas.openxmlformats.org/drawingml/2006/main" xmlns:p="http://schemas.openxmlformats.org/presentationml/2006/main" xmlns:r="http://schemas.openxmlformats.org/officeDocument/2006/relationships">
+<p:notes xmlns:a="http://schemas.openxmlformats.org/drawingml/2006/main" xmlns:r="http://schemas.openxmlformats.org/officeDocument/2006/relationships" xmlns:p="http://schemas.openxmlformats.org/presentationml/2006/main">
   <p:cSld>
     <p:spTree>
       <p:nvGrpSpPr>
@@ -843,7 +661,7 @@
         <p:nvSpPr>
           <p:cNvPr id="2" name="Slide Image Placeholder 1"/>
           <p:cNvSpPr>
-            <a:spLocks noGrp="1"/>
+            <a:spLocks noGrp="1" noRot="1" noChangeAspect="1"/>
           </p:cNvSpPr>
           <p:nvPr>
             <p:ph type="sldImg" idx="2"/>
@@ -858,7 +676,7 @@
             <a:spLocks noGrp="1"/>
           </p:cNvSpPr>
           <p:nvPr>
-            <p:ph type="body" idx="3" sz="quarter"/>
+            <p:ph type="body" sz="quarter" idx="3"/>
           </p:nvPr>
         </p:nvSpPr>
         <p:spPr/>
@@ -870,19 +688,25 @@
               <a:t>Remaining work. First: reduce unclassified entities from 24% to under 5%. Already implemented.</a:t>
             </a:r>
           </a:p>
-          <a:p/>
+          <a:p>
+            <a:endParaRPr/>
+          </a:p>
           <a:p>
             <a:r>
               <a:t>Second: cross-domain transfer on auto insurance - zero code changes. This proves our domain-agnostic claim and fills the Person, Organization gaps.</a:t>
             </a:r>
           </a:p>
-          <a:p/>
+          <a:p>
+            <a:endParaRPr/>
+          </a:p>
           <a:p>
             <a:r>
               <a:t>Third: measure Class Transfer Ratio - how many classes appear in both flood and auto?</a:t>
             </a:r>
           </a:p>
-          <a:p/>
+          <a:p>
+            <a:endParaRPr/>
+          </a:p>
           <a:p>
             <a:r>
               <a:t>Fourth: paper writing. Fifth: Streamlit demo.</a:t>
@@ -897,7 +721,7 @@
             <a:spLocks noGrp="1"/>
           </p:cNvSpPr>
           <p:nvPr>
-            <p:ph type="sldNum" idx="5" sz="quarter"/>
+            <p:ph type="sldNum" sz="quarter" idx="5"/>
           </p:nvPr>
         </p:nvSpPr>
         <p:spPr/>
@@ -911,7 +735,7 @@
 </file>
 
 <file path=ppt/notesSlides/notesSlide14.xml><?xml version="1.0" encoding="utf-8"?>
-<p:notes xmlns:a="http://schemas.openxmlformats.org/drawingml/2006/main" xmlns:p="http://schemas.openxmlformats.org/presentationml/2006/main" xmlns:r="http://schemas.openxmlformats.org/officeDocument/2006/relationships">
+<p:notes xmlns:a="http://schemas.openxmlformats.org/drawingml/2006/main" xmlns:r="http://schemas.openxmlformats.org/officeDocument/2006/relationships" xmlns:p="http://schemas.openxmlformats.org/presentationml/2006/main">
   <p:cSld>
     <p:spTree>
       <p:nvGrpSpPr>
@@ -931,7 +755,7 @@
         <p:nvSpPr>
           <p:cNvPr id="2" name="Slide Image Placeholder 1"/>
           <p:cNvSpPr>
-            <a:spLocks noGrp="1"/>
+            <a:spLocks noGrp="1" noRot="1" noChangeAspect="1"/>
           </p:cNvSpPr>
           <p:nvPr>
             <p:ph type="sldImg" idx="2"/>
@@ -946,7 +770,7 @@
             <a:spLocks noGrp="1"/>
           </p:cNvSpPr>
           <p:nvPr>
-            <p:ph type="body" idx="3" sz="quarter"/>
+            <p:ph type="body" sz="quarter" idx="3"/>
           </p:nvPr>
         </p:nvSpPr>
         <p:spPr/>
@@ -967,7 +791,7 @@
             <a:spLocks noGrp="1"/>
           </p:cNvSpPr>
           <p:nvPr>
-            <p:ph type="sldNum" idx="5" sz="quarter"/>
+            <p:ph type="sldNum" sz="quarter" idx="5"/>
           </p:nvPr>
         </p:nvSpPr>
         <p:spPr/>
@@ -981,7 +805,7 @@
 </file>
 
 <file path=ppt/notesSlides/notesSlide2.xml><?xml version="1.0" encoding="utf-8"?>
-<p:notes xmlns:a="http://schemas.openxmlformats.org/drawingml/2006/main" xmlns:p="http://schemas.openxmlformats.org/presentationml/2006/main" xmlns:r="http://schemas.openxmlformats.org/officeDocument/2006/relationships">
+<p:notes xmlns:a="http://schemas.openxmlformats.org/drawingml/2006/main" xmlns:r="http://schemas.openxmlformats.org/officeDocument/2006/relationships" xmlns:p="http://schemas.openxmlformats.org/presentationml/2006/main">
   <p:cSld>
     <p:spTree>
       <p:nvGrpSpPr>
@@ -1001,7 +825,7 @@
         <p:nvSpPr>
           <p:cNvPr id="2" name="Slide Image Placeholder 1"/>
           <p:cNvSpPr>
-            <a:spLocks noGrp="1"/>
+            <a:spLocks noGrp="1" noRot="1" noChangeAspect="1"/>
           </p:cNvSpPr>
           <p:nvPr>
             <p:ph type="sldImg" idx="2"/>
@@ -1016,7 +840,7 @@
             <a:spLocks noGrp="1"/>
           </p:cNvSpPr>
           <p:nvPr>
-            <p:ph type="body" idx="3" sz="quarter"/>
+            <p:ph type="body" sz="quarter" idx="3"/>
           </p:nvPr>
         </p:nvSpPr>
         <p:spPr/>
@@ -1028,13 +852,17 @@
               <a:t>Here's the problem. When an insurance company expands into a new LOB, they need a new ontology. That means hiring domain experts, spending 3-6 months, and the work doesn't transfer.</a:t>
             </a:r>
           </a:p>
-          <a:p/>
+          <a:p>
+            <a:endParaRPr/>
+          </a:p>
           <a:p>
             <a:r>
               <a:t>Existing tools like LLMGraphTransformer produce a flat mess - duplicate nodes, no types, no hierarchy. Look at this example: the same building shows up as two different nodes.</a:t>
             </a:r>
           </a:p>
-          <a:p/>
+          <a:p>
+            <a:endParaRPr/>
+          </a:p>
           <a:p>
             <a:r>
               <a:t>Our research question: can we automatically induce an ontology from an extracted knowledge graph?</a:t>
@@ -1049,7 +877,7 @@
             <a:spLocks noGrp="1"/>
           </p:cNvSpPr>
           <p:nvPr>
-            <p:ph type="sldNum" idx="5" sz="quarter"/>
+            <p:ph type="sldNum" sz="quarter" idx="5"/>
           </p:nvPr>
         </p:nvSpPr>
         <p:spPr/>
@@ -1063,7 +891,7 @@
 </file>
 
 <file path=ppt/notesSlides/notesSlide3.xml><?xml version="1.0" encoding="utf-8"?>
-<p:notes xmlns:a="http://schemas.openxmlformats.org/drawingml/2006/main" xmlns:p="http://schemas.openxmlformats.org/presentationml/2006/main" xmlns:r="http://schemas.openxmlformats.org/officeDocument/2006/relationships">
+<p:notes xmlns:a="http://schemas.openxmlformats.org/drawingml/2006/main" xmlns:r="http://schemas.openxmlformats.org/officeDocument/2006/relationships" xmlns:p="http://schemas.openxmlformats.org/presentationml/2006/main">
   <p:cSld>
     <p:spTree>
       <p:nvGrpSpPr>
@@ -1083,7 +911,7 @@
         <p:nvSpPr>
           <p:cNvPr id="2" name="Slide Image Placeholder 1"/>
           <p:cNvSpPr>
-            <a:spLocks noGrp="1"/>
+            <a:spLocks noGrp="1" noRot="1" noChangeAspect="1"/>
           </p:cNvSpPr>
           <p:nvPr>
             <p:ph type="sldImg" idx="2"/>
@@ -1098,7 +926,7 @@
             <a:spLocks noGrp="1"/>
           </p:cNvSpPr>
           <p:nvPr>
-            <p:ph type="body" idx="3" sz="quarter"/>
+            <p:ph type="body" sz="quarter" idx="3"/>
           </p:nvPr>
         </p:nvSpPr>
         <p:spPr/>
@@ -1110,25 +938,33 @@
               <a:t>This is important. Our pipeline ingests THREE different data types.</a:t>
             </a:r>
           </a:p>
-          <a:p/>
+          <a:p>
+            <a:endParaRPr/>
+          </a:p>
           <a:p>
             <a:r>
               <a:t>First, the SFIP policy document, a 45-page PDF with coverage definitions, exclusions, and claims procedures. 49 sections.</a:t>
             </a:r>
           </a:p>
-          <a:p/>
+          <a:p>
+            <a:endParaRPr/>
+          </a:p>
           <a:p>
             <a:r>
               <a:t>Second, claims records from OpenFEMA - CSV files with total building coverage, flood zone, county code, date of loss. 72 records.</a:t>
             </a:r>
           </a:p>
-          <a:p/>
+          <a:p>
+            <a:endParaRPr/>
+          </a:p>
           <a:p>
             <a:r>
               <a:t>Third, policy records - another CSV with property details, occupancy types, deductible amounts. 67 records.</a:t>
             </a:r>
           </a:p>
-          <a:p/>
+          <a:p>
+            <a:endParaRPr/>
+          </a:p>
           <a:p>
             <a:r>
               <a:t>All three go through the SAME Zone 1 chunking pipeline. 188 chunks total. No format-specific code.</a:t>
@@ -1143,7 +979,7 @@
             <a:spLocks noGrp="1"/>
           </p:cNvSpPr>
           <p:nvPr>
-            <p:ph type="sldNum" idx="5" sz="quarter"/>
+            <p:ph type="sldNum" sz="quarter" idx="5"/>
           </p:nvPr>
         </p:nvSpPr>
         <p:spPr/>
@@ -1157,7 +993,7 @@
 </file>
 
 <file path=ppt/notesSlides/notesSlide4.xml><?xml version="1.0" encoding="utf-8"?>
-<p:notes xmlns:a="http://schemas.openxmlformats.org/drawingml/2006/main" xmlns:p="http://schemas.openxmlformats.org/presentationml/2006/main" xmlns:r="http://schemas.openxmlformats.org/officeDocument/2006/relationships">
+<p:notes xmlns:a="http://schemas.openxmlformats.org/drawingml/2006/main" xmlns:r="http://schemas.openxmlformats.org/officeDocument/2006/relationships" xmlns:p="http://schemas.openxmlformats.org/presentationml/2006/main">
   <p:cSld>
     <p:spTree>
       <p:nvGrpSpPr>
@@ -1177,7 +1013,7 @@
         <p:nvSpPr>
           <p:cNvPr id="2" name="Slide Image Placeholder 1"/>
           <p:cNvSpPr>
-            <a:spLocks noGrp="1"/>
+            <a:spLocks noGrp="1" noRot="1" noChangeAspect="1"/>
           </p:cNvSpPr>
           <p:nvPr>
             <p:ph type="sldImg" idx="2"/>
@@ -1192,7 +1028,7 @@
             <a:spLocks noGrp="1"/>
           </p:cNvSpPr>
           <p:nvPr>
-            <p:ph type="body" idx="3" sz="quarter"/>
+            <p:ph type="body" sz="quarter" idx="3"/>
           </p:nvPr>
         </p:nvSpPr>
         <p:spPr/>
@@ -1204,7 +1040,9 @@
               <a:t>Our pipeline has 4 zones. Zone 1 ingests documents - handles both PDF and CSV. Zone 2 bootstraps vocabularies from the documents themselves and extracts triples. Zone 3 is the research contribution - ontology induction with SV-LOI. Zone 4 is structured Neo4j storage.</a:t>
             </a:r>
           </a:p>
-          <a:p/>
+          <a:p>
+            <a:endParaRPr/>
+          </a:p>
           <a:p>
             <a:r>
               <a:t>Critical point: the pipeline NEVER sees the reference ontology. Riskine is used ONLY for evaluation. This is what makes the method domain-agnostic.</a:t>
@@ -1219,7 +1057,7 @@
             <a:spLocks noGrp="1"/>
           </p:cNvSpPr>
           <p:nvPr>
-            <p:ph type="sldNum" idx="5" sz="quarter"/>
+            <p:ph type="sldNum" sz="quarter" idx="5"/>
           </p:nvPr>
         </p:nvSpPr>
         <p:spPr/>
@@ -1233,7 +1071,7 @@
 </file>
 
 <file path=ppt/notesSlides/notesSlide5.xml><?xml version="1.0" encoding="utf-8"?>
-<p:notes xmlns:a="http://schemas.openxmlformats.org/drawingml/2006/main" xmlns:p="http://schemas.openxmlformats.org/presentationml/2006/main" xmlns:r="http://schemas.openxmlformats.org/officeDocument/2006/relationships">
+<p:notes xmlns:a="http://schemas.openxmlformats.org/drawingml/2006/main" xmlns:r="http://schemas.openxmlformats.org/officeDocument/2006/relationships" xmlns:p="http://schemas.openxmlformats.org/presentationml/2006/main">
   <p:cSld>
     <p:spTree>
       <p:nvGrpSpPr>
@@ -1253,7 +1091,7 @@
         <p:nvSpPr>
           <p:cNvPr id="2" name="Slide Image Placeholder 1"/>
           <p:cNvSpPr>
-            <a:spLocks noGrp="1"/>
+            <a:spLocks noGrp="1" noRot="1" noChangeAspect="1"/>
           </p:cNvSpPr>
           <p:nvPr>
             <p:ph type="sldImg" idx="2"/>
@@ -1268,7 +1106,7 @@
             <a:spLocks noGrp="1"/>
           </p:cNvSpPr>
           <p:nvPr>
-            <p:ph type="body" idx="3" sz="quarter"/>
+            <p:ph type="body" sz="quarter" idx="3"/>
           </p:nvPr>
         </p:nvSpPr>
         <p:spPr/>
@@ -1280,19 +1118,25 @@
               <a:t>Zone 2 produces 1,351 entities and 1,749 relationships from 188 chunks.</a:t>
             </a:r>
           </a:p>
-          <a:p/>
+          <a:p>
+            <a:endParaRPr/>
+          </a:p>
           <a:p>
             <a:r>
               <a:t>Query accuracy: we run 20 Cypher queries like 'What does Coverage A cover?' 19 out of 20 correct - 95%. Type inconsistency: only 2.2% of entities have conflicting labels.</a:t>
             </a:r>
           </a:p>
-          <a:p/>
+          <a:p>
+            <a:endParaRPr/>
+          </a:p>
           <a:p>
             <a:r>
               <a:t>The extraction is fully domain-agnostic - the LLM bootstraps its own entity and relation types from the documents. We use synthetic few-shot examples, not text from the source documents.</a:t>
             </a:r>
           </a:p>
-          <a:p/>
+          <a:p>
+            <a:endParaRPr/>
+          </a:p>
           <a:p>
             <a:r>
               <a:t>Takeaway: extraction is solved. The bottleneck is ontology induction.</a:t>
@@ -1307,7 +1151,7 @@
             <a:spLocks noGrp="1"/>
           </p:cNvSpPr>
           <p:nvPr>
-            <p:ph type="sldNum" idx="5" sz="quarter"/>
+            <p:ph type="sldNum" sz="quarter" idx="5"/>
           </p:nvPr>
         </p:nvSpPr>
         <p:spPr/>
@@ -1321,7 +1165,7 @@
 </file>
 
 <file path=ppt/notesSlides/notesSlide6.xml><?xml version="1.0" encoding="utf-8"?>
-<p:notes xmlns:a="http://schemas.openxmlformats.org/drawingml/2006/main" xmlns:p="http://schemas.openxmlformats.org/presentationml/2006/main" xmlns:r="http://schemas.openxmlformats.org/officeDocument/2006/relationships">
+<p:notes xmlns:a="http://schemas.openxmlformats.org/drawingml/2006/main" xmlns:r="http://schemas.openxmlformats.org/officeDocument/2006/relationships" xmlns:p="http://schemas.openxmlformats.org/presentationml/2006/main">
   <p:cSld>
     <p:spTree>
       <p:nvGrpSpPr>
@@ -1341,7 +1185,7 @@
         <p:nvSpPr>
           <p:cNvPr id="2" name="Slide Image Placeholder 1"/>
           <p:cNvSpPr>
-            <a:spLocks noGrp="1"/>
+            <a:spLocks noGrp="1" noRot="1" noChangeAspect="1"/>
           </p:cNvSpPr>
           <p:nvPr>
             <p:ph type="sldImg" idx="2"/>
@@ -1356,7 +1200,7 @@
             <a:spLocks noGrp="1"/>
           </p:cNvSpPr>
           <p:nvPr>
-            <p:ph type="body" idx="3" sz="quarter"/>
+            <p:ph type="body" sz="quarter" idx="3"/>
           </p:nvPr>
         </p:nvSpPr>
         <p:spPr/>
@@ -1368,25 +1212,33 @@
               <a:t>Three methods compared, each using a fundamentally different signal.</a:t>
             </a:r>
           </a:p>
-          <a:p/>
+          <a:p>
+            <a:endParaRPr/>
+          </a:p>
           <a:p>
             <a:r>
               <a:t>Leiden embeds entity names, builds a similarity graph, clusters. Groups things that LOOK alike.</a:t>
             </a:r>
           </a:p>
-          <a:p/>
+          <a:p>
+            <a:endParaRPr/>
+          </a:p>
           <a:p>
             <a:r>
               <a:t>RSI-LCR builds relation-signature vectors - what relations each entity participates in. Clusters with HAC, refines with LLM coherence checks. Groups things that BEHAVE alike.</a:t>
             </a:r>
           </a:p>
-          <a:p/>
+          <a:p>
+            <a:endParaRPr/>
+          </a:p>
           <a:p>
             <a:r>
               <a:t>SV-LOI has the LLM discover classes from domain detection, then assign entities, then structurally verify with 2-sigma outlier detection, then arbitrate disagreements. It knows what entities ARE.</a:t>
             </a:r>
           </a:p>
-          <a:p/>
+          <a:p>
+            <a:endParaRPr/>
+          </a:p>
           <a:p>
             <a:r>
               <a:t>The key insight: neither semantic nor structural signal alone is sufficient.</a:t>
@@ -1401,7 +1253,7 @@
             <a:spLocks noGrp="1"/>
           </p:cNvSpPr>
           <p:nvPr>
-            <p:ph type="sldNum" idx="5" sz="quarter"/>
+            <p:ph type="sldNum" sz="quarter" idx="5"/>
           </p:nvPr>
         </p:nvSpPr>
         <p:spPr/>
@@ -1415,7 +1267,7 @@
 </file>
 
 <file path=ppt/notesSlides/notesSlide7.xml><?xml version="1.0" encoding="utf-8"?>
-<p:notes xmlns:a="http://schemas.openxmlformats.org/drawingml/2006/main" xmlns:p="http://schemas.openxmlformats.org/presentationml/2006/main" xmlns:r="http://schemas.openxmlformats.org/officeDocument/2006/relationships">
+<p:notes xmlns:a="http://schemas.openxmlformats.org/drawingml/2006/main" xmlns:r="http://schemas.openxmlformats.org/officeDocument/2006/relationships" xmlns:p="http://schemas.openxmlformats.org/presentationml/2006/main">
   <p:cSld>
     <p:spTree>
       <p:nvGrpSpPr>
@@ -1435,7 +1287,7 @@
         <p:nvSpPr>
           <p:cNvPr id="2" name="Slide Image Placeholder 1"/>
           <p:cNvSpPr>
-            <a:spLocks noGrp="1"/>
+            <a:spLocks noGrp="1" noRot="1" noChangeAspect="1"/>
           </p:cNvSpPr>
           <p:nvPr>
             <p:ph type="sldImg" idx="2"/>
@@ -1450,7 +1302,7 @@
             <a:spLocks noGrp="1"/>
           </p:cNvSpPr>
           <p:nvPr>
-            <p:ph type="body" idx="3" sz="quarter"/>
+            <p:ph type="body" sz="quarter" idx="3"/>
           </p:nvPr>
         </p:nvSpPr>
         <p:spPr/>
@@ -1462,13 +1314,17 @@
               <a:t>Leiden found 11 clusters. But the clusters are semantically impure.</a:t>
             </a:r>
           </a:p>
-          <a:p/>
+          <a:p>
+            <a:endParaRPr/>
+          </a:p>
           <a:p>
             <a:r>
               <a:t>Concrete example: the 'Hazard' cluster contained Coverage B, Residential Building, Flood Zone A, and Mudflow. All embed near insurance terms, but they're 4 DIFFERENT classes. Name F1 was literally zero.</a:t>
             </a:r>
           </a:p>
-          <a:p/>
+          <a:p>
+            <a:endParaRPr/>
+          </a:p>
           <a:p>
             <a:r>
               <a:t>Lesson: embedding similarity groups entities that LOOK alike, not entities that ARE the same thing.</a:t>
@@ -1483,7 +1339,7 @@
             <a:spLocks noGrp="1"/>
           </p:cNvSpPr>
           <p:nvPr>
-            <p:ph type="sldNum" idx="5" sz="quarter"/>
+            <p:ph type="sldNum" sz="quarter" idx="5"/>
           </p:nvPr>
         </p:nvSpPr>
         <p:spPr/>
@@ -1497,7 +1353,7 @@
 </file>
 
 <file path=ppt/notesSlides/notesSlide8.xml><?xml version="1.0" encoding="utf-8"?>
-<p:notes xmlns:a="http://schemas.openxmlformats.org/drawingml/2006/main" xmlns:p="http://schemas.openxmlformats.org/presentationml/2006/main" xmlns:r="http://schemas.openxmlformats.org/officeDocument/2006/relationships">
+<p:notes xmlns:a="http://schemas.openxmlformats.org/drawingml/2006/main" xmlns:r="http://schemas.openxmlformats.org/officeDocument/2006/relationships" xmlns:p="http://schemas.openxmlformats.org/presentationml/2006/main">
   <p:cSld>
     <p:spTree>
       <p:nvGrpSpPr>
@@ -1517,7 +1373,7 @@
         <p:nvSpPr>
           <p:cNvPr id="2" name="Slide Image Placeholder 1"/>
           <p:cNvSpPr>
-            <a:spLocks noGrp="1"/>
+            <a:spLocks noGrp="1" noRot="1" noChangeAspect="1"/>
           </p:cNvSpPr>
           <p:nvPr>
             <p:ph type="sldImg" idx="2"/>
@@ -1532,7 +1388,7 @@
             <a:spLocks noGrp="1"/>
           </p:cNvSpPr>
           <p:nvPr>
-            <p:ph type="body" idx="3" sz="quarter"/>
+            <p:ph type="body" sz="quarter" idx="3"/>
           </p:nvPr>
         </p:nvSpPr>
         <p:spPr/>
@@ -1544,19 +1400,25 @@
               <a:t>RSI-LCR clusters by relation patterns. Name F1 went from zero to 0.295 - found Coverage, Risk, Property.</a:t>
             </a:r>
           </a:p>
-          <a:p/>
+          <a:p>
+            <a:endParaRPr/>
+          </a:p>
           <a:p>
             <a:r>
               <a:t>But it over-fragments to 30 clusters. Coverage B and Coverage A have slightly different relation patterns, so they end up in different clusters. Both ARE Coverage, but the algorithm splits them.</a:t>
             </a:r>
           </a:p>
-          <a:p/>
+          <a:p>
+            <a:endParaRPr/>
+          </a:p>
           <a:p>
             <a:r>
               <a:t>Worse: Coverage and Structure share many relations - COVERS, HAS_LIMIT, APPLIES_TO. Signatures overlap.</a:t>
             </a:r>
           </a:p>
-          <a:p/>
+          <a:p>
+            <a:endParaRPr/>
+          </a:p>
           <a:p>
             <a:r>
               <a:t>Lesson: relation patterns tell you how entities BEHAVE, not what they ARE.</a:t>
@@ -1571,7 +1433,7 @@
             <a:spLocks noGrp="1"/>
           </p:cNvSpPr>
           <p:nvPr>
-            <p:ph type="sldNum" idx="5" sz="quarter"/>
+            <p:ph type="sldNum" sz="quarter" idx="5"/>
           </p:nvPr>
         </p:nvSpPr>
         <p:spPr/>
@@ -1585,7 +1447,7 @@
 </file>
 
 <file path=ppt/notesSlides/notesSlide9.xml><?xml version="1.0" encoding="utf-8"?>
-<p:notes xmlns:a="http://schemas.openxmlformats.org/drawingml/2006/main" xmlns:p="http://schemas.openxmlformats.org/presentationml/2006/main" xmlns:r="http://schemas.openxmlformats.org/officeDocument/2006/relationships">
+<p:notes xmlns:a="http://schemas.openxmlformats.org/drawingml/2006/main" xmlns:r="http://schemas.openxmlformats.org/officeDocument/2006/relationships" xmlns:p="http://schemas.openxmlformats.org/presentationml/2006/main">
   <p:cSld>
     <p:spTree>
       <p:nvGrpSpPr>
@@ -1605,7 +1467,7 @@
         <p:nvSpPr>
           <p:cNvPr id="2" name="Slide Image Placeholder 1"/>
           <p:cNvSpPr>
-            <a:spLocks noGrp="1"/>
+            <a:spLocks noGrp="1" noRot="1" noChangeAspect="1"/>
           </p:cNvSpPr>
           <p:nvPr>
             <p:ph type="sldImg" idx="2"/>
@@ -1620,7 +1482,7 @@
             <a:spLocks noGrp="1"/>
           </p:cNvSpPr>
           <p:nvPr>
-            <p:ph type="body" idx="3" sz="quarter"/>
+            <p:ph type="body" sz="quarter" idx="3"/>
           </p:nvPr>
         </p:nvSpPr>
         <p:spPr/>
@@ -1632,19 +1494,25 @@
               <a:t>SV-LOI fuses both signals. 6 phases: detect domain, propose classes, assign entities, structural verification, arbitration, consolidation.</a:t>
             </a:r>
           </a:p>
-          <a:p/>
+          <a:p>
+            <a:endParaRPr/>
+          </a:p>
           <a:p>
             <a:r>
               <a:t>Here's a concrete example. The LLM typed 'Flood Zone A' as Coverage. But Phase 4 checks: Coverage entities have COVERS and HAS_LIMIT. Flood Zone A has AFFECTS and LOCATED_IN. Cosine similarity to Coverage centroid: 0.12 when average is 0.90. Flagged!</a:t>
             </a:r>
           </a:p>
-          <a:p/>
+          <a:p>
+            <a:endParaRPr/>
+          </a:p>
           <a:p>
             <a:r>
               <a:t>Phase 5 shows the LLM both signals: 'You said Coverage, but it looks like Risk structurally.' The LLM corrects to Risk. Neither signal alone catches this.</a:t>
             </a:r>
           </a:p>
-          <a:p/>
+          <a:p>
+            <a:endParaRPr/>
+          </a:p>
           <a:p>
             <a:r>
               <a:t>Results: Name F1 0.563, BERTScore 0.732, Graph F1 0.714.</a:t>
@@ -1659,7 +1527,7 @@
             <a:spLocks noGrp="1"/>
           </p:cNvSpPr>
           <p:nvPr>
-            <p:ph type="sldNum" idx="5" sz="quarter"/>
+            <p:ph type="sldNum" sz="quarter" idx="5"/>
           </p:nvPr>
         </p:nvSpPr>
         <p:spPr/>
@@ -1710,10 +1578,9 @@
           <a:lstStyle/>
           <a:p>
             <a:r>
-              <a:rPr lang="en-US" smtClean="0"/>
+              <a:rPr lang="en-US"/>
               <a:t>Click to edit Master title style</a:t>
             </a:r>
-            <a:endParaRPr lang="en-US"/>
           </a:p>
         </p:txBody>
       </p:sp>
@@ -1829,10 +1696,9 @@
           </a:lstStyle>
           <a:p>
             <a:r>
-              <a:rPr lang="en-US" smtClean="0"/>
+              <a:rPr lang="en-US"/>
               <a:t>Click to edit Master subtitle style</a:t>
             </a:r>
-            <a:endParaRPr lang="en-US"/>
           </a:p>
         </p:txBody>
       </p:sp>
@@ -1853,7 +1719,7 @@
           <a:p>
             <a:fld id="{5BCAD085-E8A6-8845-BD4E-CB4CCA059FC4}" type="datetimeFigureOut">
               <a:rPr lang="en-US" smtClean="0"/>
-              <a:t>1/27/13</a:t>
+              <a:t>3/26/26</a:t>
             </a:fld>
             <a:endParaRPr lang="en-US"/>
           </a:p>
@@ -1947,10 +1813,9 @@
           <a:lstStyle/>
           <a:p>
             <a:r>
-              <a:rPr lang="en-US" smtClean="0"/>
+              <a:rPr lang="en-US"/>
               <a:t>Click to edit Master title style</a:t>
             </a:r>
-            <a:endParaRPr lang="en-US"/>
           </a:p>
         </p:txBody>
       </p:sp>
@@ -1971,38 +1836,37 @@
           <a:p>
             <a:pPr lvl="0"/>
             <a:r>
-              <a:rPr lang="en-US" smtClean="0"/>
+              <a:rPr lang="en-US"/>
               <a:t>Click to edit Master text styles</a:t>
             </a:r>
           </a:p>
           <a:p>
             <a:pPr lvl="1"/>
             <a:r>
-              <a:rPr lang="en-US" smtClean="0"/>
+              <a:rPr lang="en-US"/>
               <a:t>Second level</a:t>
             </a:r>
           </a:p>
           <a:p>
             <a:pPr lvl="2"/>
             <a:r>
-              <a:rPr lang="en-US" smtClean="0"/>
+              <a:rPr lang="en-US"/>
               <a:t>Third level</a:t>
             </a:r>
           </a:p>
           <a:p>
             <a:pPr lvl="3"/>
             <a:r>
-              <a:rPr lang="en-US" smtClean="0"/>
+              <a:rPr lang="en-US"/>
               <a:t>Fourth level</a:t>
             </a:r>
           </a:p>
           <a:p>
             <a:pPr lvl="4"/>
             <a:r>
-              <a:rPr lang="en-US" smtClean="0"/>
+              <a:rPr lang="en-US"/>
               <a:t>Fifth level</a:t>
             </a:r>
-            <a:endParaRPr lang="en-US"/>
           </a:p>
         </p:txBody>
       </p:sp>
@@ -2023,7 +1887,7 @@
           <a:p>
             <a:fld id="{5BCAD085-E8A6-8845-BD4E-CB4CCA059FC4}" type="datetimeFigureOut">
               <a:rPr lang="en-US" smtClean="0"/>
-              <a:t>1/27/13</a:t>
+              <a:t>3/26/26</a:t>
             </a:fld>
             <a:endParaRPr lang="en-US"/>
           </a:p>
@@ -2122,10 +1986,9 @@
           <a:lstStyle/>
           <a:p>
             <a:r>
-              <a:rPr lang="en-US" smtClean="0"/>
+              <a:rPr lang="en-US"/>
               <a:t>Click to edit Master title style</a:t>
             </a:r>
-            <a:endParaRPr lang="en-US"/>
           </a:p>
         </p:txBody>
       </p:sp>
@@ -2151,38 +2014,37 @@
           <a:p>
             <a:pPr lvl="0"/>
             <a:r>
-              <a:rPr lang="en-US" smtClean="0"/>
+              <a:rPr lang="en-US"/>
               <a:t>Click to edit Master text styles</a:t>
             </a:r>
           </a:p>
           <a:p>
             <a:pPr lvl="1"/>
             <a:r>
-              <a:rPr lang="en-US" smtClean="0"/>
+              <a:rPr lang="en-US"/>
               <a:t>Second level</a:t>
             </a:r>
           </a:p>
           <a:p>
             <a:pPr lvl="2"/>
             <a:r>
-              <a:rPr lang="en-US" smtClean="0"/>
+              <a:rPr lang="en-US"/>
               <a:t>Third level</a:t>
             </a:r>
           </a:p>
           <a:p>
             <a:pPr lvl="3"/>
             <a:r>
-              <a:rPr lang="en-US" smtClean="0"/>
+              <a:rPr lang="en-US"/>
               <a:t>Fourth level</a:t>
             </a:r>
           </a:p>
           <a:p>
             <a:pPr lvl="4"/>
             <a:r>
-              <a:rPr lang="en-US" smtClean="0"/>
+              <a:rPr lang="en-US"/>
               <a:t>Fifth level</a:t>
             </a:r>
-            <a:endParaRPr lang="en-US"/>
           </a:p>
         </p:txBody>
       </p:sp>
@@ -2203,7 +2065,7 @@
           <a:p>
             <a:fld id="{5BCAD085-E8A6-8845-BD4E-CB4CCA059FC4}" type="datetimeFigureOut">
               <a:rPr lang="en-US" smtClean="0"/>
-              <a:t>1/27/13</a:t>
+              <a:t>3/26/26</a:t>
             </a:fld>
             <a:endParaRPr lang="en-US"/>
           </a:p>
@@ -2297,10 +2159,9 @@
           <a:lstStyle/>
           <a:p>
             <a:r>
-              <a:rPr lang="en-US" smtClean="0"/>
+              <a:rPr lang="en-US"/>
               <a:t>Click to edit Master title style</a:t>
             </a:r>
-            <a:endParaRPr lang="en-US"/>
           </a:p>
         </p:txBody>
       </p:sp>
@@ -2321,38 +2182,37 @@
           <a:p>
             <a:pPr lvl="0"/>
             <a:r>
-              <a:rPr lang="en-US" smtClean="0"/>
+              <a:rPr lang="en-US"/>
               <a:t>Click to edit Master text styles</a:t>
             </a:r>
           </a:p>
           <a:p>
             <a:pPr lvl="1"/>
             <a:r>
-              <a:rPr lang="en-US" smtClean="0"/>
+              <a:rPr lang="en-US"/>
               <a:t>Second level</a:t>
             </a:r>
           </a:p>
           <a:p>
             <a:pPr lvl="2"/>
             <a:r>
-              <a:rPr lang="en-US" smtClean="0"/>
+              <a:rPr lang="en-US"/>
               <a:t>Third level</a:t>
             </a:r>
           </a:p>
           <a:p>
             <a:pPr lvl="3"/>
             <a:r>
-              <a:rPr lang="en-US" smtClean="0"/>
+              <a:rPr lang="en-US"/>
               <a:t>Fourth level</a:t>
             </a:r>
           </a:p>
           <a:p>
             <a:pPr lvl="4"/>
             <a:r>
-              <a:rPr lang="en-US" smtClean="0"/>
+              <a:rPr lang="en-US"/>
               <a:t>Fifth level</a:t>
             </a:r>
-            <a:endParaRPr lang="en-US"/>
           </a:p>
         </p:txBody>
       </p:sp>
@@ -2373,7 +2233,7 @@
           <a:p>
             <a:fld id="{5BCAD085-E8A6-8845-BD4E-CB4CCA059FC4}" type="datetimeFigureOut">
               <a:rPr lang="en-US" smtClean="0"/>
-              <a:t>1/27/13</a:t>
+              <a:t>3/26/26</a:t>
             </a:fld>
             <a:endParaRPr lang="en-US"/>
           </a:p>
@@ -2476,10 +2336,9 @@
           </a:lstStyle>
           <a:p>
             <a:r>
-              <a:rPr lang="en-US" smtClean="0"/>
+              <a:rPr lang="en-US"/>
               <a:t>Click to edit Master title style</a:t>
             </a:r>
-            <a:endParaRPr lang="en-US"/>
           </a:p>
         </p:txBody>
       </p:sp>
@@ -2596,7 +2455,7 @@
           <a:p>
             <a:pPr lvl="0"/>
             <a:r>
-              <a:rPr lang="en-US" smtClean="0"/>
+              <a:rPr lang="en-US"/>
               <a:t>Click to edit Master text styles</a:t>
             </a:r>
           </a:p>
@@ -2619,7 +2478,7 @@
           <a:p>
             <a:fld id="{5BCAD085-E8A6-8845-BD4E-CB4CCA059FC4}" type="datetimeFigureOut">
               <a:rPr lang="en-US" smtClean="0"/>
-              <a:t>1/27/13</a:t>
+              <a:t>3/26/26</a:t>
             </a:fld>
             <a:endParaRPr lang="en-US"/>
           </a:p>
@@ -2713,10 +2572,9 @@
           <a:lstStyle/>
           <a:p>
             <a:r>
-              <a:rPr lang="en-US" smtClean="0"/>
+              <a:rPr lang="en-US"/>
               <a:t>Click to edit Master title style</a:t>
             </a:r>
-            <a:endParaRPr lang="en-US"/>
           </a:p>
         </p:txBody>
       </p:sp>
@@ -2770,38 +2628,37 @@
           <a:p>
             <a:pPr lvl="0"/>
             <a:r>
-              <a:rPr lang="en-US" smtClean="0"/>
+              <a:rPr lang="en-US"/>
               <a:t>Click to edit Master text styles</a:t>
             </a:r>
           </a:p>
           <a:p>
             <a:pPr lvl="1"/>
             <a:r>
-              <a:rPr lang="en-US" smtClean="0"/>
+              <a:rPr lang="en-US"/>
               <a:t>Second level</a:t>
             </a:r>
           </a:p>
           <a:p>
             <a:pPr lvl="2"/>
             <a:r>
-              <a:rPr lang="en-US" smtClean="0"/>
+              <a:rPr lang="en-US"/>
               <a:t>Third level</a:t>
             </a:r>
           </a:p>
           <a:p>
             <a:pPr lvl="3"/>
             <a:r>
-              <a:rPr lang="en-US" smtClean="0"/>
+              <a:rPr lang="en-US"/>
               <a:t>Fourth level</a:t>
             </a:r>
           </a:p>
           <a:p>
             <a:pPr lvl="4"/>
             <a:r>
-              <a:rPr lang="en-US" smtClean="0"/>
+              <a:rPr lang="en-US"/>
               <a:t>Fifth level</a:t>
             </a:r>
-            <a:endParaRPr lang="en-US"/>
           </a:p>
         </p:txBody>
       </p:sp>
@@ -2855,38 +2712,37 @@
           <a:p>
             <a:pPr lvl="0"/>
             <a:r>
-              <a:rPr lang="en-US" smtClean="0"/>
+              <a:rPr lang="en-US"/>
               <a:t>Click to edit Master text styles</a:t>
             </a:r>
           </a:p>
           <a:p>
             <a:pPr lvl="1"/>
             <a:r>
-              <a:rPr lang="en-US" smtClean="0"/>
+              <a:rPr lang="en-US"/>
               <a:t>Second level</a:t>
             </a:r>
           </a:p>
           <a:p>
             <a:pPr lvl="2"/>
             <a:r>
-              <a:rPr lang="en-US" smtClean="0"/>
+              <a:rPr lang="en-US"/>
               <a:t>Third level</a:t>
             </a:r>
           </a:p>
           <a:p>
             <a:pPr lvl="3"/>
             <a:r>
-              <a:rPr lang="en-US" smtClean="0"/>
+              <a:rPr lang="en-US"/>
               <a:t>Fourth level</a:t>
             </a:r>
           </a:p>
           <a:p>
             <a:pPr lvl="4"/>
             <a:r>
-              <a:rPr lang="en-US" smtClean="0"/>
+              <a:rPr lang="en-US"/>
               <a:t>Fifth level</a:t>
             </a:r>
-            <a:endParaRPr lang="en-US"/>
           </a:p>
         </p:txBody>
       </p:sp>
@@ -2907,7 +2763,7 @@
           <a:p>
             <a:fld id="{5BCAD085-E8A6-8845-BD4E-CB4CCA059FC4}" type="datetimeFigureOut">
               <a:rPr lang="en-US" smtClean="0"/>
-              <a:t>1/27/13</a:t>
+              <a:t>3/26/26</a:t>
             </a:fld>
             <a:endParaRPr lang="en-US"/>
           </a:p>
@@ -3005,10 +2861,9 @@
           </a:lstStyle>
           <a:p>
             <a:r>
-              <a:rPr lang="en-US" smtClean="0"/>
+              <a:rPr lang="en-US"/>
               <a:t>Click to edit Master title style</a:t>
             </a:r>
-            <a:endParaRPr lang="en-US"/>
           </a:p>
         </p:txBody>
       </p:sp>
@@ -3071,7 +2926,7 @@
           <a:p>
             <a:pPr lvl="0"/>
             <a:r>
-              <a:rPr lang="en-US" smtClean="0"/>
+              <a:rPr lang="en-US"/>
               <a:t>Click to edit Master text styles</a:t>
             </a:r>
           </a:p>
@@ -3127,38 +2982,37 @@
           <a:p>
             <a:pPr lvl="0"/>
             <a:r>
-              <a:rPr lang="en-US" smtClean="0"/>
+              <a:rPr lang="en-US"/>
               <a:t>Click to edit Master text styles</a:t>
             </a:r>
           </a:p>
           <a:p>
             <a:pPr lvl="1"/>
             <a:r>
-              <a:rPr lang="en-US" smtClean="0"/>
+              <a:rPr lang="en-US"/>
               <a:t>Second level</a:t>
             </a:r>
           </a:p>
           <a:p>
             <a:pPr lvl="2"/>
             <a:r>
-              <a:rPr lang="en-US" smtClean="0"/>
+              <a:rPr lang="en-US"/>
               <a:t>Third level</a:t>
             </a:r>
           </a:p>
           <a:p>
             <a:pPr lvl="3"/>
             <a:r>
-              <a:rPr lang="en-US" smtClean="0"/>
+              <a:rPr lang="en-US"/>
               <a:t>Fourth level</a:t>
             </a:r>
           </a:p>
           <a:p>
             <a:pPr lvl="4"/>
             <a:r>
-              <a:rPr lang="en-US" smtClean="0"/>
+              <a:rPr lang="en-US"/>
               <a:t>Fifth level</a:t>
             </a:r>
-            <a:endParaRPr lang="en-US"/>
           </a:p>
         </p:txBody>
       </p:sp>
@@ -3221,7 +3075,7 @@
           <a:p>
             <a:pPr lvl="0"/>
             <a:r>
-              <a:rPr lang="en-US" smtClean="0"/>
+              <a:rPr lang="en-US"/>
               <a:t>Click to edit Master text styles</a:t>
             </a:r>
           </a:p>
@@ -3277,38 +3131,37 @@
           <a:p>
             <a:pPr lvl="0"/>
             <a:r>
-              <a:rPr lang="en-US" smtClean="0"/>
+              <a:rPr lang="en-US"/>
               <a:t>Click to edit Master text styles</a:t>
             </a:r>
           </a:p>
           <a:p>
             <a:pPr lvl="1"/>
             <a:r>
-              <a:rPr lang="en-US" smtClean="0"/>
+              <a:rPr lang="en-US"/>
               <a:t>Second level</a:t>
             </a:r>
           </a:p>
           <a:p>
             <a:pPr lvl="2"/>
             <a:r>
-              <a:rPr lang="en-US" smtClean="0"/>
+              <a:rPr lang="en-US"/>
               <a:t>Third level</a:t>
             </a:r>
           </a:p>
           <a:p>
             <a:pPr lvl="3"/>
             <a:r>
-              <a:rPr lang="en-US" smtClean="0"/>
+              <a:rPr lang="en-US"/>
               <a:t>Fourth level</a:t>
             </a:r>
           </a:p>
           <a:p>
             <a:pPr lvl="4"/>
             <a:r>
-              <a:rPr lang="en-US" smtClean="0"/>
+              <a:rPr lang="en-US"/>
               <a:t>Fifth level</a:t>
             </a:r>
-            <a:endParaRPr lang="en-US"/>
           </a:p>
         </p:txBody>
       </p:sp>
@@ -3329,7 +3182,7 @@
           <a:p>
             <a:fld id="{5BCAD085-E8A6-8845-BD4E-CB4CCA059FC4}" type="datetimeFigureOut">
               <a:rPr lang="en-US" smtClean="0"/>
-              <a:t>1/27/13</a:t>
+              <a:t>3/26/26</a:t>
             </a:fld>
             <a:endParaRPr lang="en-US"/>
           </a:p>
@@ -3423,10 +3276,9 @@
           <a:lstStyle/>
           <a:p>
             <a:r>
-              <a:rPr lang="en-US" smtClean="0"/>
+              <a:rPr lang="en-US"/>
               <a:t>Click to edit Master title style</a:t>
             </a:r>
-            <a:endParaRPr lang="en-US"/>
           </a:p>
         </p:txBody>
       </p:sp>
@@ -3447,7 +3299,7 @@
           <a:p>
             <a:fld id="{5BCAD085-E8A6-8845-BD4E-CB4CCA059FC4}" type="datetimeFigureOut">
               <a:rPr lang="en-US" smtClean="0"/>
-              <a:t>1/27/13</a:t>
+              <a:t>3/26/26</a:t>
             </a:fld>
             <a:endParaRPr lang="en-US"/>
           </a:p>
@@ -3542,7 +3394,7 @@
           <a:p>
             <a:fld id="{5BCAD085-E8A6-8845-BD4E-CB4CCA059FC4}" type="datetimeFigureOut">
               <a:rPr lang="en-US" smtClean="0"/>
-              <a:t>1/27/13</a:t>
+              <a:t>3/26/26</a:t>
             </a:fld>
             <a:endParaRPr lang="en-US"/>
           </a:p>
@@ -3645,10 +3497,9 @@
           </a:lstStyle>
           <a:p>
             <a:r>
-              <a:rPr lang="en-US" smtClean="0"/>
+              <a:rPr lang="en-US"/>
               <a:t>Click to edit Master title style</a:t>
             </a:r>
-            <a:endParaRPr lang="en-US"/>
           </a:p>
         </p:txBody>
       </p:sp>
@@ -3702,38 +3553,37 @@
           <a:p>
             <a:pPr lvl="0"/>
             <a:r>
-              <a:rPr lang="en-US" smtClean="0"/>
+              <a:rPr lang="en-US"/>
               <a:t>Click to edit Master text styles</a:t>
             </a:r>
           </a:p>
           <a:p>
             <a:pPr lvl="1"/>
             <a:r>
-              <a:rPr lang="en-US" smtClean="0"/>
+              <a:rPr lang="en-US"/>
               <a:t>Second level</a:t>
             </a:r>
           </a:p>
           <a:p>
             <a:pPr lvl="2"/>
             <a:r>
-              <a:rPr lang="en-US" smtClean="0"/>
+              <a:rPr lang="en-US"/>
               <a:t>Third level</a:t>
             </a:r>
           </a:p>
           <a:p>
             <a:pPr lvl="3"/>
             <a:r>
-              <a:rPr lang="en-US" smtClean="0"/>
+              <a:rPr lang="en-US"/>
               <a:t>Fourth level</a:t>
             </a:r>
           </a:p>
           <a:p>
             <a:pPr lvl="4"/>
             <a:r>
-              <a:rPr lang="en-US" smtClean="0"/>
+              <a:rPr lang="en-US"/>
               <a:t>Fifth level</a:t>
             </a:r>
-            <a:endParaRPr lang="en-US"/>
           </a:p>
         </p:txBody>
       </p:sp>
@@ -3796,7 +3646,7 @@
           <a:p>
             <a:pPr lvl="0"/>
             <a:r>
-              <a:rPr lang="en-US" smtClean="0"/>
+              <a:rPr lang="en-US"/>
               <a:t>Click to edit Master text styles</a:t>
             </a:r>
           </a:p>
@@ -3819,7 +3669,7 @@
           <a:p>
             <a:fld id="{5BCAD085-E8A6-8845-BD4E-CB4CCA059FC4}" type="datetimeFigureOut">
               <a:rPr lang="en-US" smtClean="0"/>
-              <a:t>1/27/13</a:t>
+              <a:t>3/26/26</a:t>
             </a:fld>
             <a:endParaRPr lang="en-US"/>
           </a:p>
@@ -3922,10 +3772,9 @@
           </a:lstStyle>
           <a:p>
             <a:r>
-              <a:rPr lang="en-US" smtClean="0"/>
+              <a:rPr lang="en-US"/>
               <a:t>Click to edit Master title style</a:t>
             </a:r>
-            <a:endParaRPr lang="en-US"/>
           </a:p>
         </p:txBody>
       </p:sp>
@@ -4049,7 +3898,7 @@
           <a:p>
             <a:pPr lvl="0"/>
             <a:r>
-              <a:rPr lang="en-US" smtClean="0"/>
+              <a:rPr lang="en-US"/>
               <a:t>Click to edit Master text styles</a:t>
             </a:r>
           </a:p>
@@ -4072,7 +3921,7 @@
           <a:p>
             <a:fld id="{5BCAD085-E8A6-8845-BD4E-CB4CCA059FC4}" type="datetimeFigureOut">
               <a:rPr lang="en-US" smtClean="0"/>
-              <a:t>1/27/13</a:t>
+              <a:t>3/26/26</a:t>
             </a:fld>
             <a:endParaRPr lang="en-US"/>
           </a:p>
@@ -4181,10 +4030,9 @@
           <a:lstStyle/>
           <a:p>
             <a:r>
-              <a:rPr lang="en-US" smtClean="0"/>
+              <a:rPr lang="en-US"/>
               <a:t>Click to edit Master title style</a:t>
             </a:r>
-            <a:endParaRPr lang="en-US"/>
           </a:p>
         </p:txBody>
       </p:sp>
@@ -4215,38 +4063,37 @@
           <a:p>
             <a:pPr lvl="0"/>
             <a:r>
-              <a:rPr lang="en-US" smtClean="0"/>
+              <a:rPr lang="en-US"/>
               <a:t>Click to edit Master text styles</a:t>
             </a:r>
           </a:p>
           <a:p>
             <a:pPr lvl="1"/>
             <a:r>
-              <a:rPr lang="en-US" smtClean="0"/>
+              <a:rPr lang="en-US"/>
               <a:t>Second level</a:t>
             </a:r>
           </a:p>
           <a:p>
             <a:pPr lvl="2"/>
             <a:r>
-              <a:rPr lang="en-US" smtClean="0"/>
+              <a:rPr lang="en-US"/>
               <a:t>Third level</a:t>
             </a:r>
           </a:p>
           <a:p>
             <a:pPr lvl="3"/>
             <a:r>
-              <a:rPr lang="en-US" smtClean="0"/>
+              <a:rPr lang="en-US"/>
               <a:t>Fourth level</a:t>
             </a:r>
           </a:p>
           <a:p>
             <a:pPr lvl="4"/>
             <a:r>
-              <a:rPr lang="en-US" smtClean="0"/>
+              <a:rPr lang="en-US"/>
               <a:t>Fifth level</a:t>
             </a:r>
-            <a:endParaRPr lang="en-US"/>
           </a:p>
         </p:txBody>
       </p:sp>
@@ -4285,7 +4132,7 @@
           <a:p>
             <a:fld id="{5BCAD085-E8A6-8845-BD4E-CB4CCA059FC4}" type="datetimeFigureOut">
               <a:rPr lang="en-US" smtClean="0"/>
-              <a:t>1/27/13</a:t>
+              <a:t>3/26/26</a:t>
             </a:fld>
             <a:endParaRPr lang="en-US"/>
           </a:p>
@@ -4644,7 +4491,7 @@
 </file>
 
 <file path=ppt/slides/slide1.xml><?xml version="1.0" encoding="utf-8"?>
-<p:sld xmlns:a="http://schemas.openxmlformats.org/drawingml/2006/main" xmlns:p="http://schemas.openxmlformats.org/presentationml/2006/main" xmlns:r="http://schemas.openxmlformats.org/officeDocument/2006/relationships">
+<p:sld xmlns:a="http://schemas.openxmlformats.org/drawingml/2006/main" xmlns:r="http://schemas.openxmlformats.org/officeDocument/2006/relationships" xmlns:p="http://schemas.openxmlformats.org/presentationml/2006/main">
   <p:cSld>
     <p:bg>
       <p:bgPr>
@@ -4660,7 +4507,14 @@
         <p:cNvGrpSpPr/>
         <p:nvPr/>
       </p:nvGrpSpPr>
-      <p:grpSpPr/>
+      <p:grpSpPr>
+        <a:xfrm>
+          <a:off x="0" y="0"/>
+          <a:ext cx="0" cy="0"/>
+          <a:chOff x="0" y="0"/>
+          <a:chExt cx="0" cy="0"/>
+        </a:xfrm>
+      </p:grpSpPr>
       <p:sp>
         <p:nvSpPr>
           <p:cNvPr id="2" name="TextBox 1"/>
@@ -4810,7 +4664,7 @@
         <p:spPr>
           <a:xfrm>
             <a:off x="914400" y="4572000"/>
-            <a:ext cx="10058400" cy="457200"/>
+            <a:ext cx="10058400" cy="338554"/>
           </a:xfrm>
           <a:prstGeom prst="rect">
             <a:avLst/>
@@ -4831,7 +4685,24 @@
               </a:defRPr>
             </a:pPr>
             <a:r>
-              <a:t>Advisor: Dr. Yingying Kang (Assurant)</a:t>
+              <a:rPr dirty="0"/>
+              <a:t>Advisor: </a:t>
+            </a:r>
+            <a:r>
+              <a:rPr lang="en-US" dirty="0"/>
+              <a:t>Prof. </a:t>
+            </a:r>
+            <a:r>
+              <a:rPr lang="en-US" dirty="0" err="1"/>
+              <a:t>Agichtein</a:t>
+            </a:r>
+            <a:r>
+              <a:rPr lang="en-US" dirty="0"/>
+              <a:t>, Eugene, </a:t>
+            </a:r>
+            <a:r>
+              <a:rPr dirty="0"/>
+              <a:t>Dr. Yingying Kang (Assurant)</a:t>
             </a:r>
           </a:p>
         </p:txBody>
@@ -4845,7 +4716,7 @@
 </file>
 
 <file path=ppt/slides/slide10.xml><?xml version="1.0" encoding="utf-8"?>
-<p:sld xmlns:a="http://schemas.openxmlformats.org/drawingml/2006/main" xmlns:p="http://schemas.openxmlformats.org/presentationml/2006/main" xmlns:r="http://schemas.openxmlformats.org/officeDocument/2006/relationships">
+<p:sld xmlns:a="http://schemas.openxmlformats.org/drawingml/2006/main" xmlns:r="http://schemas.openxmlformats.org/officeDocument/2006/relationships" xmlns:p="http://schemas.openxmlformats.org/presentationml/2006/main">
   <p:cSld>
     <p:bg>
       <p:bgPr>
@@ -4861,7 +4732,14 @@
         <p:cNvGrpSpPr/>
         <p:nvPr/>
       </p:nvGrpSpPr>
-      <p:grpSpPr/>
+      <p:grpSpPr>
+        <a:xfrm>
+          <a:off x="0" y="0"/>
+          <a:ext cx="0" cy="0"/>
+          <a:chOff x="0" y="0"/>
+          <a:chExt cx="0" cy="0"/>
+        </a:xfrm>
+      </p:grpSpPr>
       <p:sp>
         <p:nvSpPr>
           <p:cNvPr id="2" name="TextBox 1"/>
@@ -4905,7 +4783,7 @@
         </p:nvSpPr>
         <p:spPr>
           <a:xfrm>
-            <a:off x="731520" y="914400"/>
+            <a:off x="685800" y="1005840"/>
             <a:ext cx="5303520" cy="1188720"/>
           </a:xfrm>
           <a:prstGeom prst="roundRect">
@@ -4939,6 +4817,7 @@
           <a:lstStyle/>
           <a:p>
             <a:pPr algn="ctr"/>
+            <a:endParaRPr/>
           </a:p>
         </p:txBody>
       </p:sp>
@@ -4986,6 +4865,7 @@
                 </a:solidFill>
               </a:defRPr>
             </a:pPr>
+            <a:endParaRPr/>
           </a:p>
           <a:p>
             <a:pPr>
@@ -5027,7 +4907,7 @@
         </p:nvSpPr>
         <p:spPr>
           <a:xfrm>
-            <a:off x="6400800" y="914400"/>
+            <a:off x="6400799" y="1005840"/>
             <a:ext cx="5303520" cy="1188720"/>
           </a:xfrm>
           <a:prstGeom prst="roundRect">
@@ -5061,6 +4941,7 @@
           <a:lstStyle/>
           <a:p>
             <a:pPr algn="ctr"/>
+            <a:endParaRPr/>
           </a:p>
         </p:txBody>
       </p:sp>
@@ -5094,6 +4975,7 @@
               </a:defRPr>
             </a:pPr>
             <a:r>
+              <a:rPr dirty="0"/>
               <a:t>Graph F1 -- Does the HIERARCHY align?</a:t>
             </a:r>
           </a:p>
@@ -5108,6 +4990,7 @@
                 </a:solidFill>
               </a:defRPr>
             </a:pPr>
+            <a:endParaRPr dirty="0"/>
           </a:p>
           <a:p>
             <a:pPr>
@@ -5121,6 +5004,7 @@
               </a:defRPr>
             </a:pPr>
             <a:r>
+              <a:rPr dirty="0"/>
               <a:t>Propagate embeddings through SUBCLASS_OF edges (2 hops)</a:t>
             </a:r>
           </a:p>
@@ -5136,6 +5020,7 @@
               </a:defRPr>
             </a:pPr>
             <a:r>
+              <a:rPr dirty="0"/>
               <a:t>'Peril' SUBCLASS_OF 'Risk' gets credit through graph proximity</a:t>
             </a:r>
           </a:p>
@@ -5149,7 +5034,7 @@
         </p:nvSpPr>
         <p:spPr>
           <a:xfrm>
-            <a:off x="731520" y="2377440"/>
+            <a:off x="731520" y="2423160"/>
             <a:ext cx="5303520" cy="1188720"/>
           </a:xfrm>
           <a:prstGeom prst="roundRect">
@@ -5183,6 +5068,7 @@
           <a:lstStyle/>
           <a:p>
             <a:pPr algn="ctr"/>
+            <a:endParaRPr dirty="0"/>
           </a:p>
         </p:txBody>
       </p:sp>
@@ -5230,6 +5116,7 @@
                 </a:solidFill>
               </a:defRPr>
             </a:pPr>
+            <a:endParaRPr/>
           </a:p>
           <a:p>
             <a:pPr>
@@ -5271,7 +5158,7 @@
         </p:nvSpPr>
         <p:spPr>
           <a:xfrm>
-            <a:off x="6400800" y="2377440"/>
+            <a:off x="6400799" y="2423160"/>
             <a:ext cx="5303520" cy="1188720"/>
           </a:xfrm>
           <a:prstGeom prst="roundRect">
@@ -5305,6 +5192,7 @@
           <a:lstStyle/>
           <a:p>
             <a:pPr algn="ctr"/>
+            <a:endParaRPr/>
           </a:p>
         </p:txBody>
       </p:sp>
@@ -5352,6 +5240,7 @@
                 </a:solidFill>
               </a:defRPr>
             </a:pPr>
+            <a:endParaRPr/>
           </a:p>
           <a:p>
             <a:pPr>
@@ -5484,6 +5373,7 @@
                 </a:solidFill>
               </a:defRPr>
             </a:pPr>
+            <a:endParaRPr/>
           </a:p>
         </p:txBody>
       </p:sp>
@@ -6021,7 +5911,7 @@
 </file>
 
 <file path=ppt/slides/slide11.xml><?xml version="1.0" encoding="utf-8"?>
-<p:sld xmlns:a="http://schemas.openxmlformats.org/drawingml/2006/main" xmlns:p="http://schemas.openxmlformats.org/presentationml/2006/main" xmlns:r="http://schemas.openxmlformats.org/officeDocument/2006/relationships">
+<p:sld xmlns:a="http://schemas.openxmlformats.org/drawingml/2006/main" xmlns:r="http://schemas.openxmlformats.org/officeDocument/2006/relationships" xmlns:p="http://schemas.openxmlformats.org/presentationml/2006/main">
   <p:cSld>
     <p:bg>
       <p:bgPr>
@@ -6037,7 +5927,14 @@
         <p:cNvGrpSpPr/>
         <p:nvPr/>
       </p:nvGrpSpPr>
-      <p:grpSpPr/>
+      <p:grpSpPr>
+        <a:xfrm>
+          <a:off x="0" y="0"/>
+          <a:ext cx="0" cy="0"/>
+          <a:chOff x="0" y="0"/>
+          <a:chExt cx="0" cy="0"/>
+        </a:xfrm>
+      </p:grpSpPr>
       <p:sp>
         <p:nvSpPr>
           <p:cNvPr id="2" name="TextBox 1"/>
@@ -7657,7 +7554,7 @@
 </file>
 
 <file path=ppt/slides/slide12.xml><?xml version="1.0" encoding="utf-8"?>
-<p:sld xmlns:a="http://schemas.openxmlformats.org/drawingml/2006/main" xmlns:p="http://schemas.openxmlformats.org/presentationml/2006/main" xmlns:r="http://schemas.openxmlformats.org/officeDocument/2006/relationships">
+<p:sld xmlns:a="http://schemas.openxmlformats.org/drawingml/2006/main" xmlns:r="http://schemas.openxmlformats.org/officeDocument/2006/relationships" xmlns:p="http://schemas.openxmlformats.org/presentationml/2006/main">
   <p:cSld>
     <p:bg>
       <p:bgPr>
@@ -7673,7 +7570,14 @@
         <p:cNvGrpSpPr/>
         <p:nvPr/>
       </p:nvGrpSpPr>
-      <p:grpSpPr/>
+      <p:grpSpPr>
+        <a:xfrm>
+          <a:off x="0" y="0"/>
+          <a:ext cx="0" cy="0"/>
+          <a:chOff x="0" y="0"/>
+          <a:chExt cx="0" cy="0"/>
+        </a:xfrm>
+      </p:grpSpPr>
       <p:sp>
         <p:nvSpPr>
           <p:cNvPr id="2" name="TextBox 1"/>
@@ -8068,7 +7972,7 @@
 </file>
 
 <file path=ppt/slides/slide13.xml><?xml version="1.0" encoding="utf-8"?>
-<p:sld xmlns:a="http://schemas.openxmlformats.org/drawingml/2006/main" xmlns:p="http://schemas.openxmlformats.org/presentationml/2006/main" xmlns:r="http://schemas.openxmlformats.org/officeDocument/2006/relationships">
+<p:sld xmlns:a="http://schemas.openxmlformats.org/drawingml/2006/main" xmlns:r="http://schemas.openxmlformats.org/officeDocument/2006/relationships" xmlns:p="http://schemas.openxmlformats.org/presentationml/2006/main">
   <p:cSld>
     <p:bg>
       <p:bgPr>
@@ -8084,7 +7988,14 @@
         <p:cNvGrpSpPr/>
         <p:nvPr/>
       </p:nvGrpSpPr>
-      <p:grpSpPr/>
+      <p:grpSpPr>
+        <a:xfrm>
+          <a:off x="0" y="0"/>
+          <a:ext cx="0" cy="0"/>
+          <a:chOff x="0" y="0"/>
+          <a:chExt cx="0" cy="0"/>
+        </a:xfrm>
+      </p:grpSpPr>
       <p:sp>
         <p:nvSpPr>
           <p:cNvPr id="2" name="TextBox 1"/>
@@ -8479,7 +8390,7 @@
 </file>
 
 <file path=ppt/slides/slide14.xml><?xml version="1.0" encoding="utf-8"?>
-<p:sld xmlns:a="http://schemas.openxmlformats.org/drawingml/2006/main" xmlns:p="http://schemas.openxmlformats.org/presentationml/2006/main" xmlns:r="http://schemas.openxmlformats.org/officeDocument/2006/relationships">
+<p:sld xmlns:a="http://schemas.openxmlformats.org/drawingml/2006/main" xmlns:r="http://schemas.openxmlformats.org/officeDocument/2006/relationships" xmlns:p="http://schemas.openxmlformats.org/presentationml/2006/main">
   <p:cSld>
     <p:bg>
       <p:bgPr>
@@ -8495,7 +8406,14 @@
         <p:cNvGrpSpPr/>
         <p:nvPr/>
       </p:nvGrpSpPr>
-      <p:grpSpPr/>
+      <p:grpSpPr>
+        <a:xfrm>
+          <a:off x="0" y="0"/>
+          <a:ext cx="0" cy="0"/>
+          <a:chOff x="0" y="0"/>
+          <a:chExt cx="0" cy="0"/>
+        </a:xfrm>
+      </p:grpSpPr>
       <p:sp>
         <p:nvSpPr>
           <p:cNvPr id="2" name="TextBox 1"/>
@@ -8630,6 +8548,7 @@
                 </a:solidFill>
               </a:defRPr>
             </a:pPr>
+            <a:endParaRPr/>
           </a:p>
           <a:p>
             <a:pPr>
@@ -8687,7 +8606,7 @@
 </file>
 
 <file path=ppt/slides/slide2.xml><?xml version="1.0" encoding="utf-8"?>
-<p:sld xmlns:a="http://schemas.openxmlformats.org/drawingml/2006/main" xmlns:p="http://schemas.openxmlformats.org/presentationml/2006/main" xmlns:r="http://schemas.openxmlformats.org/officeDocument/2006/relationships">
+<p:sld xmlns:a="http://schemas.openxmlformats.org/drawingml/2006/main" xmlns:r="http://schemas.openxmlformats.org/officeDocument/2006/relationships" xmlns:p="http://schemas.openxmlformats.org/presentationml/2006/main">
   <p:cSld>
     <p:bg>
       <p:bgPr>
@@ -8703,7 +8622,14 @@
         <p:cNvGrpSpPr/>
         <p:nvPr/>
       </p:nvGrpSpPr>
-      <p:grpSpPr/>
+      <p:grpSpPr>
+        <a:xfrm>
+          <a:off x="0" y="0"/>
+          <a:ext cx="0" cy="0"/>
+          <a:chOff x="0" y="0"/>
+          <a:chExt cx="0" cy="0"/>
+        </a:xfrm>
+      </p:grpSpPr>
       <p:sp>
         <p:nvSpPr>
           <p:cNvPr id="2" name="TextBox 1"/>
@@ -8783,6 +8709,7 @@
                 </a:solidFill>
               </a:defRPr>
             </a:pPr>
+            <a:endParaRPr/>
           </a:p>
           <a:p>
             <a:pPr>
@@ -8840,6 +8767,7 @@
                 </a:solidFill>
               </a:defRPr>
             </a:pPr>
+            <a:endParaRPr/>
           </a:p>
           <a:p>
             <a:pPr>
@@ -8947,6 +8875,7 @@
                 </a:solidFill>
               </a:defRPr>
             </a:pPr>
+            <a:endParaRPr/>
           </a:p>
           <a:p>
             <a:pPr>
@@ -8974,6 +8903,7 @@
                 </a:solidFill>
               </a:defRPr>
             </a:pPr>
+            <a:endParaRPr/>
           </a:p>
           <a:p>
             <a:pPr>
@@ -9061,6 +8991,7 @@
                 </a:solidFill>
               </a:defRPr>
             </a:pPr>
+            <a:endParaRPr/>
           </a:p>
           <a:p>
             <a:pPr>
@@ -9123,7 +9054,7 @@
 </file>
 
 <file path=ppt/slides/slide3.xml><?xml version="1.0" encoding="utf-8"?>
-<p:sld xmlns:a="http://schemas.openxmlformats.org/drawingml/2006/main" xmlns:p="http://schemas.openxmlformats.org/presentationml/2006/main" xmlns:r="http://schemas.openxmlformats.org/officeDocument/2006/relationships">
+<p:sld xmlns:a="http://schemas.openxmlformats.org/drawingml/2006/main" xmlns:r="http://schemas.openxmlformats.org/officeDocument/2006/relationships" xmlns:p="http://schemas.openxmlformats.org/presentationml/2006/main">
   <p:cSld>
     <p:bg>
       <p:bgPr>
@@ -9139,7 +9070,14 @@
         <p:cNvGrpSpPr/>
         <p:nvPr/>
       </p:nvGrpSpPr>
-      <p:grpSpPr/>
+      <p:grpSpPr>
+        <a:xfrm>
+          <a:off x="0" y="0"/>
+          <a:ext cx="0" cy="0"/>
+          <a:chOff x="0" y="0"/>
+          <a:chExt cx="0" cy="0"/>
+        </a:xfrm>
+      </p:grpSpPr>
       <p:sp>
         <p:nvSpPr>
           <p:cNvPr id="2" name="TextBox 1"/>
@@ -9217,6 +9155,7 @@
           <a:lstStyle/>
           <a:p>
             <a:pPr algn="ctr"/>
+            <a:endParaRPr/>
           </a:p>
         </p:txBody>
       </p:sp>
@@ -9264,6 +9203,7 @@
                 </a:solidFill>
               </a:defRPr>
             </a:pPr>
+            <a:endParaRPr/>
           </a:p>
           <a:p>
             <a:pPr>
@@ -9291,6 +9231,7 @@
                 </a:solidFill>
               </a:defRPr>
             </a:pPr>
+            <a:endParaRPr/>
           </a:p>
           <a:p>
             <a:pPr>
@@ -9363,6 +9304,7 @@
                 </a:solidFill>
               </a:defRPr>
             </a:pPr>
+            <a:endParaRPr/>
           </a:p>
           <a:p>
             <a:pPr>
@@ -9423,6 +9365,7 @@
           <a:lstStyle/>
           <a:p>
             <a:pPr algn="ctr"/>
+            <a:endParaRPr/>
           </a:p>
         </p:txBody>
       </p:sp>
@@ -9470,6 +9413,7 @@
                 </a:solidFill>
               </a:defRPr>
             </a:pPr>
+            <a:endParaRPr/>
           </a:p>
           <a:p>
             <a:pPr>
@@ -9497,6 +9441,7 @@
                 </a:solidFill>
               </a:defRPr>
             </a:pPr>
+            <a:endParaRPr/>
           </a:p>
           <a:p>
             <a:pPr>
@@ -9569,6 +9514,7 @@
                 </a:solidFill>
               </a:defRPr>
             </a:pPr>
+            <a:endParaRPr/>
           </a:p>
           <a:p>
             <a:pPr>
@@ -9629,6 +9575,7 @@
           <a:lstStyle/>
           <a:p>
             <a:pPr algn="ctr"/>
+            <a:endParaRPr/>
           </a:p>
         </p:txBody>
       </p:sp>
@@ -9676,6 +9623,7 @@
                 </a:solidFill>
               </a:defRPr>
             </a:pPr>
+            <a:endParaRPr/>
           </a:p>
           <a:p>
             <a:pPr>
@@ -9703,6 +9651,7 @@
                 </a:solidFill>
               </a:defRPr>
             </a:pPr>
+            <a:endParaRPr/>
           </a:p>
           <a:p>
             <a:pPr>
@@ -9775,6 +9724,7 @@
                 </a:solidFill>
               </a:defRPr>
             </a:pPr>
+            <a:endParaRPr/>
           </a:p>
           <a:p>
             <a:pPr>
@@ -9872,7 +9822,7 @@
 </file>
 
 <file path=ppt/slides/slide4.xml><?xml version="1.0" encoding="utf-8"?>
-<p:sld xmlns:a="http://schemas.openxmlformats.org/drawingml/2006/main" xmlns:p="http://schemas.openxmlformats.org/presentationml/2006/main" xmlns:r="http://schemas.openxmlformats.org/officeDocument/2006/relationships">
+<p:sld xmlns:a="http://schemas.openxmlformats.org/drawingml/2006/main" xmlns:r="http://schemas.openxmlformats.org/officeDocument/2006/relationships" xmlns:p="http://schemas.openxmlformats.org/presentationml/2006/main">
   <p:cSld>
     <p:bg>
       <p:bgPr>
@@ -9888,7 +9838,14 @@
         <p:cNvGrpSpPr/>
         <p:nvPr/>
       </p:nvGrpSpPr>
-      <p:grpSpPr/>
+      <p:grpSpPr>
+        <a:xfrm>
+          <a:off x="0" y="0"/>
+          <a:ext cx="0" cy="0"/>
+          <a:chOff x="0" y="0"/>
+          <a:chExt cx="0" cy="0"/>
+        </a:xfrm>
+      </p:grpSpPr>
       <p:sp>
         <p:nvSpPr>
           <p:cNvPr id="2" name="TextBox 1"/>
@@ -9966,6 +9923,7 @@
           <a:lstStyle/>
           <a:p>
             <a:pPr algn="ctr"/>
+            <a:endParaRPr/>
           </a:p>
         </p:txBody>
       </p:sp>
@@ -10159,6 +10117,7 @@
           <a:lstStyle/>
           <a:p>
             <a:pPr algn="ctr"/>
+            <a:endParaRPr/>
           </a:p>
         </p:txBody>
       </p:sp>
@@ -10352,6 +10311,7 @@
           <a:lstStyle/>
           <a:p>
             <a:pPr algn="ctr"/>
+            <a:endParaRPr/>
           </a:p>
         </p:txBody>
       </p:sp>
@@ -10549,6 +10509,7 @@
           <a:lstStyle/>
           <a:p>
             <a:pPr algn="ctr"/>
+            <a:endParaRPr/>
           </a:p>
         </p:txBody>
       </p:sp>
@@ -10707,6 +10668,7 @@
           <a:lstStyle/>
           <a:p>
             <a:pPr algn="ctr"/>
+            <a:endParaRPr/>
           </a:p>
         </p:txBody>
       </p:sp>
@@ -10824,7 +10786,7 @@
 </file>
 
 <file path=ppt/slides/slide5.xml><?xml version="1.0" encoding="utf-8"?>
-<p:sld xmlns:a="http://schemas.openxmlformats.org/drawingml/2006/main" xmlns:p="http://schemas.openxmlformats.org/presentationml/2006/main" xmlns:r="http://schemas.openxmlformats.org/officeDocument/2006/relationships">
+<p:sld xmlns:a="http://schemas.openxmlformats.org/drawingml/2006/main" xmlns:r="http://schemas.openxmlformats.org/officeDocument/2006/relationships" xmlns:p="http://schemas.openxmlformats.org/presentationml/2006/main">
   <p:cSld>
     <p:bg>
       <p:bgPr>
@@ -10840,7 +10802,14 @@
         <p:cNvGrpSpPr/>
         <p:nvPr/>
       </p:nvGrpSpPr>
-      <p:grpSpPr/>
+      <p:grpSpPr>
+        <a:xfrm>
+          <a:off x="0" y="0"/>
+          <a:ext cx="0" cy="0"/>
+          <a:chOff x="0" y="0"/>
+          <a:chExt cx="0" cy="0"/>
+        </a:xfrm>
+      </p:grpSpPr>
       <p:sp>
         <p:nvSpPr>
           <p:cNvPr id="2" name="TextBox 1"/>
@@ -11200,7 +11169,7 @@
         <p:spPr>
           <a:xfrm>
             <a:off x="731520" y="2834640"/>
-            <a:ext cx="5029200" cy="2286000"/>
+            <a:ext cx="5029200" cy="2436564"/>
           </a:xfrm>
           <a:prstGeom prst="rect">
             <a:avLst/>
@@ -11220,6 +11189,7 @@
                 </a:solidFill>
               </a:defRPr>
             </a:pPr>
+            <a:endParaRPr dirty="0"/>
           </a:p>
           <a:p>
             <a:pPr>
@@ -11233,6 +11203,7 @@
               </a:defRPr>
             </a:pPr>
             <a:r>
+              <a:rPr dirty="0"/>
               <a:t>Query Accuracy (20 Cypher questions):</a:t>
             </a:r>
           </a:p>
@@ -11248,6 +11219,7 @@
               </a:defRPr>
             </a:pPr>
             <a:r>
+              <a:rPr dirty="0"/>
               <a:t>Q: "What does Coverage A cover?"</a:t>
             </a:r>
           </a:p>
@@ -11263,6 +11235,7 @@
               </a:defRPr>
             </a:pPr>
             <a:r>
+              <a:rPr dirty="0"/>
               <a:t>Cypher query finds answer in graph</a:t>
             </a:r>
           </a:p>
@@ -11278,6 +11251,7 @@
               </a:defRPr>
             </a:pPr>
             <a:r>
+              <a:rPr dirty="0"/>
               <a:t>LLM grades: does answer mention 'building'?</a:t>
             </a:r>
           </a:p>
@@ -11293,8 +11267,59 @@
               </a:defRPr>
             </a:pPr>
             <a:r>
+              <a:rPr dirty="0"/>
               <a:t>19/20 correct = 95%</a:t>
             </a:r>
+            <a:endParaRPr lang="en-US" dirty="0"/>
+          </a:p>
+          <a:p>
+            <a:pPr>
+              <a:spcBef>
+                <a:spcPts val="400"/>
+              </a:spcBef>
+              <a:defRPr sz="1400" b="0">
+                <a:solidFill>
+                  <a:srgbClr val="00E676"/>
+                </a:solidFill>
+              </a:defRPr>
+            </a:pPr>
+            <a:r>
+              <a:rPr lang="en-US" sz="1400" b="1" dirty="0"/>
+              <a:t>Entity Coverage</a:t>
+            </a:r>
+          </a:p>
+          <a:p>
+            <a:pPr>
+              <a:spcBef>
+                <a:spcPts val="400"/>
+              </a:spcBef>
+              <a:defRPr sz="1400" b="0">
+                <a:solidFill>
+                  <a:srgbClr val="00E676"/>
+                </a:solidFill>
+              </a:defRPr>
+            </a:pPr>
+            <a:r>
+              <a:rPr lang="en-US" sz="1400" b="1" dirty="0"/>
+              <a:t>Triple Precision</a:t>
+            </a:r>
+          </a:p>
+          <a:p>
+            <a:pPr>
+              <a:spcBef>
+                <a:spcPts val="400"/>
+              </a:spcBef>
+              <a:defRPr sz="1400" b="0">
+                <a:solidFill>
+                  <a:srgbClr val="00E676"/>
+                </a:solidFill>
+              </a:defRPr>
+            </a:pPr>
+            <a:r>
+              <a:rPr lang="en-US" sz="1400" b="1" dirty="0"/>
+              <a:t>Fact Recall</a:t>
+            </a:r>
+            <a:endParaRPr dirty="0"/>
           </a:p>
         </p:txBody>
       </p:sp>
@@ -11327,6 +11352,7 @@
                 </a:solidFill>
               </a:defRPr>
             </a:pPr>
+            <a:endParaRPr dirty="0"/>
           </a:p>
           <a:p>
             <a:pPr>
@@ -11340,6 +11366,7 @@
               </a:defRPr>
             </a:pPr>
             <a:r>
+              <a:rPr dirty="0"/>
               <a:t>Model: qwen2.5:72b</a:t>
             </a:r>
           </a:p>
@@ -11355,6 +11382,7 @@
               </a:defRPr>
             </a:pPr>
             <a:r>
+              <a:rPr dirty="0"/>
               <a:t>Emory Turing (2x RTX 8000 48GB)</a:t>
             </a:r>
           </a:p>
@@ -11369,6 +11397,7 @@
                 </a:solidFill>
               </a:defRPr>
             </a:pPr>
+            <a:endParaRPr dirty="0"/>
           </a:p>
           <a:p>
             <a:pPr>
@@ -11382,6 +11411,7 @@
               </a:defRPr>
             </a:pPr>
             <a:r>
+              <a:rPr dirty="0"/>
               <a:t>Domain-agnostic bootstrapping:</a:t>
             </a:r>
           </a:p>
@@ -11397,6 +11427,7 @@
               </a:defRPr>
             </a:pPr>
             <a:r>
+              <a:rPr dirty="0"/>
               <a:t>LLM proposes 20 entity types from docs</a:t>
             </a:r>
           </a:p>
@@ -11412,6 +11443,7 @@
               </a:defRPr>
             </a:pPr>
             <a:r>
+              <a:rPr dirty="0"/>
               <a:t>LLM proposes 45 relation types from docs</a:t>
             </a:r>
           </a:p>
@@ -11427,6 +11459,7 @@
               </a:defRPr>
             </a:pPr>
             <a:r>
+              <a:rPr dirty="0"/>
               <a:t>Synthetic few-shot (not from source text)</a:t>
             </a:r>
           </a:p>
@@ -11476,7 +11509,7 @@
 </file>
 
 <file path=ppt/slides/slide6.xml><?xml version="1.0" encoding="utf-8"?>
-<p:sld xmlns:a="http://schemas.openxmlformats.org/drawingml/2006/main" xmlns:p="http://schemas.openxmlformats.org/presentationml/2006/main" xmlns:r="http://schemas.openxmlformats.org/officeDocument/2006/relationships">
+<p:sld xmlns:a="http://schemas.openxmlformats.org/drawingml/2006/main" xmlns:r="http://schemas.openxmlformats.org/officeDocument/2006/relationships" xmlns:p="http://schemas.openxmlformats.org/presentationml/2006/main">
   <p:cSld>
     <p:bg>
       <p:bgPr>
@@ -11492,7 +11525,14 @@
         <p:cNvGrpSpPr/>
         <p:nvPr/>
       </p:nvGrpSpPr>
-      <p:grpSpPr/>
+      <p:grpSpPr>
+        <a:xfrm>
+          <a:off x="0" y="0"/>
+          <a:ext cx="0" cy="0"/>
+          <a:chOff x="0" y="0"/>
+          <a:chExt cx="0" cy="0"/>
+        </a:xfrm>
+      </p:grpSpPr>
       <p:sp>
         <p:nvSpPr>
           <p:cNvPr id="2" name="TextBox 1"/>
@@ -11570,6 +11610,7 @@
           <a:lstStyle/>
           <a:p>
             <a:pPr algn="ctr"/>
+            <a:endParaRPr/>
           </a:p>
         </p:txBody>
       </p:sp>
@@ -11737,6 +11778,7 @@
           <a:lstStyle/>
           <a:p>
             <a:pPr algn="ctr"/>
+            <a:endParaRPr/>
           </a:p>
         </p:txBody>
       </p:sp>
@@ -11904,6 +11946,7 @@
           <a:lstStyle/>
           <a:p>
             <a:pPr algn="ctr"/>
+            <a:endParaRPr/>
           </a:p>
         </p:txBody>
       </p:sp>
@@ -12073,7 +12116,7 @@
 </file>
 
 <file path=ppt/slides/slide7.xml><?xml version="1.0" encoding="utf-8"?>
-<p:sld xmlns:a="http://schemas.openxmlformats.org/drawingml/2006/main" xmlns:p="http://schemas.openxmlformats.org/presentationml/2006/main" xmlns:r="http://schemas.openxmlformats.org/officeDocument/2006/relationships">
+<p:sld xmlns:a="http://schemas.openxmlformats.org/drawingml/2006/main" xmlns:r="http://schemas.openxmlformats.org/officeDocument/2006/relationships" xmlns:p="http://schemas.openxmlformats.org/presentationml/2006/main">
   <p:cSld>
     <p:bg>
       <p:bgPr>
@@ -12089,7 +12132,14 @@
         <p:cNvGrpSpPr/>
         <p:nvPr/>
       </p:nvGrpSpPr>
-      <p:grpSpPr/>
+      <p:grpSpPr>
+        <a:xfrm>
+          <a:off x="0" y="0"/>
+          <a:ext cx="0" cy="0"/>
+          <a:chOff x="0" y="0"/>
+          <a:chExt cx="0" cy="0"/>
+        </a:xfrm>
+      </p:grpSpPr>
       <p:sp>
         <p:nvSpPr>
           <p:cNvPr id="2" name="TextBox 1"/>
@@ -12167,6 +12217,7 @@
           <a:lstStyle/>
           <a:p>
             <a:pPr algn="ctr"/>
+            <a:endParaRPr/>
           </a:p>
         </p:txBody>
       </p:sp>
@@ -12214,6 +12265,7 @@
                 </a:solidFill>
               </a:defRPr>
             </a:pPr>
+            <a:endParaRPr/>
           </a:p>
           <a:p>
             <a:pPr>
@@ -12304,6 +12356,7 @@
           <a:lstStyle/>
           <a:p>
             <a:pPr algn="ctr"/>
+            <a:endParaRPr/>
           </a:p>
         </p:txBody>
       </p:sp>
@@ -12351,6 +12404,7 @@
                 </a:solidFill>
               </a:defRPr>
             </a:pPr>
+            <a:endParaRPr/>
           </a:p>
           <a:p>
             <a:pPr>
@@ -12441,6 +12495,7 @@
           <a:lstStyle/>
           <a:p>
             <a:pPr algn="ctr"/>
+            <a:endParaRPr/>
           </a:p>
         </p:txBody>
       </p:sp>
@@ -12488,6 +12543,7 @@
                 </a:solidFill>
               </a:defRPr>
             </a:pPr>
+            <a:endParaRPr/>
           </a:p>
           <a:p>
             <a:pPr>
@@ -12578,6 +12634,7 @@
           <a:lstStyle/>
           <a:p>
             <a:pPr algn="ctr"/>
+            <a:endParaRPr/>
           </a:p>
         </p:txBody>
       </p:sp>
@@ -12785,6 +12842,7 @@
                 </a:solidFill>
               </a:defRPr>
             </a:pPr>
+            <a:endParaRPr/>
           </a:p>
           <a:p>
             <a:pPr>
@@ -12847,7 +12905,7 @@
 </file>
 
 <file path=ppt/slides/slide8.xml><?xml version="1.0" encoding="utf-8"?>
-<p:sld xmlns:a="http://schemas.openxmlformats.org/drawingml/2006/main" xmlns:p="http://schemas.openxmlformats.org/presentationml/2006/main" xmlns:r="http://schemas.openxmlformats.org/officeDocument/2006/relationships">
+<p:sld xmlns:a="http://schemas.openxmlformats.org/drawingml/2006/main" xmlns:r="http://schemas.openxmlformats.org/officeDocument/2006/relationships" xmlns:p="http://schemas.openxmlformats.org/presentationml/2006/main">
   <p:cSld>
     <p:bg>
       <p:bgPr>
@@ -12863,7 +12921,14 @@
         <p:cNvGrpSpPr/>
         <p:nvPr/>
       </p:nvGrpSpPr>
-      <p:grpSpPr/>
+      <p:grpSpPr>
+        <a:xfrm>
+          <a:off x="0" y="0"/>
+          <a:ext cx="0" cy="0"/>
+          <a:chOff x="0" y="0"/>
+          <a:chExt cx="0" cy="0"/>
+        </a:xfrm>
+      </p:grpSpPr>
       <p:sp>
         <p:nvSpPr>
           <p:cNvPr id="2" name="TextBox 1"/>
@@ -12941,6 +13006,7 @@
           <a:lstStyle/>
           <a:p>
             <a:pPr algn="ctr"/>
+            <a:endParaRPr/>
           </a:p>
         </p:txBody>
       </p:sp>
@@ -12988,6 +13054,7 @@
                 </a:solidFill>
               </a:defRPr>
             </a:pPr>
+            <a:endParaRPr/>
           </a:p>
           <a:p>
             <a:pPr>
@@ -13078,6 +13145,7 @@
           <a:lstStyle/>
           <a:p>
             <a:pPr algn="ctr"/>
+            <a:endParaRPr/>
           </a:p>
         </p:txBody>
       </p:sp>
@@ -13125,6 +13193,7 @@
                 </a:solidFill>
               </a:defRPr>
             </a:pPr>
+            <a:endParaRPr/>
           </a:p>
           <a:p>
             <a:pPr>
@@ -13215,6 +13284,7 @@
           <a:lstStyle/>
           <a:p>
             <a:pPr algn="ctr"/>
+            <a:endParaRPr/>
           </a:p>
         </p:txBody>
       </p:sp>
@@ -13262,6 +13332,7 @@
                 </a:solidFill>
               </a:defRPr>
             </a:pPr>
+            <a:endParaRPr/>
           </a:p>
           <a:p>
             <a:pPr>
@@ -13352,6 +13423,7 @@
           <a:lstStyle/>
           <a:p>
             <a:pPr algn="ctr"/>
+            <a:endParaRPr/>
           </a:p>
         </p:txBody>
       </p:sp>
@@ -13589,6 +13661,7 @@
                 </a:solidFill>
               </a:defRPr>
             </a:pPr>
+            <a:endParaRPr/>
           </a:p>
           <a:p>
             <a:pPr>
@@ -13651,7 +13724,7 @@
 </file>
 
 <file path=ppt/slides/slide9.xml><?xml version="1.0" encoding="utf-8"?>
-<p:sld xmlns:a="http://schemas.openxmlformats.org/drawingml/2006/main" xmlns:p="http://schemas.openxmlformats.org/presentationml/2006/main" xmlns:r="http://schemas.openxmlformats.org/officeDocument/2006/relationships">
+<p:sld xmlns:a="http://schemas.openxmlformats.org/drawingml/2006/main" xmlns:r="http://schemas.openxmlformats.org/officeDocument/2006/relationships" xmlns:p="http://schemas.openxmlformats.org/presentationml/2006/main">
   <p:cSld>
     <p:bg>
       <p:bgPr>
@@ -13667,7 +13740,14 @@
         <p:cNvGrpSpPr/>
         <p:nvPr/>
       </p:nvGrpSpPr>
-      <p:grpSpPr/>
+      <p:grpSpPr>
+        <a:xfrm>
+          <a:off x="0" y="0"/>
+          <a:ext cx="0" cy="0"/>
+          <a:chOff x="0" y="0"/>
+          <a:chExt cx="0" cy="0"/>
+        </a:xfrm>
+      </p:grpSpPr>
       <p:sp>
         <p:nvSpPr>
           <p:cNvPr id="2" name="TextBox 1"/>
@@ -13780,6 +13860,7 @@
           <a:lstStyle/>
           <a:p>
             <a:pPr algn="ctr"/>
+            <a:endParaRPr/>
           </a:p>
         </p:txBody>
       </p:sp>
@@ -13827,6 +13908,7 @@
                 </a:solidFill>
               </a:defRPr>
             </a:pPr>
+            <a:endParaRPr/>
           </a:p>
           <a:p>
             <a:pPr>
@@ -13869,6 +13951,7 @@
                 </a:solidFill>
               </a:defRPr>
             </a:pPr>
+            <a:endParaRPr/>
           </a:p>
           <a:p>
             <a:pPr>
@@ -13944,6 +14027,7 @@
           <a:lstStyle/>
           <a:p>
             <a:pPr algn="ctr"/>
+            <a:endParaRPr/>
           </a:p>
         </p:txBody>
       </p:sp>
@@ -13991,6 +14075,7 @@
                 </a:solidFill>
               </a:defRPr>
             </a:pPr>
+            <a:endParaRPr/>
           </a:p>
           <a:p>
             <a:pPr>
@@ -14126,6 +14211,7 @@
           <a:lstStyle/>
           <a:p>
             <a:pPr algn="ctr"/>
+            <a:endParaRPr/>
           </a:p>
         </p:txBody>
       </p:sp>
@@ -14173,6 +14259,7 @@
                 </a:solidFill>
               </a:defRPr>
             </a:pPr>
+            <a:endParaRPr/>
           </a:p>
           <a:p>
             <a:pPr>
@@ -14230,6 +14317,7 @@
                 </a:solidFill>
               </a:defRPr>
             </a:pPr>
+            <a:endParaRPr/>
           </a:p>
           <a:p>
             <a:pPr>
@@ -14290,6 +14378,7 @@
           <a:lstStyle/>
           <a:p>
             <a:pPr algn="ctr"/>
+            <a:endParaRPr/>
           </a:p>
         </p:txBody>
       </p:sp>
@@ -14372,6 +14461,7 @@
                 </a:solidFill>
               </a:defRPr>
             </a:pPr>
+            <a:endParaRPr/>
           </a:p>
           <a:p>
             <a:pPr>
@@ -14539,6 +14629,7 @@
                 </a:solidFill>
               </a:defRPr>
             </a:pPr>
+            <a:endParaRPr/>
           </a:p>
           <a:p>
             <a:pPr>
@@ -14566,6 +14657,7 @@
                 </a:solidFill>
               </a:defRPr>
             </a:pPr>
+            <a:endParaRPr/>
           </a:p>
           <a:p>
             <a:pPr>
@@ -14923,44 +15015,44 @@
         <a:sysClr val="window" lastClr="FFFFFF"/>
       </a:lt1>
       <a:dk2>
-        <a:srgbClr val="1F497D"/>
+        <a:srgbClr val="0E2841"/>
       </a:dk2>
       <a:lt2>
-        <a:srgbClr val="EEECE1"/>
+        <a:srgbClr val="E8E8E8"/>
       </a:lt2>
       <a:accent1>
-        <a:srgbClr val="4F81BD"/>
+        <a:srgbClr val="156082"/>
       </a:accent1>
       <a:accent2>
-        <a:srgbClr val="C0504D"/>
+        <a:srgbClr val="E97132"/>
       </a:accent2>
       <a:accent3>
-        <a:srgbClr val="9BBB59"/>
+        <a:srgbClr val="196B24"/>
       </a:accent3>
       <a:accent4>
-        <a:srgbClr val="8064A2"/>
+        <a:srgbClr val="0F9ED5"/>
       </a:accent4>
       <a:accent5>
-        <a:srgbClr val="4BACC6"/>
+        <a:srgbClr val="A02B93"/>
       </a:accent5>
       <a:accent6>
-        <a:srgbClr val="F79646"/>
+        <a:srgbClr val="4EA72E"/>
       </a:accent6>
       <a:hlink>
-        <a:srgbClr val="0000FF"/>
+        <a:srgbClr val="467886"/>
       </a:hlink>
       <a:folHlink>
-        <a:srgbClr val="800080"/>
+        <a:srgbClr val="96607D"/>
       </a:folHlink>
     </a:clrScheme>
     <a:fontScheme name="Office">
       <a:majorFont>
-        <a:latin typeface="Calibri"/>
+        <a:latin typeface="Aptos Display" panose="02110004020202020204"/>
         <a:ea typeface=""/>
         <a:cs typeface=""/>
-        <a:font script="Jpan" typeface="ＭＳ Ｐゴシック"/>
+        <a:font script="Jpan" typeface="游ゴシック Light"/>
         <a:font script="Hang" typeface="맑은 고딕"/>
-        <a:font script="Hans" typeface="宋体"/>
+        <a:font script="Hans" typeface="等线 Light"/>
         <a:font script="Hant" typeface="新細明體"/>
         <a:font script="Arab" typeface="Times New Roman"/>
         <a:font script="Hebr" typeface="Times New Roman"/>
@@ -14988,14 +15080,31 @@
         <a:font script="Viet" typeface="Times New Roman"/>
         <a:font script="Uigh" typeface="Microsoft Uighur"/>
         <a:font script="Geor" typeface="Sylfaen"/>
+        <a:font script="Armn" typeface="Arial"/>
+        <a:font script="Bugi" typeface="Leelawadee UI"/>
+        <a:font script="Bopo" typeface="Microsoft JhengHei"/>
+        <a:font script="Java" typeface="Javanese Text"/>
+        <a:font script="Lisu" typeface="Segoe UI"/>
+        <a:font script="Mymr" typeface="Myanmar Text"/>
+        <a:font script="Nkoo" typeface="Ebrima"/>
+        <a:font script="Olck" typeface="Nirmala UI"/>
+        <a:font script="Osma" typeface="Ebrima"/>
+        <a:font script="Phag" typeface="Phagspa"/>
+        <a:font script="Syrn" typeface="Estrangelo Edessa"/>
+        <a:font script="Syrj" typeface="Estrangelo Edessa"/>
+        <a:font script="Syre" typeface="Estrangelo Edessa"/>
+        <a:font script="Sora" typeface="Nirmala UI"/>
+        <a:font script="Tale" typeface="Microsoft Tai Le"/>
+        <a:font script="Talu" typeface="Microsoft New Tai Lue"/>
+        <a:font script="Tfng" typeface="Ebrima"/>
       </a:majorFont>
       <a:minorFont>
-        <a:latin typeface="Calibri"/>
+        <a:latin typeface="Aptos" panose="02110004020202020204"/>
         <a:ea typeface=""/>
         <a:cs typeface=""/>
-        <a:font script="Jpan" typeface="ＭＳ Ｐゴシック"/>
+        <a:font script="Jpan" typeface="游ゴシック"/>
         <a:font script="Hang" typeface="맑은 고딕"/>
-        <a:font script="Hans" typeface="宋体"/>
+        <a:font script="Hans" typeface="等线"/>
         <a:font script="Hant" typeface="新細明體"/>
         <a:font script="Arab" typeface="Arial"/>
         <a:font script="Hebr" typeface="Arial"/>
@@ -15023,6 +15132,23 @@
         <a:font script="Viet" typeface="Arial"/>
         <a:font script="Uigh" typeface="Microsoft Uighur"/>
         <a:font script="Geor" typeface="Sylfaen"/>
+        <a:font script="Armn" typeface="Arial"/>
+        <a:font script="Bugi" typeface="Leelawadee UI"/>
+        <a:font script="Bopo" typeface="Microsoft JhengHei"/>
+        <a:font script="Java" typeface="Javanese Text"/>
+        <a:font script="Lisu" typeface="Segoe UI"/>
+        <a:font script="Mymr" typeface="Myanmar Text"/>
+        <a:font script="Nkoo" typeface="Ebrima"/>
+        <a:font script="Olck" typeface="Nirmala UI"/>
+        <a:font script="Osma" typeface="Ebrima"/>
+        <a:font script="Phag" typeface="Phagspa"/>
+        <a:font script="Syrn" typeface="Estrangelo Edessa"/>
+        <a:font script="Syrj" typeface="Estrangelo Edessa"/>
+        <a:font script="Syre" typeface="Estrangelo Edessa"/>
+        <a:font script="Sora" typeface="Nirmala UI"/>
+        <a:font script="Tale" typeface="Microsoft Tai Le"/>
+        <a:font script="Talu" typeface="Microsoft New Tai Lue"/>
+        <a:font script="Tfng" typeface="Ebrima"/>
       </a:minorFont>
     </a:fontScheme>
     <a:fmtScheme name="Office">
@@ -15034,180 +15160,136 @@
           <a:gsLst>
             <a:gs pos="0">
               <a:schemeClr val="phClr">
-                <a:tint val="50000"/>
-                <a:satMod val="300000"/>
+                <a:lumMod val="110000"/>
+                <a:satMod val="105000"/>
+                <a:tint val="67000"/>
               </a:schemeClr>
             </a:gs>
-            <a:gs pos="35000">
+            <a:gs pos="50000">
               <a:schemeClr val="phClr">
-                <a:tint val="37000"/>
-                <a:satMod val="300000"/>
+                <a:lumMod val="105000"/>
+                <a:satMod val="103000"/>
+                <a:tint val="73000"/>
               </a:schemeClr>
             </a:gs>
             <a:gs pos="100000">
               <a:schemeClr val="phClr">
-                <a:tint val="15000"/>
-                <a:satMod val="350000"/>
+                <a:lumMod val="105000"/>
+                <a:satMod val="109000"/>
+                <a:tint val="81000"/>
               </a:schemeClr>
             </a:gs>
           </a:gsLst>
-          <a:lin ang="16200000" scaled="1"/>
+          <a:lin ang="5400000" scaled="0"/>
         </a:gradFill>
         <a:gradFill rotWithShape="1">
           <a:gsLst>
             <a:gs pos="0">
               <a:schemeClr val="phClr">
-                <a:tint val="100000"/>
+                <a:satMod val="103000"/>
+                <a:lumMod val="102000"/>
+                <a:tint val="94000"/>
+              </a:schemeClr>
+            </a:gs>
+            <a:gs pos="50000">
+              <a:schemeClr val="phClr">
+                <a:satMod val="110000"/>
+                <a:lumMod val="100000"/>
                 <a:shade val="100000"/>
-                <a:satMod val="130000"/>
               </a:schemeClr>
             </a:gs>
             <a:gs pos="100000">
               <a:schemeClr val="phClr">
-                <a:tint val="50000"/>
-                <a:shade val="100000"/>
-                <a:satMod val="350000"/>
+                <a:lumMod val="99000"/>
+                <a:satMod val="120000"/>
+                <a:shade val="78000"/>
               </a:schemeClr>
             </a:gs>
           </a:gsLst>
-          <a:lin ang="16200000" scaled="0"/>
+          <a:lin ang="5400000" scaled="0"/>
         </a:gradFill>
       </a:fillStyleLst>
       <a:lnStyleLst>
-        <a:ln w="9525" cap="flat" cmpd="sng" algn="ctr">
+        <a:ln w="12700" cap="flat" cmpd="sng" algn="ctr">
           <a:solidFill>
-            <a:schemeClr val="phClr">
-              <a:shade val="95000"/>
-              <a:satMod val="105000"/>
-            </a:schemeClr>
+            <a:schemeClr val="phClr"/>
           </a:solidFill>
           <a:prstDash val="solid"/>
+          <a:miter lim="800000"/>
+        </a:ln>
+        <a:ln w="19050" cap="flat" cmpd="sng" algn="ctr">
+          <a:solidFill>
+            <a:schemeClr val="phClr"/>
+          </a:solidFill>
+          <a:prstDash val="solid"/>
+          <a:miter lim="800000"/>
         </a:ln>
         <a:ln w="25400" cap="flat" cmpd="sng" algn="ctr">
           <a:solidFill>
             <a:schemeClr val="phClr"/>
           </a:solidFill>
           <a:prstDash val="solid"/>
-        </a:ln>
-        <a:ln w="38100" cap="flat" cmpd="sng" algn="ctr">
-          <a:solidFill>
-            <a:schemeClr val="phClr"/>
-          </a:solidFill>
-          <a:prstDash val="solid"/>
+          <a:miter lim="800000"/>
         </a:ln>
       </a:lnStyleLst>
       <a:effectStyleLst>
         <a:effectStyle>
+          <a:effectLst/>
+        </a:effectStyle>
+        <a:effectStyle>
+          <a:effectLst/>
+        </a:effectStyle>
+        <a:effectStyle>
           <a:effectLst>
-            <a:outerShdw blurRad="40000" dist="20000" dir="5400000" rotWithShape="0">
+            <a:outerShdw blurRad="57150" dist="19050" dir="5400000" algn="ctr" rotWithShape="0">
               <a:srgbClr val="000000">
-                <a:alpha val="38000"/>
+                <a:alpha val="63000"/>
               </a:srgbClr>
             </a:outerShdw>
           </a:effectLst>
-        </a:effectStyle>
-        <a:effectStyle>
-          <a:effectLst>
-            <a:outerShdw blurRad="40000" dist="23000" dir="5400000" rotWithShape="0">
-              <a:srgbClr val="000000">
-                <a:alpha val="35000"/>
-              </a:srgbClr>
-            </a:outerShdw>
-          </a:effectLst>
-        </a:effectStyle>
-        <a:effectStyle>
-          <a:effectLst>
-            <a:outerShdw blurRad="40000" dist="23000" dir="5400000" rotWithShape="0">
-              <a:srgbClr val="000000">
-                <a:alpha val="35000"/>
-              </a:srgbClr>
-            </a:outerShdw>
-          </a:effectLst>
-          <a:scene3d>
-            <a:camera prst="orthographicFront">
-              <a:rot lat="0" lon="0" rev="0"/>
-            </a:camera>
-            <a:lightRig rig="threePt" dir="t">
-              <a:rot lat="0" lon="0" rev="1200000"/>
-            </a:lightRig>
-          </a:scene3d>
-          <a:sp3d>
-            <a:bevelT w="63500" h="25400"/>
-          </a:sp3d>
         </a:effectStyle>
       </a:effectStyleLst>
       <a:bgFillStyleLst>
         <a:solidFill>
           <a:schemeClr val="phClr"/>
         </a:solidFill>
+        <a:solidFill>
+          <a:schemeClr val="phClr">
+            <a:tint val="95000"/>
+            <a:satMod val="170000"/>
+          </a:schemeClr>
+        </a:solidFill>
         <a:gradFill rotWithShape="1">
           <a:gsLst>
             <a:gs pos="0">
               <a:schemeClr val="phClr">
-                <a:tint val="40000"/>
-                <a:satMod val="350000"/>
+                <a:tint val="93000"/>
+                <a:satMod val="150000"/>
+                <a:shade val="98000"/>
+                <a:lumMod val="102000"/>
               </a:schemeClr>
             </a:gs>
-            <a:gs pos="40000">
+            <a:gs pos="50000">
               <a:schemeClr val="phClr">
-                <a:tint val="45000"/>
-                <a:shade val="99000"/>
-                <a:satMod val="350000"/>
+                <a:tint val="98000"/>
+                <a:satMod val="130000"/>
+                <a:shade val="90000"/>
+                <a:lumMod val="103000"/>
               </a:schemeClr>
             </a:gs>
             <a:gs pos="100000">
               <a:schemeClr val="phClr">
-                <a:shade val="20000"/>
-                <a:satMod val="255000"/>
+                <a:shade val="63000"/>
+                <a:satMod val="120000"/>
               </a:schemeClr>
             </a:gs>
           </a:gsLst>
-          <a:path path="circle">
-            <a:fillToRect l="50000" t="-80000" r="50000" b="180000"/>
-          </a:path>
-        </a:gradFill>
-        <a:gradFill rotWithShape="1">
-          <a:gsLst>
-            <a:gs pos="0">
-              <a:schemeClr val="phClr">
-                <a:tint val="80000"/>
-                <a:satMod val="300000"/>
-              </a:schemeClr>
-            </a:gs>
-            <a:gs pos="100000">
-              <a:schemeClr val="phClr">
-                <a:shade val="30000"/>
-                <a:satMod val="200000"/>
-              </a:schemeClr>
-            </a:gs>
-          </a:gsLst>
-          <a:path path="circle">
-            <a:fillToRect l="50000" t="50000" r="50000" b="50000"/>
-          </a:path>
+          <a:lin ang="5400000" scaled="0"/>
         </a:gradFill>
       </a:bgFillStyleLst>
     </a:fmtScheme>
   </a:themeElements>
   <a:objectDefaults>
-    <a:spDef>
-      <a:spPr/>
-      <a:bodyPr/>
-      <a:lstStyle/>
-      <a:style>
-        <a:lnRef idx="1">
-          <a:schemeClr val="accent1"/>
-        </a:lnRef>
-        <a:fillRef idx="3">
-          <a:schemeClr val="accent1"/>
-        </a:fillRef>
-        <a:effectRef idx="2">
-          <a:schemeClr val="accent1"/>
-        </a:effectRef>
-        <a:fontRef idx="minor">
-          <a:schemeClr val="lt1"/>
-        </a:fontRef>
-      </a:style>
-    </a:spDef>
     <a:lnDef>
       <a:spPr/>
       <a:bodyPr/>
@@ -15229,5 +15311,10 @@
     </a:lnDef>
   </a:objectDefaults>
   <a:extraClrSchemeLst/>
+  <a:extLst>
+    <a:ext uri="{05A4C25C-085E-4340-85A3-A5531E510DB2}">
+      <thm15:themeFamily xmlns:thm15="http://schemas.microsoft.com/office/thememl/2012/main" name="Office Theme" id="{2E142A2C-CD16-42D6-873A-C26D2A0506FA}" vid="{1BDDFF52-6CD6-40A5-AB3C-68EB2F1E4D0A}"/>
+    </a:ext>
+  </a:extLst>
 </a:theme>
 </file>
</xml_diff>